<commit_message>
updated presentation with age data notes and my cost app link
</commit_message>
<xml_diff>
--- a/Session 1/Intro to All of Us.pptx
+++ b/Session 1/Intro to All of Us.pptx
@@ -5,7 +5,7 @@
     <p:sldMasterId id="2147483648" r:id="rId1"/>
   </p:sldMasterIdLst>
   <p:notesMasterIdLst>
-    <p:notesMasterId r:id="rId41"/>
+    <p:notesMasterId r:id="rId42"/>
   </p:notesMasterIdLst>
   <p:sldIdLst>
     <p:sldId id="262" r:id="rId2"/>
@@ -26,27 +26,28 @@
     <p:sldId id="408" r:id="rId17"/>
     <p:sldId id="409" r:id="rId18"/>
     <p:sldId id="410" r:id="rId19"/>
-    <p:sldId id="403" r:id="rId20"/>
-    <p:sldId id="366" r:id="rId21"/>
-    <p:sldId id="404" r:id="rId22"/>
-    <p:sldId id="367" r:id="rId23"/>
-    <p:sldId id="368" r:id="rId24"/>
-    <p:sldId id="369" r:id="rId25"/>
-    <p:sldId id="370" r:id="rId26"/>
-    <p:sldId id="268" r:id="rId27"/>
-    <p:sldId id="407" r:id="rId28"/>
-    <p:sldId id="415" r:id="rId29"/>
-    <p:sldId id="401" r:id="rId30"/>
-    <p:sldId id="400" r:id="rId31"/>
-    <p:sldId id="402" r:id="rId32"/>
-    <p:sldId id="371" r:id="rId33"/>
-    <p:sldId id="373" r:id="rId34"/>
-    <p:sldId id="406" r:id="rId35"/>
-    <p:sldId id="374" r:id="rId36"/>
-    <p:sldId id="375" r:id="rId37"/>
-    <p:sldId id="376" r:id="rId38"/>
-    <p:sldId id="378" r:id="rId39"/>
-    <p:sldId id="414" r:id="rId40"/>
+    <p:sldId id="416" r:id="rId20"/>
+    <p:sldId id="403" r:id="rId21"/>
+    <p:sldId id="366" r:id="rId22"/>
+    <p:sldId id="404" r:id="rId23"/>
+    <p:sldId id="367" r:id="rId24"/>
+    <p:sldId id="368" r:id="rId25"/>
+    <p:sldId id="369" r:id="rId26"/>
+    <p:sldId id="370" r:id="rId27"/>
+    <p:sldId id="268" r:id="rId28"/>
+    <p:sldId id="407" r:id="rId29"/>
+    <p:sldId id="415" r:id="rId30"/>
+    <p:sldId id="401" r:id="rId31"/>
+    <p:sldId id="400" r:id="rId32"/>
+    <p:sldId id="402" r:id="rId33"/>
+    <p:sldId id="371" r:id="rId34"/>
+    <p:sldId id="373" r:id="rId35"/>
+    <p:sldId id="406" r:id="rId36"/>
+    <p:sldId id="374" r:id="rId37"/>
+    <p:sldId id="375" r:id="rId38"/>
+    <p:sldId id="376" r:id="rId39"/>
+    <p:sldId id="378" r:id="rId40"/>
+    <p:sldId id="414" r:id="rId41"/>
   </p:sldIdLst>
   <p:sldSz cx="12192000" cy="6858000"/>
   <p:notesSz cx="6858000" cy="9144000"/>
@@ -177,7 +178,7 @@
 <file path=ppt/revisionInfo.xml><?xml version="1.0" encoding="utf-8"?>
 <p1510:revInfo xmlns:a="http://schemas.openxmlformats.org/drawingml/2006/main" xmlns:r="http://schemas.openxmlformats.org/officeDocument/2006/relationships" xmlns:p1510="http://schemas.microsoft.com/office/powerpoint/2015/10/main">
   <p1510:revLst>
-    <p1510:client id="{0DF766A2-EDB3-0345-A196-1329D99E18C2}" v="6" dt="2025-11-10T15:20:49.475"/>
+    <p1510:client id="{0A4A6351-75C9-6B47-B7E1-DE14CDAAC0D7}" v="17" dt="2026-01-29T20:46:02.260"/>
   </p1510:revLst>
 </p1510:revInfo>
 </file>
@@ -187,470 +188,92 @@
   <pc:docChgLst>
     <pc:chgData name="Wegener, Maximilian" userId="00319a47-5df7-4a7f-b5fd-8c1aef3f7443" providerId="ADAL" clId="{CF2CAE99-D8F5-51A4-A68C-79C1C32033F6}"/>
     <pc:docChg chg="undo custSel addSld delSld modSld sldOrd">
-      <pc:chgData name="Wegener, Maximilian" userId="00319a47-5df7-4a7f-b5fd-8c1aef3f7443" providerId="ADAL" clId="{CF2CAE99-D8F5-51A4-A68C-79C1C32033F6}" dt="2025-11-10T15:20:42.094" v="2450" actId="20577"/>
+      <pc:chgData name="Wegener, Maximilian" userId="00319a47-5df7-4a7f-b5fd-8c1aef3f7443" providerId="ADAL" clId="{CF2CAE99-D8F5-51A4-A68C-79C1C32033F6}" dt="2026-01-29T20:46:44.865" v="3199" actId="20577"/>
       <pc:docMkLst>
         <pc:docMk/>
       </pc:docMkLst>
-      <pc:sldChg chg="delSp mod">
-        <pc:chgData name="Wegener, Maximilian" userId="00319a47-5df7-4a7f-b5fd-8c1aef3f7443" providerId="ADAL" clId="{CF2CAE99-D8F5-51A4-A68C-79C1C32033F6}" dt="2025-11-07T14:23:45.789" v="242" actId="478"/>
-        <pc:sldMkLst>
-          <pc:docMk/>
-          <pc:sldMk cId="3091722252" sldId="262"/>
-        </pc:sldMkLst>
-      </pc:sldChg>
-      <pc:sldChg chg="modSp mod modNotesTx">
-        <pc:chgData name="Wegener, Maximilian" userId="00319a47-5df7-4a7f-b5fd-8c1aef3f7443" providerId="ADAL" clId="{CF2CAE99-D8F5-51A4-A68C-79C1C32033F6}" dt="2025-11-07T14:25:39.319" v="247" actId="20577"/>
-        <pc:sldMkLst>
-          <pc:docMk/>
-          <pc:sldMk cId="3819265948" sldId="364"/>
-        </pc:sldMkLst>
-        <pc:spChg chg="mod">
-          <ac:chgData name="Wegener, Maximilian" userId="00319a47-5df7-4a7f-b5fd-8c1aef3f7443" providerId="ADAL" clId="{CF2CAE99-D8F5-51A4-A68C-79C1C32033F6}" dt="2025-11-07T14:24:29.880" v="244" actId="20577"/>
-          <ac:spMkLst>
-            <pc:docMk/>
-            <pc:sldMk cId="3819265948" sldId="364"/>
-            <ac:spMk id="2" creationId="{D18B6CA1-B07C-82C5-B037-C073D29A9CC2}"/>
-          </ac:spMkLst>
-        </pc:spChg>
-      </pc:sldChg>
-      <pc:sldChg chg="modSp mod ord">
-        <pc:chgData name="Wegener, Maximilian" userId="00319a47-5df7-4a7f-b5fd-8c1aef3f7443" providerId="ADAL" clId="{CF2CAE99-D8F5-51A4-A68C-79C1C32033F6}" dt="2025-11-07T14:31:36.110" v="321" actId="20578"/>
-        <pc:sldMkLst>
-          <pc:docMk/>
-          <pc:sldMk cId="496413785" sldId="365"/>
-        </pc:sldMkLst>
-        <pc:spChg chg="mod">
-          <ac:chgData name="Wegener, Maximilian" userId="00319a47-5df7-4a7f-b5fd-8c1aef3f7443" providerId="ADAL" clId="{CF2CAE99-D8F5-51A4-A68C-79C1C32033F6}" dt="2025-11-07T14:29:11.237" v="286" actId="20577"/>
-          <ac:spMkLst>
-            <pc:docMk/>
-            <pc:sldMk cId="496413785" sldId="365"/>
-            <ac:spMk id="2" creationId="{E118F1E8-83E2-AAA4-03D6-7B1312D04E09}"/>
-          </ac:spMkLst>
-        </pc:spChg>
-      </pc:sldChg>
-      <pc:sldChg chg="modSp mod">
-        <pc:chgData name="Wegener, Maximilian" userId="00319a47-5df7-4a7f-b5fd-8c1aef3f7443" providerId="ADAL" clId="{CF2CAE99-D8F5-51A4-A68C-79C1C32033F6}" dt="2025-11-10T15:01:26.969" v="2011" actId="1036"/>
-        <pc:sldMkLst>
-          <pc:docMk/>
-          <pc:sldMk cId="3349447059" sldId="367"/>
-        </pc:sldMkLst>
-        <pc:spChg chg="mod">
-          <ac:chgData name="Wegener, Maximilian" userId="00319a47-5df7-4a7f-b5fd-8c1aef3f7443" providerId="ADAL" clId="{CF2CAE99-D8F5-51A4-A68C-79C1C32033F6}" dt="2025-11-10T15:01:21.090" v="2003" actId="1035"/>
-          <ac:spMkLst>
-            <pc:docMk/>
-            <pc:sldMk cId="3349447059" sldId="367"/>
-            <ac:spMk id="2" creationId="{AE682C57-D543-F24B-FDEE-8F91727E4CF3}"/>
-          </ac:spMkLst>
-        </pc:spChg>
-        <pc:picChg chg="mod">
-          <ac:chgData name="Wegener, Maximilian" userId="00319a47-5df7-4a7f-b5fd-8c1aef3f7443" providerId="ADAL" clId="{CF2CAE99-D8F5-51A4-A68C-79C1C32033F6}" dt="2025-11-10T15:01:26.969" v="2011" actId="1036"/>
-          <ac:picMkLst>
-            <pc:docMk/>
-            <pc:sldMk cId="3349447059" sldId="367"/>
-            <ac:picMk id="5" creationId="{0935A675-8DBD-9DFD-B6C5-979DEEB9D92F}"/>
-          </ac:picMkLst>
-        </pc:picChg>
-      </pc:sldChg>
-      <pc:sldChg chg="modSp mod">
-        <pc:chgData name="Wegener, Maximilian" userId="00319a47-5df7-4a7f-b5fd-8c1aef3f7443" providerId="ADAL" clId="{CF2CAE99-D8F5-51A4-A68C-79C1C32033F6}" dt="2025-11-07T14:40:35.556" v="535" actId="20577"/>
+      <pc:sldChg chg="modNotesTx">
+        <pc:chgData name="Wegener, Maximilian" userId="00319a47-5df7-4a7f-b5fd-8c1aef3f7443" providerId="ADAL" clId="{CF2CAE99-D8F5-51A4-A68C-79C1C32033F6}" dt="2026-01-29T20:46:44.865" v="3199" actId="20577"/>
         <pc:sldMkLst>
           <pc:docMk/>
           <pc:sldMk cId="2367016627" sldId="368"/>
         </pc:sldMkLst>
-        <pc:spChg chg="mod">
-          <ac:chgData name="Wegener, Maximilian" userId="00319a47-5df7-4a7f-b5fd-8c1aef3f7443" providerId="ADAL" clId="{CF2CAE99-D8F5-51A4-A68C-79C1C32033F6}" dt="2025-11-07T14:40:35.556" v="535" actId="20577"/>
-          <ac:spMkLst>
-            <pc:docMk/>
-            <pc:sldMk cId="2367016627" sldId="368"/>
-            <ac:spMk id="7" creationId="{20166998-8E29-B59E-0AC6-67C25E4B7748}"/>
-          </ac:spMkLst>
-        </pc:spChg>
       </pc:sldChg>
-      <pc:sldChg chg="modSp mod">
-        <pc:chgData name="Wegener, Maximilian" userId="00319a47-5df7-4a7f-b5fd-8c1aef3f7443" providerId="ADAL" clId="{CF2CAE99-D8F5-51A4-A68C-79C1C32033F6}" dt="2025-11-10T15:03:12.705" v="2017" actId="20577"/>
+      <pc:sldChg chg="addSp modSp add del mod ord modNotes">
+        <pc:chgData name="Wegener, Maximilian" userId="00319a47-5df7-4a7f-b5fd-8c1aef3f7443" providerId="ADAL" clId="{CF2CAE99-D8F5-51A4-A68C-79C1C32033F6}" dt="2026-01-29T20:33:00.945" v="2555" actId="2696"/>
         <pc:sldMkLst>
           <pc:docMk/>
-          <pc:sldMk cId="1533948127" sldId="370"/>
+          <pc:sldMk cId="17989362" sldId="416"/>
         </pc:sldMkLst>
-        <pc:spChg chg="mod">
-          <ac:chgData name="Wegener, Maximilian" userId="00319a47-5df7-4a7f-b5fd-8c1aef3f7443" providerId="ADAL" clId="{CF2CAE99-D8F5-51A4-A68C-79C1C32033F6}" dt="2025-11-10T15:03:12.705" v="2017" actId="20577"/>
-          <ac:spMkLst>
-            <pc:docMk/>
-            <pc:sldMk cId="1533948127" sldId="370"/>
-            <ac:spMk id="15" creationId="{C8DAB06A-F7DF-4757-88BF-448AB21CF2BB}"/>
-          </ac:spMkLst>
-        </pc:spChg>
-      </pc:sldChg>
-      <pc:sldChg chg="modSp mod">
-        <pc:chgData name="Wegener, Maximilian" userId="00319a47-5df7-4a7f-b5fd-8c1aef3f7443" providerId="ADAL" clId="{CF2CAE99-D8F5-51A4-A68C-79C1C32033F6}" dt="2025-11-10T15:18:31.226" v="2391" actId="403"/>
-        <pc:sldMkLst>
-          <pc:docMk/>
-          <pc:sldMk cId="296703054" sldId="374"/>
-        </pc:sldMkLst>
-        <pc:spChg chg="mod">
-          <ac:chgData name="Wegener, Maximilian" userId="00319a47-5df7-4a7f-b5fd-8c1aef3f7443" providerId="ADAL" clId="{CF2CAE99-D8F5-51A4-A68C-79C1C32033F6}" dt="2025-11-10T15:18:31.226" v="2391" actId="403"/>
-          <ac:spMkLst>
-            <pc:docMk/>
-            <pc:sldMk cId="296703054" sldId="374"/>
-            <ac:spMk id="2" creationId="{9961C6D7-9F1E-ACDF-95A9-02BFB7019855}"/>
-          </ac:spMkLst>
-        </pc:spChg>
-      </pc:sldChg>
-      <pc:sldChg chg="modSp mod">
-        <pc:chgData name="Wegener, Maximilian" userId="00319a47-5df7-4a7f-b5fd-8c1aef3f7443" providerId="ADAL" clId="{CF2CAE99-D8F5-51A4-A68C-79C1C32033F6}" dt="2025-11-10T15:20:42.094" v="2450" actId="20577"/>
-        <pc:sldMkLst>
-          <pc:docMk/>
-          <pc:sldMk cId="2763619890" sldId="376"/>
-        </pc:sldMkLst>
-        <pc:spChg chg="mod">
-          <ac:chgData name="Wegener, Maximilian" userId="00319a47-5df7-4a7f-b5fd-8c1aef3f7443" providerId="ADAL" clId="{CF2CAE99-D8F5-51A4-A68C-79C1C32033F6}" dt="2025-11-10T15:20:42.094" v="2450" actId="20577"/>
-          <ac:spMkLst>
-            <pc:docMk/>
-            <pc:sldMk cId="2763619890" sldId="376"/>
-            <ac:spMk id="2" creationId="{98F8968C-B95C-2579-DCAC-B5038E468C5E}"/>
-          </ac:spMkLst>
-        </pc:spChg>
-      </pc:sldChg>
-      <pc:sldChg chg="addSp delSp mod">
-        <pc:chgData name="Wegener, Maximilian" userId="00319a47-5df7-4a7f-b5fd-8c1aef3f7443" providerId="ADAL" clId="{CF2CAE99-D8F5-51A4-A68C-79C1C32033F6}" dt="2025-11-05T16:44:44.471" v="6" actId="478"/>
-        <pc:sldMkLst>
-          <pc:docMk/>
-          <pc:sldMk cId="2193341156" sldId="381"/>
-        </pc:sldMkLst>
-        <pc:picChg chg="add del">
-          <ac:chgData name="Wegener, Maximilian" userId="00319a47-5df7-4a7f-b5fd-8c1aef3f7443" providerId="ADAL" clId="{CF2CAE99-D8F5-51A4-A68C-79C1C32033F6}" dt="2025-11-05T16:44:44.471" v="6" actId="478"/>
+        <pc:picChg chg="add mod">
+          <ac:chgData name="Wegener, Maximilian" userId="00319a47-5df7-4a7f-b5fd-8c1aef3f7443" providerId="ADAL" clId="{CF2CAE99-D8F5-51A4-A68C-79C1C32033F6}" dt="2026-01-29T20:31:08.330" v="2552"/>
           <ac:picMkLst>
             <pc:docMk/>
-            <pc:sldMk cId="2193341156" sldId="381"/>
-            <ac:picMk id="2" creationId="{4363CA7D-213E-1C91-B67A-C77699EBA599}"/>
+            <pc:sldMk cId="17989362" sldId="416"/>
+            <ac:picMk id="5" creationId="{11A872DC-26C7-6BE8-4901-11FB4E2E37EA}"/>
           </ac:picMkLst>
         </pc:picChg>
       </pc:sldChg>
-      <pc:sldChg chg="addSp delSp modSp add mod">
-        <pc:chgData name="Wegener, Maximilian" userId="00319a47-5df7-4a7f-b5fd-8c1aef3f7443" providerId="ADAL" clId="{CF2CAE99-D8F5-51A4-A68C-79C1C32033F6}" dt="2025-11-05T18:31:02.450" v="48" actId="478"/>
+      <pc:sldChg chg="addSp delSp modSp new mod">
+        <pc:chgData name="Wegener, Maximilian" userId="00319a47-5df7-4a7f-b5fd-8c1aef3f7443" providerId="ADAL" clId="{CF2CAE99-D8F5-51A4-A68C-79C1C32033F6}" dt="2026-01-29T20:40:35.410" v="2992" actId="20577"/>
         <pc:sldMkLst>
           <pc:docMk/>
-          <pc:sldMk cId="2546088075" sldId="398"/>
+          <pc:sldMk cId="1265380304" sldId="416"/>
         </pc:sldMkLst>
-        <pc:picChg chg="add del mod">
-          <ac:chgData name="Wegener, Maximilian" userId="00319a47-5df7-4a7f-b5fd-8c1aef3f7443" providerId="ADAL" clId="{CF2CAE99-D8F5-51A4-A68C-79C1C32033F6}" dt="2025-11-05T18:31:02.450" v="48" actId="478"/>
-          <ac:picMkLst>
-            <pc:docMk/>
-            <pc:sldMk cId="2546088075" sldId="398"/>
-            <ac:picMk id="5" creationId="{C346020C-1CEE-BE6D-F2CE-511E1BEE3F52}"/>
-          </ac:picMkLst>
-        </pc:picChg>
-      </pc:sldChg>
-      <pc:sldChg chg="addSp modSp add mod ord modNotes">
-        <pc:chgData name="Wegener, Maximilian" userId="00319a47-5df7-4a7f-b5fd-8c1aef3f7443" providerId="ADAL" clId="{CF2CAE99-D8F5-51A4-A68C-79C1C32033F6}" dt="2025-11-05T18:32:02.352" v="64"/>
-        <pc:sldMkLst>
-          <pc:docMk/>
-          <pc:sldMk cId="4074103413" sldId="399"/>
-        </pc:sldMkLst>
-        <pc:picChg chg="add mod">
-          <ac:chgData name="Wegener, Maximilian" userId="00319a47-5df7-4a7f-b5fd-8c1aef3f7443" providerId="ADAL" clId="{CF2CAE99-D8F5-51A4-A68C-79C1C32033F6}" dt="2025-11-05T18:32:02.260" v="62"/>
-          <ac:picMkLst>
-            <pc:docMk/>
-            <pc:sldMk cId="4074103413" sldId="399"/>
-            <ac:picMk id="5" creationId="{0289B054-939B-2A46-C92B-A8D658053AAF}"/>
-          </ac:picMkLst>
-        </pc:picChg>
-      </pc:sldChg>
-      <pc:sldChg chg="addSp modSp add mod ord modNotes">
-        <pc:chgData name="Wegener, Maximilian" userId="00319a47-5df7-4a7f-b5fd-8c1aef3f7443" providerId="ADAL" clId="{CF2CAE99-D8F5-51A4-A68C-79C1C32033F6}" dt="2025-11-05T18:33:58.519" v="81"/>
-        <pc:sldMkLst>
-          <pc:docMk/>
-          <pc:sldMk cId="2006104158" sldId="400"/>
-        </pc:sldMkLst>
-        <pc:picChg chg="add mod">
-          <ac:chgData name="Wegener, Maximilian" userId="00319a47-5df7-4a7f-b5fd-8c1aef3f7443" providerId="ADAL" clId="{CF2CAE99-D8F5-51A4-A68C-79C1C32033F6}" dt="2025-11-05T18:33:58.472" v="79"/>
-          <ac:picMkLst>
-            <pc:docMk/>
-            <pc:sldMk cId="2006104158" sldId="400"/>
-            <ac:picMk id="5" creationId="{44B34122-BD54-B4E4-15CE-2EAE461D695D}"/>
-          </ac:picMkLst>
-        </pc:picChg>
-      </pc:sldChg>
-      <pc:sldChg chg="addSp modSp add mod ord modNotes">
-        <pc:chgData name="Wegener, Maximilian" userId="00319a47-5df7-4a7f-b5fd-8c1aef3f7443" providerId="ADAL" clId="{CF2CAE99-D8F5-51A4-A68C-79C1C32033F6}" dt="2025-11-05T18:34:23.215" v="97"/>
-        <pc:sldMkLst>
-          <pc:docMk/>
-          <pc:sldMk cId="1091494889" sldId="401"/>
-        </pc:sldMkLst>
-        <pc:picChg chg="add mod">
-          <ac:chgData name="Wegener, Maximilian" userId="00319a47-5df7-4a7f-b5fd-8c1aef3f7443" providerId="ADAL" clId="{CF2CAE99-D8F5-51A4-A68C-79C1C32033F6}" dt="2025-11-05T18:34:23.168" v="95"/>
-          <ac:picMkLst>
-            <pc:docMk/>
-            <pc:sldMk cId="1091494889" sldId="401"/>
-            <ac:picMk id="5" creationId="{2FEAA140-33D0-8730-1320-4629836DCD4C}"/>
-          </ac:picMkLst>
-        </pc:picChg>
-      </pc:sldChg>
-      <pc:sldChg chg="addSp modSp add mod ord modNotes">
-        <pc:chgData name="Wegener, Maximilian" userId="00319a47-5df7-4a7f-b5fd-8c1aef3f7443" providerId="ADAL" clId="{CF2CAE99-D8F5-51A4-A68C-79C1C32033F6}" dt="2025-11-05T18:34:54.556" v="115" actId="20578"/>
-        <pc:sldMkLst>
-          <pc:docMk/>
-          <pc:sldMk cId="2349529186" sldId="402"/>
-        </pc:sldMkLst>
-        <pc:picChg chg="add mod">
-          <ac:chgData name="Wegener, Maximilian" userId="00319a47-5df7-4a7f-b5fd-8c1aef3f7443" providerId="ADAL" clId="{CF2CAE99-D8F5-51A4-A68C-79C1C32033F6}" dt="2025-11-05T18:34:48.237" v="111"/>
-          <ac:picMkLst>
-            <pc:docMk/>
-            <pc:sldMk cId="2349529186" sldId="402"/>
-            <ac:picMk id="5" creationId="{8DD4F5FA-8519-B724-82B0-8C16CF8228D1}"/>
-          </ac:picMkLst>
-        </pc:picChg>
-      </pc:sldChg>
-      <pc:sldChg chg="addSp modSp add mod ord modNotes">
-        <pc:chgData name="Wegener, Maximilian" userId="00319a47-5df7-4a7f-b5fd-8c1aef3f7443" providerId="ADAL" clId="{CF2CAE99-D8F5-51A4-A68C-79C1C32033F6}" dt="2025-11-05T18:35:23.284" v="131"/>
-        <pc:sldMkLst>
-          <pc:docMk/>
-          <pc:sldMk cId="420915141" sldId="403"/>
-        </pc:sldMkLst>
-        <pc:picChg chg="add mod">
-          <ac:chgData name="Wegener, Maximilian" userId="00319a47-5df7-4a7f-b5fd-8c1aef3f7443" providerId="ADAL" clId="{CF2CAE99-D8F5-51A4-A68C-79C1C32033F6}" dt="2025-11-05T18:35:23.241" v="129"/>
-          <ac:picMkLst>
-            <pc:docMk/>
-            <pc:sldMk cId="420915141" sldId="403"/>
-            <ac:picMk id="5" creationId="{01A7D900-C774-470D-C04A-3D9FA92242A9}"/>
-          </ac:picMkLst>
-        </pc:picChg>
-      </pc:sldChg>
-      <pc:sldChg chg="addSp modSp add mod ord modNotes">
-        <pc:chgData name="Wegener, Maximilian" userId="00319a47-5df7-4a7f-b5fd-8c1aef3f7443" providerId="ADAL" clId="{CF2CAE99-D8F5-51A4-A68C-79C1C32033F6}" dt="2025-11-05T18:35:51.338" v="147"/>
-        <pc:sldMkLst>
-          <pc:docMk/>
-          <pc:sldMk cId="3205798321" sldId="404"/>
-        </pc:sldMkLst>
-        <pc:picChg chg="add mod">
-          <ac:chgData name="Wegener, Maximilian" userId="00319a47-5df7-4a7f-b5fd-8c1aef3f7443" providerId="ADAL" clId="{CF2CAE99-D8F5-51A4-A68C-79C1C32033F6}" dt="2025-11-05T18:35:51.290" v="145"/>
-          <ac:picMkLst>
-            <pc:docMk/>
-            <pc:sldMk cId="3205798321" sldId="404"/>
-            <ac:picMk id="5" creationId="{C1F71EEC-99FF-A438-3C9A-8751B06DB653}"/>
-          </ac:picMkLst>
-        </pc:picChg>
-      </pc:sldChg>
-      <pc:sldChg chg="addSp modSp add mod ord modNotes">
-        <pc:chgData name="Wegener, Maximilian" userId="00319a47-5df7-4a7f-b5fd-8c1aef3f7443" providerId="ADAL" clId="{CF2CAE99-D8F5-51A4-A68C-79C1C32033F6}" dt="2025-11-05T18:36:06.322" v="163"/>
-        <pc:sldMkLst>
-          <pc:docMk/>
-          <pc:sldMk cId="1946418425" sldId="405"/>
-        </pc:sldMkLst>
-        <pc:picChg chg="add mod">
-          <ac:chgData name="Wegener, Maximilian" userId="00319a47-5df7-4a7f-b5fd-8c1aef3f7443" providerId="ADAL" clId="{CF2CAE99-D8F5-51A4-A68C-79C1C32033F6}" dt="2025-11-05T18:36:06.274" v="161"/>
-          <ac:picMkLst>
-            <pc:docMk/>
-            <pc:sldMk cId="1946418425" sldId="405"/>
-            <ac:picMk id="5" creationId="{14A71708-FB44-0383-8E32-C2BFE940F0F2}"/>
-          </ac:picMkLst>
-        </pc:picChg>
-      </pc:sldChg>
-      <pc:sldChg chg="addSp modSp add mod ord modNotes">
-        <pc:chgData name="Wegener, Maximilian" userId="00319a47-5df7-4a7f-b5fd-8c1aef3f7443" providerId="ADAL" clId="{CF2CAE99-D8F5-51A4-A68C-79C1C32033F6}" dt="2025-11-05T18:50:07.360" v="186"/>
-        <pc:sldMkLst>
-          <pc:docMk/>
-          <pc:sldMk cId="3719010492" sldId="406"/>
-        </pc:sldMkLst>
-        <pc:picChg chg="add mod">
-          <ac:chgData name="Wegener, Maximilian" userId="00319a47-5df7-4a7f-b5fd-8c1aef3f7443" providerId="ADAL" clId="{CF2CAE99-D8F5-51A4-A68C-79C1C32033F6}" dt="2025-11-05T18:50:07.311" v="184"/>
-          <ac:picMkLst>
-            <pc:docMk/>
-            <pc:sldMk cId="3719010492" sldId="406"/>
-            <ac:picMk id="5" creationId="{140C26EA-2A53-D509-7219-A382EB8AE04F}"/>
-          </ac:picMkLst>
-        </pc:picChg>
-      </pc:sldChg>
-      <pc:sldChg chg="addSp delSp modSp new mod ord modNotesTx">
-        <pc:chgData name="Wegener, Maximilian" userId="00319a47-5df7-4a7f-b5fd-8c1aef3f7443" providerId="ADAL" clId="{CF2CAE99-D8F5-51A4-A68C-79C1C32033F6}" dt="2025-11-10T15:06:29.529" v="2037" actId="20577"/>
-        <pc:sldMkLst>
-          <pc:docMk/>
-          <pc:sldMk cId="1184809725" sldId="407"/>
-        </pc:sldMkLst>
-        <pc:spChg chg="add mod">
-          <ac:chgData name="Wegener, Maximilian" userId="00319a47-5df7-4a7f-b5fd-8c1aef3f7443" providerId="ADAL" clId="{CF2CAE99-D8F5-51A4-A68C-79C1C32033F6}" dt="2025-11-07T16:44:01.944" v="1461" actId="1076"/>
+        <pc:spChg chg="del">
+          <ac:chgData name="Wegener, Maximilian" userId="00319a47-5df7-4a7f-b5fd-8c1aef3f7443" providerId="ADAL" clId="{CF2CAE99-D8F5-51A4-A68C-79C1C32033F6}" dt="2026-01-29T20:34:42.914" v="2583" actId="478"/>
           <ac:spMkLst>
             <pc:docMk/>
-            <pc:sldMk cId="1184809725" sldId="407"/>
-            <ac:spMk id="2" creationId="{7D4EC2B2-C52D-5E7C-74D3-2124856F4B22}"/>
+            <pc:sldMk cId="1265380304" sldId="416"/>
+            <ac:spMk id="2" creationId="{33EF2F05-2899-DF03-44E6-8D897B8E91AE}"/>
           </ac:spMkLst>
         </pc:spChg>
         <pc:spChg chg="mod">
-          <ac:chgData name="Wegener, Maximilian" userId="00319a47-5df7-4a7f-b5fd-8c1aef3f7443" providerId="ADAL" clId="{CF2CAE99-D8F5-51A4-A68C-79C1C32033F6}" dt="2025-11-07T15:12:45.782" v="561" actId="13926"/>
+          <ac:chgData name="Wegener, Maximilian" userId="00319a47-5df7-4a7f-b5fd-8c1aef3f7443" providerId="ADAL" clId="{CF2CAE99-D8F5-51A4-A68C-79C1C32033F6}" dt="2026-01-29T20:34:36.658" v="2581" actId="20577"/>
           <ac:spMkLst>
             <pc:docMk/>
-            <pc:sldMk cId="1184809725" sldId="407"/>
-            <ac:spMk id="3" creationId="{32070482-EF80-8B1D-3DFB-33651C065695}"/>
+            <pc:sldMk cId="1265380304" sldId="416"/>
+            <ac:spMk id="3" creationId="{DB15BF82-222D-4F21-FC15-F9270DA65858}"/>
           </ac:spMkLst>
         </pc:spChg>
-        <pc:spChg chg="mod">
-          <ac:chgData name="Wegener, Maximilian" userId="00319a47-5df7-4a7f-b5fd-8c1aef3f7443" providerId="ADAL" clId="{CF2CAE99-D8F5-51A4-A68C-79C1C32033F6}" dt="2025-11-10T15:06:29.529" v="2037" actId="20577"/>
+        <pc:spChg chg="del">
+          <ac:chgData name="Wegener, Maximilian" userId="00319a47-5df7-4a7f-b5fd-8c1aef3f7443" providerId="ADAL" clId="{CF2CAE99-D8F5-51A4-A68C-79C1C32033F6}" dt="2026-01-29T20:34:38.972" v="2582" actId="478"/>
           <ac:spMkLst>
             <pc:docMk/>
-            <pc:sldMk cId="1184809725" sldId="407"/>
-            <ac:spMk id="4" creationId="{A996235D-2199-7FC7-EEB5-5A27AABD9165}"/>
+            <pc:sldMk cId="1265380304" sldId="416"/>
+            <ac:spMk id="4" creationId="{5AC895C3-3862-23E2-67EB-C96054C88E19}"/>
           </ac:spMkLst>
         </pc:spChg>
-      </pc:sldChg>
-      <pc:sldChg chg="addSp delSp modSp add mod">
-        <pc:chgData name="Wegener, Maximilian" userId="00319a47-5df7-4a7f-b5fd-8c1aef3f7443" providerId="ADAL" clId="{CF2CAE99-D8F5-51A4-A68C-79C1C32033F6}" dt="2025-11-07T14:35:33.871" v="366" actId="404"/>
-        <pc:sldMkLst>
-          <pc:docMk/>
-          <pc:sldMk cId="1006352360" sldId="408"/>
-        </pc:sldMkLst>
-        <pc:spChg chg="add mod">
-          <ac:chgData name="Wegener, Maximilian" userId="00319a47-5df7-4a7f-b5fd-8c1aef3f7443" providerId="ADAL" clId="{CF2CAE99-D8F5-51A4-A68C-79C1C32033F6}" dt="2025-11-07T14:33:47.923" v="342" actId="1076"/>
+        <pc:spChg chg="add del mod">
+          <ac:chgData name="Wegener, Maximilian" userId="00319a47-5df7-4a7f-b5fd-8c1aef3f7443" providerId="ADAL" clId="{CF2CAE99-D8F5-51A4-A68C-79C1C32033F6}" dt="2026-01-29T20:36:02.220" v="2589"/>
           <ac:spMkLst>
             <pc:docMk/>
-            <pc:sldMk cId="1006352360" sldId="408"/>
-            <ac:spMk id="2" creationId="{6D738B4C-F51E-CE89-565E-DD75FAFD6B64}"/>
+            <pc:sldMk cId="1265380304" sldId="416"/>
+            <ac:spMk id="6" creationId="{7C4A95BA-5B18-3310-5FA8-979D17F7A5A3}"/>
           </ac:spMkLst>
         </pc:spChg>
-        <pc:spChg chg="mod">
-          <ac:chgData name="Wegener, Maximilian" userId="00319a47-5df7-4a7f-b5fd-8c1aef3f7443" providerId="ADAL" clId="{CF2CAE99-D8F5-51A4-A68C-79C1C32033F6}" dt="2025-11-07T14:35:27.705" v="365" actId="1036"/>
+        <pc:spChg chg="add del mod">
+          <ac:chgData name="Wegener, Maximilian" userId="00319a47-5df7-4a7f-b5fd-8c1aef3f7443" providerId="ADAL" clId="{CF2CAE99-D8F5-51A4-A68C-79C1C32033F6}" dt="2026-01-29T20:35:57.693" v="2587"/>
           <ac:spMkLst>
             <pc:docMk/>
-            <pc:sldMk cId="1006352360" sldId="408"/>
-            <ac:spMk id="3" creationId="{7C33F4E8-A94A-72E9-0FE9-2799643F87F7}"/>
-          </ac:spMkLst>
-        </pc:spChg>
-        <pc:spChg chg="mod">
-          <ac:chgData name="Wegener, Maximilian" userId="00319a47-5df7-4a7f-b5fd-8c1aef3f7443" providerId="ADAL" clId="{CF2CAE99-D8F5-51A4-A68C-79C1C32033F6}" dt="2025-11-07T14:35:33.871" v="366" actId="404"/>
-          <ac:spMkLst>
-            <pc:docMk/>
-            <pc:sldMk cId="1006352360" sldId="408"/>
-            <ac:spMk id="18" creationId="{106241B8-023A-FE55-74BE-B56D733D5509}"/>
-          </ac:spMkLst>
-        </pc:spChg>
-      </pc:sldChg>
-      <pc:sldChg chg="addSp delSp modSp add mod">
-        <pc:chgData name="Wegener, Maximilian" userId="00319a47-5df7-4a7f-b5fd-8c1aef3f7443" providerId="ADAL" clId="{CF2CAE99-D8F5-51A4-A68C-79C1C32033F6}" dt="2025-11-07T14:36:22.867" v="372" actId="478"/>
-        <pc:sldMkLst>
-          <pc:docMk/>
-          <pc:sldMk cId="3342901713" sldId="409"/>
-        </pc:sldMkLst>
-        <pc:spChg chg="add mod">
-          <ac:chgData name="Wegener, Maximilian" userId="00319a47-5df7-4a7f-b5fd-8c1aef3f7443" providerId="ADAL" clId="{CF2CAE99-D8F5-51A4-A68C-79C1C32033F6}" dt="2025-11-07T14:36:20.054" v="371"/>
-          <ac:spMkLst>
-            <pc:docMk/>
-            <pc:sldMk cId="3342901713" sldId="409"/>
-            <ac:spMk id="13" creationId="{7881A65C-2252-0BEB-7CB2-7A8FB306A14C}"/>
+            <pc:sldMk cId="1265380304" sldId="416"/>
+            <ac:spMk id="7" creationId="{A885BDA9-A911-4D0E-0DD4-BFFF3E868C1E}"/>
           </ac:spMkLst>
         </pc:spChg>
         <pc:spChg chg="add mod">
-          <ac:chgData name="Wegener, Maximilian" userId="00319a47-5df7-4a7f-b5fd-8c1aef3f7443" providerId="ADAL" clId="{CF2CAE99-D8F5-51A4-A68C-79C1C32033F6}" dt="2025-11-07T14:36:20.054" v="371"/>
+          <ac:chgData name="Wegener, Maximilian" userId="00319a47-5df7-4a7f-b5fd-8c1aef3f7443" providerId="ADAL" clId="{CF2CAE99-D8F5-51A4-A68C-79C1C32033F6}" dt="2026-01-29T20:37:11.783" v="2775" actId="20577"/>
           <ac:spMkLst>
             <pc:docMk/>
-            <pc:sldMk cId="3342901713" sldId="409"/>
-            <ac:spMk id="14" creationId="{5ABDCEB7-D06A-8B16-8AAD-A785108F7B96}"/>
+            <pc:sldMk cId="1265380304" sldId="416"/>
+            <ac:spMk id="8" creationId="{FB28D8FF-D33B-4062-B26E-B5631CF251CA}"/>
           </ac:spMkLst>
         </pc:spChg>
         <pc:spChg chg="add mod">
-          <ac:chgData name="Wegener, Maximilian" userId="00319a47-5df7-4a7f-b5fd-8c1aef3f7443" providerId="ADAL" clId="{CF2CAE99-D8F5-51A4-A68C-79C1C32033F6}" dt="2025-11-07T14:36:20.054" v="371"/>
+          <ac:chgData name="Wegener, Maximilian" userId="00319a47-5df7-4a7f-b5fd-8c1aef3f7443" providerId="ADAL" clId="{CF2CAE99-D8F5-51A4-A68C-79C1C32033F6}" dt="2026-01-29T20:40:35.410" v="2992" actId="20577"/>
           <ac:spMkLst>
             <pc:docMk/>
-            <pc:sldMk cId="3342901713" sldId="409"/>
-            <ac:spMk id="15" creationId="{27C6241D-4E4A-070E-168A-9B3D8AC3357E}"/>
-          </ac:spMkLst>
-        </pc:spChg>
-      </pc:sldChg>
-      <pc:sldChg chg="modSp add mod modNotesTx">
-        <pc:chgData name="Wegener, Maximilian" userId="00319a47-5df7-4a7f-b5fd-8c1aef3f7443" providerId="ADAL" clId="{CF2CAE99-D8F5-51A4-A68C-79C1C32033F6}" dt="2025-11-10T14:59:41.558" v="1903" actId="20577"/>
-        <pc:sldMkLst>
-          <pc:docMk/>
-          <pc:sldMk cId="2479410611" sldId="410"/>
-        </pc:sldMkLst>
-        <pc:spChg chg="mod">
-          <ac:chgData name="Wegener, Maximilian" userId="00319a47-5df7-4a7f-b5fd-8c1aef3f7443" providerId="ADAL" clId="{CF2CAE99-D8F5-51A4-A68C-79C1C32033F6}" dt="2025-11-10T14:59:41.558" v="1903" actId="20577"/>
-          <ac:spMkLst>
-            <pc:docMk/>
-            <pc:sldMk cId="2479410611" sldId="410"/>
-            <ac:spMk id="6" creationId="{500BCF6C-B8AC-DCD0-AA3F-9FFFADABE4EA}"/>
-          </ac:spMkLst>
-        </pc:spChg>
-        <pc:spChg chg="mod">
-          <ac:chgData name="Wegener, Maximilian" userId="00319a47-5df7-4a7f-b5fd-8c1aef3f7443" providerId="ADAL" clId="{CF2CAE99-D8F5-51A4-A68C-79C1C32033F6}" dt="2025-11-07T14:30:09.737" v="301" actId="13926"/>
-          <ac:spMkLst>
-            <pc:docMk/>
-            <pc:sldMk cId="2479410611" sldId="410"/>
-            <ac:spMk id="20" creationId="{E5ECBD88-FAC8-AA7C-0B34-BF3CC91122C7}"/>
-          </ac:spMkLst>
-        </pc:spChg>
-      </pc:sldChg>
-      <pc:sldChg chg="addSp delSp modSp add mod">
-        <pc:chgData name="Wegener, Maximilian" userId="00319a47-5df7-4a7f-b5fd-8c1aef3f7443" providerId="ADAL" clId="{CF2CAE99-D8F5-51A4-A68C-79C1C32033F6}" dt="2025-11-07T14:38:30.951" v="396" actId="207"/>
-        <pc:sldMkLst>
-          <pc:docMk/>
-          <pc:sldMk cId="1241447715" sldId="412"/>
-        </pc:sldMkLst>
-        <pc:spChg chg="mod">
-          <ac:chgData name="Wegener, Maximilian" userId="00319a47-5df7-4a7f-b5fd-8c1aef3f7443" providerId="ADAL" clId="{CF2CAE99-D8F5-51A4-A68C-79C1C32033F6}" dt="2025-11-07T14:38:30.951" v="396" actId="207"/>
-          <ac:spMkLst>
-            <pc:docMk/>
-            <pc:sldMk cId="1241447715" sldId="412"/>
-            <ac:spMk id="2" creationId="{403642BE-31ED-1C59-B523-DF446D0B0F15}"/>
-          </ac:spMkLst>
-        </pc:spChg>
-        <pc:spChg chg="mod">
-          <ac:chgData name="Wegener, Maximilian" userId="00319a47-5df7-4a7f-b5fd-8c1aef3f7443" providerId="ADAL" clId="{CF2CAE99-D8F5-51A4-A68C-79C1C32033F6}" dt="2025-11-07T14:37:25.721" v="379" actId="1076"/>
-          <ac:spMkLst>
-            <pc:docMk/>
-            <pc:sldMk cId="1241447715" sldId="412"/>
-            <ac:spMk id="7" creationId="{1F097D90-F1D3-8826-90B1-E826E36C1FCA}"/>
-          </ac:spMkLst>
-        </pc:spChg>
-        <pc:spChg chg="add mod">
-          <ac:chgData name="Wegener, Maximilian" userId="00319a47-5df7-4a7f-b5fd-8c1aef3f7443" providerId="ADAL" clId="{CF2CAE99-D8F5-51A4-A68C-79C1C32033F6}" dt="2025-11-07T14:37:07.425" v="373"/>
-          <ac:spMkLst>
-            <pc:docMk/>
-            <pc:sldMk cId="1241447715" sldId="412"/>
-            <ac:spMk id="8" creationId="{453FFEAD-BC30-D650-F4CE-35E183318892}"/>
-          </ac:spMkLst>
-        </pc:spChg>
-        <pc:spChg chg="add mod">
-          <ac:chgData name="Wegener, Maximilian" userId="00319a47-5df7-4a7f-b5fd-8c1aef3f7443" providerId="ADAL" clId="{CF2CAE99-D8F5-51A4-A68C-79C1C32033F6}" dt="2025-11-07T14:37:07.425" v="373"/>
-          <ac:spMkLst>
-            <pc:docMk/>
-            <pc:sldMk cId="1241447715" sldId="412"/>
-            <ac:spMk id="9" creationId="{CE4A8C3F-A22A-478E-7351-CE0303BD008B}"/>
-          </ac:spMkLst>
-        </pc:spChg>
-        <pc:picChg chg="mod">
-          <ac:chgData name="Wegener, Maximilian" userId="00319a47-5df7-4a7f-b5fd-8c1aef3f7443" providerId="ADAL" clId="{CF2CAE99-D8F5-51A4-A68C-79C1C32033F6}" dt="2025-11-07T14:37:21.489" v="378" actId="1076"/>
-          <ac:picMkLst>
-            <pc:docMk/>
-            <pc:sldMk cId="1241447715" sldId="412"/>
-            <ac:picMk id="6" creationId="{7A4DC78A-2E25-697B-6FE1-249F29C0556B}"/>
-          </ac:picMkLst>
-        </pc:picChg>
-      </pc:sldChg>
-      <pc:sldChg chg="add">
-        <pc:chgData name="Wegener, Maximilian" userId="00319a47-5df7-4a7f-b5fd-8c1aef3f7443" providerId="ADAL" clId="{CF2CAE99-D8F5-51A4-A68C-79C1C32033F6}" dt="2025-11-07T14:42:33.163" v="539"/>
-        <pc:sldMkLst>
-          <pc:docMk/>
-          <pc:sldMk cId="3292860451" sldId="414"/>
-        </pc:sldMkLst>
-      </pc:sldChg>
-      <pc:sldChg chg="addSp delSp modSp add mod modNotesTx">
-        <pc:chgData name="Wegener, Maximilian" userId="00319a47-5df7-4a7f-b5fd-8c1aef3f7443" providerId="ADAL" clId="{CF2CAE99-D8F5-51A4-A68C-79C1C32033F6}" dt="2025-11-10T15:09:48.956" v="2046" actId="20577"/>
-        <pc:sldMkLst>
-          <pc:docMk/>
-          <pc:sldMk cId="3368575850" sldId="415"/>
-        </pc:sldMkLst>
-        <pc:spChg chg="mod">
-          <ac:chgData name="Wegener, Maximilian" userId="00319a47-5df7-4a7f-b5fd-8c1aef3f7443" providerId="ADAL" clId="{CF2CAE99-D8F5-51A4-A68C-79C1C32033F6}" dt="2025-11-10T15:09:48.956" v="2046" actId="20577"/>
-          <ac:spMkLst>
-            <pc:docMk/>
-            <pc:sldMk cId="3368575850" sldId="415"/>
-            <ac:spMk id="2" creationId="{F36FD501-EB22-A0C8-7B41-6299FD690A13}"/>
-          </ac:spMkLst>
-        </pc:spChg>
-        <pc:spChg chg="mod">
-          <ac:chgData name="Wegener, Maximilian" userId="00319a47-5df7-4a7f-b5fd-8c1aef3f7443" providerId="ADAL" clId="{CF2CAE99-D8F5-51A4-A68C-79C1C32033F6}" dt="2025-11-07T16:45:02.097" v="1497" actId="20577"/>
-          <ac:spMkLst>
-            <pc:docMk/>
-            <pc:sldMk cId="3368575850" sldId="415"/>
-            <ac:spMk id="4" creationId="{2C0E88D1-7BB3-C90E-3DDC-48BA3992414D}"/>
+            <pc:sldMk cId="1265380304" sldId="416"/>
+            <ac:spMk id="9" creationId="{05D4A543-36A2-AAFD-BF06-E8BDCAA00048}"/>
           </ac:spMkLst>
         </pc:spChg>
       </pc:sldChg>
@@ -8837,7 +8460,7 @@
           <a:p>
             <a:fld id="{F0B8440E-8C35-1142-93FC-F32DCB9C4FDA}" type="datetimeFigureOut">
               <a:rPr lang="en-US" smtClean="0"/>
-              <a:t>11/10/25</a:t>
+              <a:t>1/29/26</a:t>
             </a:fld>
             <a:endParaRPr lang="en-US"/>
           </a:p>
@@ -10498,7 +10121,7 @@
           <a:p>
             <a:fld id="{A5B4ED3A-914E-6443-A2E7-C28A873C6BCA}" type="slidenum">
               <a:rPr lang="en-US" smtClean="0"/>
-              <a:t>19</a:t>
+              <a:t>20</a:t>
             </a:fld>
             <a:endParaRPr lang="en-US"/>
           </a:p>
@@ -10714,7 +10337,7 @@
           <a:p>
             <a:fld id="{A5B4ED3A-914E-6443-A2E7-C28A873C6BCA}" type="slidenum">
               <a:rPr lang="en-US" smtClean="0"/>
-              <a:t>20</a:t>
+              <a:t>21</a:t>
             </a:fld>
             <a:endParaRPr lang="en-US"/>
           </a:p>
@@ -10809,7 +10432,7 @@
           <a:p>
             <a:fld id="{A5B4ED3A-914E-6443-A2E7-C28A873C6BCA}" type="slidenum">
               <a:rPr lang="en-US" smtClean="0"/>
-              <a:t>21</a:t>
+              <a:t>22</a:t>
             </a:fld>
             <a:endParaRPr lang="en-US"/>
           </a:p>
@@ -10917,7 +10540,7 @@
           <a:p>
             <a:fld id="{A5B4ED3A-914E-6443-A2E7-C28A873C6BCA}" type="slidenum">
               <a:rPr lang="en-US" smtClean="0"/>
-              <a:t>22</a:t>
+              <a:t>23</a:t>
             </a:fld>
             <a:endParaRPr lang="en-US"/>
           </a:p>
@@ -10998,6 +10621,31 @@
           <a:bodyPr/>
           <a:lstStyle/>
           <a:p>
+            <a:r>
+              <a:rPr lang="en-US" dirty="0"/>
+              <a:t>Current Age = Age today</a:t>
+            </a:r>
+          </a:p>
+          <a:p>
+            <a:endParaRPr lang="en-US" dirty="0"/>
+          </a:p>
+          <a:p>
+            <a:r>
+              <a:rPr lang="en-US" dirty="0"/>
+              <a:t>Age at consent / age at CDR (</a:t>
+            </a:r>
+            <a:r>
+              <a:rPr lang="en-US" sz="1200" dirty="0">
+                <a:latin typeface="Avenir Book" panose="02000503020000020003" pitchFamily="2" charset="0"/>
+              </a:rPr>
+              <a:t>curated data repository) = static age at when the person was entered into the study/data were add to CDR -&gt; same age options used for different data query</a:t>
+            </a:r>
+            <a:r>
+              <a:rPr lang="en-US" sz="1200">
+                <a:latin typeface="Avenir Book" panose="02000503020000020003" pitchFamily="2" charset="0"/>
+              </a:rPr>
+              <a:t>/analysis</a:t>
+            </a:r>
             <a:endParaRPr lang="en-US" dirty="0"/>
           </a:p>
         </p:txBody>
@@ -11025,7 +10673,7 @@
           <a:p>
             <a:fld id="{A5B4ED3A-914E-6443-A2E7-C28A873C6BCA}" type="slidenum">
               <a:rPr lang="en-US" smtClean="0"/>
-              <a:t>23</a:t>
+              <a:t>24</a:t>
             </a:fld>
             <a:endParaRPr lang="en-US"/>
           </a:p>
@@ -11133,7 +10781,7 @@
           <a:p>
             <a:fld id="{A5B4ED3A-914E-6443-A2E7-C28A873C6BCA}" type="slidenum">
               <a:rPr lang="en-US" smtClean="0"/>
-              <a:t>24</a:t>
+              <a:t>25</a:t>
             </a:fld>
             <a:endParaRPr lang="en-US"/>
           </a:p>
@@ -11241,7 +10889,7 @@
           <a:p>
             <a:fld id="{A5B4ED3A-914E-6443-A2E7-C28A873C6BCA}" type="slidenum">
               <a:rPr lang="en-US" smtClean="0"/>
-              <a:t>25</a:t>
+              <a:t>26</a:t>
             </a:fld>
             <a:endParaRPr lang="en-US"/>
           </a:p>
@@ -11836,7 +11484,7 @@
           <a:p>
             <a:fld id="{A5B4ED3A-914E-6443-A2E7-C28A873C6BCA}" type="slidenum">
               <a:rPr lang="en-US" smtClean="0"/>
-              <a:t>27</a:t>
+              <a:t>28</a:t>
             </a:fld>
             <a:endParaRPr lang="en-US"/>
           </a:p>
@@ -12574,7 +12222,7 @@
           <a:p>
             <a:fld id="{A5B4ED3A-914E-6443-A2E7-C28A873C6BCA}" type="slidenum">
               <a:rPr lang="en-US" smtClean="0"/>
-              <a:t>28</a:t>
+              <a:t>29</a:t>
             </a:fld>
             <a:endParaRPr lang="en-US"/>
           </a:p>
@@ -12669,7 +12317,7 @@
           <a:p>
             <a:fld id="{A5B4ED3A-914E-6443-A2E7-C28A873C6BCA}" type="slidenum">
               <a:rPr lang="en-US" smtClean="0"/>
-              <a:t>29</a:t>
+              <a:t>30</a:t>
             </a:fld>
             <a:endParaRPr lang="en-US"/>
           </a:p>
@@ -12872,7 +12520,7 @@
           <a:p>
             <a:fld id="{A5B4ED3A-914E-6443-A2E7-C28A873C6BCA}" type="slidenum">
               <a:rPr lang="en-US" smtClean="0"/>
-              <a:t>30</a:t>
+              <a:t>31</a:t>
             </a:fld>
             <a:endParaRPr lang="en-US"/>
           </a:p>
@@ -12967,7 +12615,7 @@
           <a:p>
             <a:fld id="{A5B4ED3A-914E-6443-A2E7-C28A873C6BCA}" type="slidenum">
               <a:rPr lang="en-US" smtClean="0"/>
-              <a:t>31</a:t>
+              <a:t>32</a:t>
             </a:fld>
             <a:endParaRPr lang="en-US"/>
           </a:p>
@@ -13075,7 +12723,7 @@
           <a:p>
             <a:fld id="{A5B4ED3A-914E-6443-A2E7-C28A873C6BCA}" type="slidenum">
               <a:rPr lang="en-US" smtClean="0"/>
-              <a:t>32</a:t>
+              <a:t>33</a:t>
             </a:fld>
             <a:endParaRPr lang="en-US"/>
           </a:p>
@@ -13183,7 +12831,7 @@
           <a:p>
             <a:fld id="{A5B4ED3A-914E-6443-A2E7-C28A873C6BCA}" type="slidenum">
               <a:rPr lang="en-US" smtClean="0"/>
-              <a:t>33</a:t>
+              <a:t>34</a:t>
             </a:fld>
             <a:endParaRPr lang="en-US"/>
           </a:p>
@@ -13278,7 +12926,7 @@
           <a:p>
             <a:fld id="{A5B4ED3A-914E-6443-A2E7-C28A873C6BCA}" type="slidenum">
               <a:rPr lang="en-US" smtClean="0"/>
-              <a:t>34</a:t>
+              <a:t>35</a:t>
             </a:fld>
             <a:endParaRPr lang="en-US"/>
           </a:p>
@@ -13386,7 +13034,7 @@
           <a:p>
             <a:fld id="{A5B4ED3A-914E-6443-A2E7-C28A873C6BCA}" type="slidenum">
               <a:rPr lang="en-US" smtClean="0"/>
-              <a:t>35</a:t>
+              <a:t>36</a:t>
             </a:fld>
             <a:endParaRPr lang="en-US"/>
           </a:p>
@@ -13494,7 +13142,7 @@
           <a:p>
             <a:fld id="{A5B4ED3A-914E-6443-A2E7-C28A873C6BCA}" type="slidenum">
               <a:rPr lang="en-US" smtClean="0"/>
-              <a:t>36</a:t>
+              <a:t>37</a:t>
             </a:fld>
             <a:endParaRPr lang="en-US"/>
           </a:p>
@@ -13602,7 +13250,7 @@
           <a:p>
             <a:fld id="{A5B4ED3A-914E-6443-A2E7-C28A873C6BCA}" type="slidenum">
               <a:rPr lang="en-US" smtClean="0"/>
-              <a:t>37</a:t>
+              <a:t>38</a:t>
             </a:fld>
             <a:endParaRPr lang="en-US"/>
           </a:p>
@@ -13710,7 +13358,7 @@
           <a:p>
             <a:fld id="{50049E44-D13C-C54E-8DA3-DB5207EAD25C}" type="slidenum">
               <a:rPr lang="en-US" smtClean="0"/>
-              <a:t>38</a:t>
+              <a:t>39</a:t>
             </a:fld>
             <a:endParaRPr lang="en-US"/>
           </a:p>
@@ -13794,7 +13442,7 @@
           <a:p>
             <a:fld id="{A5B4ED3A-914E-6443-A2E7-C28A873C6BCA}" type="slidenum">
               <a:rPr lang="en-US" smtClean="0"/>
-              <a:t>39</a:t>
+              <a:t>40</a:t>
             </a:fld>
             <a:endParaRPr lang="en-US"/>
           </a:p>
@@ -22156,10 +21804,9 @@
           </a:lstStyle>
           <a:p>
             <a:r>
-              <a:rPr lang="en-US"/>
+              <a:rPr lang="en-US" dirty="0"/>
               <a:t>Background</a:t>
             </a:r>
-            <a:endParaRPr lang="en-US" dirty="0"/>
           </a:p>
         </p:txBody>
       </p:sp>
@@ -23299,6 +22946,543 @@
 </file>
 
 <file path=ppt/slides/slide19.xml><?xml version="1.0" encoding="utf-8"?>
+<p:sld xmlns:a="http://schemas.openxmlformats.org/drawingml/2006/main" xmlns:r="http://schemas.openxmlformats.org/officeDocument/2006/relationships" xmlns:p="http://schemas.openxmlformats.org/presentationml/2006/main">
+  <p:cSld>
+    <p:spTree>
+      <p:nvGrpSpPr>
+        <p:cNvPr id="1" name=""/>
+        <p:cNvGrpSpPr/>
+        <p:nvPr/>
+      </p:nvGrpSpPr>
+      <p:grpSpPr>
+        <a:xfrm>
+          <a:off x="0" y="0"/>
+          <a:ext cx="0" cy="0"/>
+          <a:chOff x="0" y="0"/>
+          <a:chExt cx="0" cy="0"/>
+        </a:xfrm>
+      </p:grpSpPr>
+      <p:sp>
+        <p:nvSpPr>
+          <p:cNvPr id="3" name="Text Placeholder 2">
+            <a:extLst>
+              <a:ext uri="{FF2B5EF4-FFF2-40B4-BE49-F238E27FC236}">
+                <a16:creationId xmlns:a16="http://schemas.microsoft.com/office/drawing/2014/main" id="{DB15BF82-222D-4F21-FC15-F9270DA65858}"/>
+              </a:ext>
+            </a:extLst>
+          </p:cNvPr>
+          <p:cNvSpPr>
+            <a:spLocks noGrp="1"/>
+          </p:cNvSpPr>
+          <p:nvPr>
+            <p:ph type="body" sz="quarter" idx="11"/>
+          </p:nvPr>
+        </p:nvSpPr>
+        <p:spPr/>
+        <p:txBody>
+          <a:bodyPr/>
+          <a:lstStyle/>
+          <a:p>
+            <a:r>
+              <a:rPr lang="en-US" dirty="0">
+                <a:hlinkClick r:id="rId2"/>
+              </a:rPr>
+              <a:t>My AoU Cost Estimator App</a:t>
+            </a:r>
+            <a:endParaRPr lang="en-US" dirty="0"/>
+          </a:p>
+        </p:txBody>
+      </p:sp>
+      <p:sp>
+        <p:nvSpPr>
+          <p:cNvPr id="5" name="Slide Number Placeholder 4">
+            <a:extLst>
+              <a:ext uri="{FF2B5EF4-FFF2-40B4-BE49-F238E27FC236}">
+                <a16:creationId xmlns:a16="http://schemas.microsoft.com/office/drawing/2014/main" id="{DBE3D5F8-9199-1BA4-626D-CBF8BCB02CB6}"/>
+              </a:ext>
+            </a:extLst>
+          </p:cNvPr>
+          <p:cNvSpPr>
+            <a:spLocks noGrp="1"/>
+          </p:cNvSpPr>
+          <p:nvPr>
+            <p:ph type="sldNum" sz="quarter" idx="18"/>
+          </p:nvPr>
+        </p:nvSpPr>
+        <p:spPr/>
+        <p:txBody>
+          <a:bodyPr/>
+          <a:lstStyle/>
+          <a:p>
+            <a:fld id="{548469FB-C78A-B94B-B04A-B5BC8C934F85}" type="slidenum">
+              <a:rPr lang="en-US" smtClean="0"/>
+              <a:t>19</a:t>
+            </a:fld>
+            <a:endParaRPr lang="en-US"/>
+          </a:p>
+        </p:txBody>
+      </p:sp>
+      <p:sp>
+        <p:nvSpPr>
+          <p:cNvPr id="8" name="TextBox 7">
+            <a:extLst>
+              <a:ext uri="{FF2B5EF4-FFF2-40B4-BE49-F238E27FC236}">
+                <a16:creationId xmlns:a16="http://schemas.microsoft.com/office/drawing/2014/main" id="{FB28D8FF-D33B-4062-B26E-B5631CF251CA}"/>
+              </a:ext>
+            </a:extLst>
+          </p:cNvPr>
+          <p:cNvSpPr txBox="1"/>
+          <p:nvPr/>
+        </p:nvSpPr>
+        <p:spPr>
+          <a:xfrm>
+            <a:off x="4705141" y="1118522"/>
+            <a:ext cx="6648659" cy="4462760"/>
+          </a:xfrm>
+          <a:prstGeom prst="rect">
+            <a:avLst/>
+          </a:prstGeom>
+          <a:noFill/>
+        </p:spPr>
+        <p:txBody>
+          <a:bodyPr wrap="square" rtlCol="0">
+            <a:spAutoFit/>
+          </a:bodyPr>
+          <a:lstStyle/>
+          <a:p>
+            <a:r>
+              <a:rPr lang="en-US" sz="3000" b="1" dirty="0">
+                <a:solidFill>
+                  <a:srgbClr val="002060"/>
+                </a:solidFill>
+                <a:latin typeface="Avenir Book" panose="02000503020000020003" pitchFamily="2" charset="0"/>
+              </a:rPr>
+              <a:t>Can use this application to estimate the following:</a:t>
+            </a:r>
+          </a:p>
+          <a:p>
+            <a:pPr marL="285750" indent="-285750">
+              <a:buFont typeface="Arial" panose="020B0604020202020204" pitchFamily="34" charset="0"/>
+              <a:buChar char="•"/>
+            </a:pPr>
+            <a:endParaRPr lang="en-US" sz="3200" dirty="0">
+              <a:latin typeface="Avenir Book" panose="02000503020000020003" pitchFamily="2" charset="0"/>
+            </a:endParaRPr>
+          </a:p>
+          <a:p>
+            <a:pPr marL="342900" indent="-342900">
+              <a:buFont typeface="Arial" panose="020B0604020202020204" pitchFamily="34" charset="0"/>
+              <a:buChar char="•"/>
+            </a:pPr>
+            <a:r>
+              <a:rPr lang="en-US" sz="2400" dirty="0">
+                <a:latin typeface="Avenir Book" panose="02000503020000020003" pitchFamily="2" charset="0"/>
+              </a:rPr>
+              <a:t>Upfront costs</a:t>
+            </a:r>
+          </a:p>
+          <a:p>
+            <a:pPr marL="342900" indent="-342900">
+              <a:buFont typeface="Arial" panose="020B0604020202020204" pitchFamily="34" charset="0"/>
+              <a:buChar char="•"/>
+            </a:pPr>
+            <a:endParaRPr lang="en-US" sz="2400" dirty="0">
+              <a:latin typeface="Avenir Book" panose="02000503020000020003" pitchFamily="2" charset="0"/>
+            </a:endParaRPr>
+          </a:p>
+          <a:p>
+            <a:pPr marL="342900" indent="-342900">
+              <a:buFont typeface="Arial" panose="020B0604020202020204" pitchFamily="34" charset="0"/>
+              <a:buChar char="•"/>
+            </a:pPr>
+            <a:r>
+              <a:rPr lang="en-US" sz="2400" dirty="0">
+                <a:latin typeface="Avenir Book" panose="02000503020000020003" pitchFamily="2" charset="0"/>
+              </a:rPr>
+              <a:t>Total compute costs</a:t>
+            </a:r>
+          </a:p>
+          <a:p>
+            <a:pPr marL="457200" indent="-457200">
+              <a:buFont typeface="Arial" panose="020B0604020202020204" pitchFamily="34" charset="0"/>
+              <a:buChar char="•"/>
+            </a:pPr>
+            <a:endParaRPr lang="en-US" sz="2400" dirty="0">
+              <a:latin typeface="Avenir Book" panose="02000503020000020003" pitchFamily="2" charset="0"/>
+            </a:endParaRPr>
+          </a:p>
+          <a:p>
+            <a:pPr marL="457200" indent="-457200">
+              <a:buFont typeface="Arial" panose="020B0604020202020204" pitchFamily="34" charset="0"/>
+              <a:buChar char="•"/>
+            </a:pPr>
+            <a:r>
+              <a:rPr lang="en-US" sz="2400" dirty="0">
+                <a:latin typeface="Avenir Book" panose="02000503020000020003" pitchFamily="2" charset="0"/>
+              </a:rPr>
+              <a:t>Data storage costs for duration of the project</a:t>
+            </a:r>
+          </a:p>
+          <a:p>
+            <a:pPr marL="457200" indent="-457200">
+              <a:buFont typeface="Arial" panose="020B0604020202020204" pitchFamily="34" charset="0"/>
+              <a:buChar char="•"/>
+            </a:pPr>
+            <a:endParaRPr lang="en-US" sz="2400" dirty="0">
+              <a:latin typeface="Avenir Book" panose="02000503020000020003" pitchFamily="2" charset="0"/>
+            </a:endParaRPr>
+          </a:p>
+          <a:p>
+            <a:pPr marL="457200" indent="-457200">
+              <a:buFont typeface="Arial" panose="020B0604020202020204" pitchFamily="34" charset="0"/>
+              <a:buChar char="•"/>
+            </a:pPr>
+            <a:r>
+              <a:rPr lang="en-US" sz="2400" dirty="0">
+                <a:latin typeface="Avenir Book" panose="02000503020000020003" pitchFamily="2" charset="0"/>
+              </a:rPr>
+              <a:t>Total project cost</a:t>
+            </a:r>
+          </a:p>
+        </p:txBody>
+      </p:sp>
+      <p:sp>
+        <p:nvSpPr>
+          <p:cNvPr id="9" name="TextBox 8">
+            <a:extLst>
+              <a:ext uri="{FF2B5EF4-FFF2-40B4-BE49-F238E27FC236}">
+                <a16:creationId xmlns:a16="http://schemas.microsoft.com/office/drawing/2014/main" id="{05D4A543-36A2-AAFD-BF06-E8BDCAA00048}"/>
+              </a:ext>
+            </a:extLst>
+          </p:cNvPr>
+          <p:cNvSpPr txBox="1"/>
+          <p:nvPr/>
+        </p:nvSpPr>
+        <p:spPr>
+          <a:xfrm>
+            <a:off x="152696" y="3692765"/>
+            <a:ext cx="3717890" cy="2102692"/>
+          </a:xfrm>
+          <a:prstGeom prst="rect">
+            <a:avLst/>
+          </a:prstGeom>
+          <a:noFill/>
+        </p:spPr>
+        <p:txBody>
+          <a:bodyPr wrap="square" rtlCol="0">
+            <a:spAutoFit/>
+          </a:bodyPr>
+          <a:lstStyle/>
+          <a:p>
+            <a:pPr>
+              <a:lnSpc>
+                <a:spcPct val="90000"/>
+              </a:lnSpc>
+              <a:spcBef>
+                <a:spcPts val="1000"/>
+              </a:spcBef>
+            </a:pPr>
+            <a:r>
+              <a:rPr lang="en-US" b="1" dirty="0">
+                <a:solidFill>
+                  <a:schemeClr val="bg1"/>
+                </a:solidFill>
+                <a:latin typeface="YaleNew" panose="02000602050000020003" pitchFamily="2" charset="77"/>
+                <a:cs typeface="Calibri" panose="020F0502020204030204" pitchFamily="34" charset="0"/>
+              </a:rPr>
+              <a:t>NOTES</a:t>
+            </a:r>
+          </a:p>
+          <a:p>
+            <a:pPr marL="285750" indent="-285750">
+              <a:lnSpc>
+                <a:spcPct val="90000"/>
+              </a:lnSpc>
+              <a:spcBef>
+                <a:spcPts val="1000"/>
+              </a:spcBef>
+              <a:buSzPct val="80000"/>
+              <a:buFont typeface="Arial" panose="020B0604020202020204" pitchFamily="34" charset="0"/>
+              <a:buChar char="•"/>
+            </a:pPr>
+            <a:r>
+              <a:rPr lang="en-US" dirty="0">
+                <a:solidFill>
+                  <a:schemeClr val="bg1"/>
+                </a:solidFill>
+                <a:latin typeface="YaleNew" panose="02000602050000020003" pitchFamily="2" charset="77"/>
+                <a:cs typeface="Calibri" panose="020F0502020204030204" pitchFamily="34" charset="0"/>
+              </a:rPr>
+              <a:t>Beta phase (updates will be made)</a:t>
+            </a:r>
+          </a:p>
+          <a:p>
+            <a:pPr marL="285750" indent="-285750">
+              <a:lnSpc>
+                <a:spcPct val="90000"/>
+              </a:lnSpc>
+              <a:spcBef>
+                <a:spcPts val="1000"/>
+              </a:spcBef>
+              <a:buSzPct val="80000"/>
+              <a:buFont typeface="Arial" panose="020B0604020202020204" pitchFamily="34" charset="0"/>
+              <a:buChar char="•"/>
+            </a:pPr>
+            <a:r>
+              <a:rPr lang="en-US" dirty="0">
+                <a:solidFill>
+                  <a:schemeClr val="bg1"/>
+                </a:solidFill>
+                <a:latin typeface="YaleNew" panose="02000602050000020003" pitchFamily="2" charset="77"/>
+                <a:cs typeface="Calibri" panose="020F0502020204030204" pitchFamily="34" charset="0"/>
+              </a:rPr>
+              <a:t>Not an official AoU app</a:t>
+            </a:r>
+          </a:p>
+          <a:p>
+            <a:pPr marL="285750" indent="-285750">
+              <a:lnSpc>
+                <a:spcPct val="90000"/>
+              </a:lnSpc>
+              <a:spcBef>
+                <a:spcPts val="1000"/>
+              </a:spcBef>
+              <a:buSzPct val="80000"/>
+              <a:buFont typeface="Arial" panose="020B0604020202020204" pitchFamily="34" charset="0"/>
+              <a:buChar char="•"/>
+            </a:pPr>
+            <a:r>
+              <a:rPr lang="en-US" dirty="0">
+                <a:solidFill>
+                  <a:schemeClr val="bg1"/>
+                </a:solidFill>
+                <a:latin typeface="YaleNew" panose="02000602050000020003" pitchFamily="2" charset="77"/>
+                <a:cs typeface="Calibri" panose="020F0502020204030204" pitchFamily="34" charset="0"/>
+              </a:rPr>
+              <a:t>Pay attention to the parameters you need</a:t>
+            </a:r>
+          </a:p>
+          <a:p>
+            <a:pPr marL="285750" indent="-285750">
+              <a:lnSpc>
+                <a:spcPct val="90000"/>
+              </a:lnSpc>
+              <a:spcBef>
+                <a:spcPts val="1000"/>
+              </a:spcBef>
+              <a:buSzPct val="80000"/>
+              <a:buFont typeface="Arial" panose="020B0604020202020204" pitchFamily="34" charset="0"/>
+              <a:buChar char="•"/>
+            </a:pPr>
+            <a:r>
+              <a:rPr lang="en-US" dirty="0">
+                <a:solidFill>
+                  <a:schemeClr val="bg1"/>
+                </a:solidFill>
+                <a:latin typeface="YaleNew" panose="02000602050000020003" pitchFamily="2" charset="77"/>
+                <a:cs typeface="Calibri" panose="020F0502020204030204" pitchFamily="34" charset="0"/>
+              </a:rPr>
+              <a:t>Please provide feedback</a:t>
+            </a:r>
+          </a:p>
+        </p:txBody>
+      </p:sp>
+    </p:spTree>
+    <p:extLst>
+      <p:ext uri="{BB962C8B-B14F-4D97-AF65-F5344CB8AC3E}">
+        <p14:creationId xmlns:p14="http://schemas.microsoft.com/office/powerpoint/2010/main" val="1265380304"/>
+      </p:ext>
+    </p:extLst>
+  </p:cSld>
+  <p:clrMapOvr>
+    <a:masterClrMapping/>
+  </p:clrMapOvr>
+</p:sld>
+</file>
+
+<file path=ppt/slides/slide2.xml><?xml version="1.0" encoding="utf-8"?>
+<p:sld xmlns:a="http://schemas.openxmlformats.org/drawingml/2006/main" xmlns:r="http://schemas.openxmlformats.org/officeDocument/2006/relationships" xmlns:p="http://schemas.openxmlformats.org/presentationml/2006/main">
+  <p:cSld>
+    <p:spTree>
+      <p:nvGrpSpPr>
+        <p:cNvPr id="1" name="">
+          <a:extLst>
+            <a:ext uri="{FF2B5EF4-FFF2-40B4-BE49-F238E27FC236}">
+              <a16:creationId xmlns:a16="http://schemas.microsoft.com/office/drawing/2014/main" id="{F83DC302-EFD2-C148-18AC-25687AF43B71}"/>
+            </a:ext>
+          </a:extLst>
+        </p:cNvPr>
+        <p:cNvGrpSpPr/>
+        <p:nvPr/>
+      </p:nvGrpSpPr>
+      <p:grpSpPr>
+        <a:xfrm>
+          <a:off x="0" y="0"/>
+          <a:ext cx="0" cy="0"/>
+          <a:chOff x="0" y="0"/>
+          <a:chExt cx="0" cy="0"/>
+        </a:xfrm>
+      </p:grpSpPr>
+      <p:sp>
+        <p:nvSpPr>
+          <p:cNvPr id="3" name="Text Placeholder 2">
+            <a:extLst>
+              <a:ext uri="{FF2B5EF4-FFF2-40B4-BE49-F238E27FC236}">
+                <a16:creationId xmlns:a16="http://schemas.microsoft.com/office/drawing/2014/main" id="{C09063F1-00EC-C725-2398-222ECAAE9D8E}"/>
+              </a:ext>
+            </a:extLst>
+          </p:cNvPr>
+          <p:cNvSpPr>
+            <a:spLocks noGrp="1"/>
+          </p:cNvSpPr>
+          <p:nvPr>
+            <p:ph type="body" sz="quarter" idx="11"/>
+          </p:nvPr>
+        </p:nvSpPr>
+        <p:spPr>
+          <a:xfrm>
+            <a:off x="458143" y="3143633"/>
+            <a:ext cx="3034570" cy="722197"/>
+          </a:xfrm>
+        </p:spPr>
+        <p:txBody>
+          <a:bodyPr/>
+          <a:lstStyle/>
+          <a:p>
+            <a:r>
+              <a:rPr lang="en-US" dirty="0">
+                <a:latin typeface="YaleNew" panose="02000602050000020003" pitchFamily="2" charset="77"/>
+              </a:rPr>
+              <a:t>Interactive poll questions</a:t>
+            </a:r>
+          </a:p>
+        </p:txBody>
+      </p:sp>
+      <p:sp>
+        <p:nvSpPr>
+          <p:cNvPr id="6" name="Slide Number Placeholder 5">
+            <a:extLst>
+              <a:ext uri="{FF2B5EF4-FFF2-40B4-BE49-F238E27FC236}">
+                <a16:creationId xmlns:a16="http://schemas.microsoft.com/office/drawing/2014/main" id="{28F2178C-7904-230F-946F-A4C46EA7E995}"/>
+              </a:ext>
+            </a:extLst>
+          </p:cNvPr>
+          <p:cNvSpPr>
+            <a:spLocks noGrp="1"/>
+          </p:cNvSpPr>
+          <p:nvPr>
+            <p:ph type="sldNum" sz="quarter" idx="18"/>
+          </p:nvPr>
+        </p:nvSpPr>
+        <p:spPr/>
+        <p:txBody>
+          <a:bodyPr/>
+          <a:lstStyle/>
+          <a:p>
+            <a:fld id="{548469FB-C78A-B94B-B04A-B5BC8C934F85}" type="slidenum">
+              <a:rPr lang="en-US" smtClean="0"/>
+              <a:t>2</a:t>
+            </a:fld>
+            <a:endParaRPr lang="en-US"/>
+          </a:p>
+        </p:txBody>
+      </p:sp>
+      <p:pic>
+        <p:nvPicPr>
+          <p:cNvPr id="2" name="Picture 1">
+            <a:extLst>
+              <a:ext uri="{FF2B5EF4-FFF2-40B4-BE49-F238E27FC236}">
+                <a16:creationId xmlns:a16="http://schemas.microsoft.com/office/drawing/2014/main" id="{4363CA7D-213E-1C91-B67A-C77699EBA599}"/>
+              </a:ext>
+            </a:extLst>
+          </p:cNvPr>
+          <p:cNvPicPr>
+            <a:picLocks noChangeAspect="1"/>
+          </p:cNvPicPr>
+          <p:nvPr/>
+        </p:nvPicPr>
+        <p:blipFill>
+          <a:blip r:embed="rId3"/>
+          <a:stretch>
+            <a:fillRect/>
+          </a:stretch>
+        </p:blipFill>
+        <p:spPr>
+          <a:xfrm>
+            <a:off x="5296907" y="243308"/>
+            <a:ext cx="5664720" cy="6295604"/>
+          </a:xfrm>
+          <a:prstGeom prst="rect">
+            <a:avLst/>
+          </a:prstGeom>
+        </p:spPr>
+      </p:pic>
+      <p:sp>
+        <p:nvSpPr>
+          <p:cNvPr id="4" name="Oval 3">
+            <a:extLst>
+              <a:ext uri="{FF2B5EF4-FFF2-40B4-BE49-F238E27FC236}">
+                <a16:creationId xmlns:a16="http://schemas.microsoft.com/office/drawing/2014/main" id="{009B0DA8-9AE9-2A95-5B46-5858BF3BC709}"/>
+              </a:ext>
+            </a:extLst>
+          </p:cNvPr>
+          <p:cNvSpPr/>
+          <p:nvPr/>
+        </p:nvSpPr>
+        <p:spPr>
+          <a:xfrm>
+            <a:off x="5518768" y="5057522"/>
+            <a:ext cx="1408014" cy="712099"/>
+          </a:xfrm>
+          <a:prstGeom prst="ellipse">
+            <a:avLst/>
+          </a:prstGeom>
+          <a:noFill/>
+          <a:ln w="76200">
+            <a:solidFill>
+              <a:srgbClr val="FF0000"/>
+            </a:solidFill>
+          </a:ln>
+        </p:spPr>
+        <p:style>
+          <a:lnRef idx="2">
+            <a:schemeClr val="accent1">
+              <a:shade val="15000"/>
+            </a:schemeClr>
+          </a:lnRef>
+          <a:fillRef idx="1">
+            <a:schemeClr val="accent1"/>
+          </a:fillRef>
+          <a:effectRef idx="0">
+            <a:schemeClr val="accent1"/>
+          </a:effectRef>
+          <a:fontRef idx="minor">
+            <a:schemeClr val="lt1"/>
+          </a:fontRef>
+        </p:style>
+        <p:txBody>
+          <a:bodyPr rtlCol="0" anchor="ctr"/>
+          <a:lstStyle/>
+          <a:p>
+            <a:pPr algn="ctr"/>
+            <a:endParaRPr lang="en-US"/>
+          </a:p>
+        </p:txBody>
+      </p:sp>
+    </p:spTree>
+    <p:extLst>
+      <p:ext uri="{BB962C8B-B14F-4D97-AF65-F5344CB8AC3E}">
+        <p14:creationId xmlns:p14="http://schemas.microsoft.com/office/powerpoint/2010/main" val="2193341156"/>
+      </p:ext>
+    </p:extLst>
+  </p:cSld>
+  <p:clrMapOvr>
+    <a:masterClrMapping/>
+  </p:clrMapOvr>
+</p:sld>
+</file>
+
+<file path=ppt/slides/slide20.xml><?xml version="1.0" encoding="utf-8"?>
 <p:sld xmlns:a="http://schemas.openxmlformats.org/drawingml/2006/main" xmlns:r="http://schemas.openxmlformats.org/officeDocument/2006/relationships" xmlns:p="http://schemas.openxmlformats.org/presentationml/2006/main">
   <p:cSld>
     <p:spTree>
@@ -23408,189 +23592,7 @@
 </p:sld>
 </file>
 
-<file path=ppt/slides/slide2.xml><?xml version="1.0" encoding="utf-8"?>
-<p:sld xmlns:a="http://schemas.openxmlformats.org/drawingml/2006/main" xmlns:r="http://schemas.openxmlformats.org/officeDocument/2006/relationships" xmlns:p="http://schemas.openxmlformats.org/presentationml/2006/main">
-  <p:cSld>
-    <p:spTree>
-      <p:nvGrpSpPr>
-        <p:cNvPr id="1" name="">
-          <a:extLst>
-            <a:ext uri="{FF2B5EF4-FFF2-40B4-BE49-F238E27FC236}">
-              <a16:creationId xmlns:a16="http://schemas.microsoft.com/office/drawing/2014/main" id="{F83DC302-EFD2-C148-18AC-25687AF43B71}"/>
-            </a:ext>
-          </a:extLst>
-        </p:cNvPr>
-        <p:cNvGrpSpPr/>
-        <p:nvPr/>
-      </p:nvGrpSpPr>
-      <p:grpSpPr>
-        <a:xfrm>
-          <a:off x="0" y="0"/>
-          <a:ext cx="0" cy="0"/>
-          <a:chOff x="0" y="0"/>
-          <a:chExt cx="0" cy="0"/>
-        </a:xfrm>
-      </p:grpSpPr>
-      <p:sp>
-        <p:nvSpPr>
-          <p:cNvPr id="3" name="Text Placeholder 2">
-            <a:extLst>
-              <a:ext uri="{FF2B5EF4-FFF2-40B4-BE49-F238E27FC236}">
-                <a16:creationId xmlns:a16="http://schemas.microsoft.com/office/drawing/2014/main" id="{C09063F1-00EC-C725-2398-222ECAAE9D8E}"/>
-              </a:ext>
-            </a:extLst>
-          </p:cNvPr>
-          <p:cNvSpPr>
-            <a:spLocks noGrp="1"/>
-          </p:cNvSpPr>
-          <p:nvPr>
-            <p:ph type="body" sz="quarter" idx="11"/>
-          </p:nvPr>
-        </p:nvSpPr>
-        <p:spPr>
-          <a:xfrm>
-            <a:off x="458143" y="3143633"/>
-            <a:ext cx="3034570" cy="722197"/>
-          </a:xfrm>
-        </p:spPr>
-        <p:txBody>
-          <a:bodyPr/>
-          <a:lstStyle/>
-          <a:p>
-            <a:r>
-              <a:rPr lang="en-US" dirty="0">
-                <a:latin typeface="YaleNew" panose="02000602050000020003" pitchFamily="2" charset="77"/>
-              </a:rPr>
-              <a:t>Interactive poll questions</a:t>
-            </a:r>
-          </a:p>
-        </p:txBody>
-      </p:sp>
-      <p:sp>
-        <p:nvSpPr>
-          <p:cNvPr id="6" name="Slide Number Placeholder 5">
-            <a:extLst>
-              <a:ext uri="{FF2B5EF4-FFF2-40B4-BE49-F238E27FC236}">
-                <a16:creationId xmlns:a16="http://schemas.microsoft.com/office/drawing/2014/main" id="{28F2178C-7904-230F-946F-A4C46EA7E995}"/>
-              </a:ext>
-            </a:extLst>
-          </p:cNvPr>
-          <p:cNvSpPr>
-            <a:spLocks noGrp="1"/>
-          </p:cNvSpPr>
-          <p:nvPr>
-            <p:ph type="sldNum" sz="quarter" idx="18"/>
-          </p:nvPr>
-        </p:nvSpPr>
-        <p:spPr/>
-        <p:txBody>
-          <a:bodyPr/>
-          <a:lstStyle/>
-          <a:p>
-            <a:fld id="{548469FB-C78A-B94B-B04A-B5BC8C934F85}" type="slidenum">
-              <a:rPr lang="en-US" smtClean="0"/>
-              <a:t>2</a:t>
-            </a:fld>
-            <a:endParaRPr lang="en-US"/>
-          </a:p>
-        </p:txBody>
-      </p:sp>
-      <p:pic>
-        <p:nvPicPr>
-          <p:cNvPr id="2" name="Picture 1">
-            <a:extLst>
-              <a:ext uri="{FF2B5EF4-FFF2-40B4-BE49-F238E27FC236}">
-                <a16:creationId xmlns:a16="http://schemas.microsoft.com/office/drawing/2014/main" id="{4363CA7D-213E-1C91-B67A-C77699EBA599}"/>
-              </a:ext>
-            </a:extLst>
-          </p:cNvPr>
-          <p:cNvPicPr>
-            <a:picLocks noChangeAspect="1"/>
-          </p:cNvPicPr>
-          <p:nvPr/>
-        </p:nvPicPr>
-        <p:blipFill>
-          <a:blip r:embed="rId3"/>
-          <a:stretch>
-            <a:fillRect/>
-          </a:stretch>
-        </p:blipFill>
-        <p:spPr>
-          <a:xfrm>
-            <a:off x="5296907" y="243308"/>
-            <a:ext cx="5664720" cy="6295604"/>
-          </a:xfrm>
-          <a:prstGeom prst="rect">
-            <a:avLst/>
-          </a:prstGeom>
-        </p:spPr>
-      </p:pic>
-      <p:sp>
-        <p:nvSpPr>
-          <p:cNvPr id="4" name="Oval 3">
-            <a:extLst>
-              <a:ext uri="{FF2B5EF4-FFF2-40B4-BE49-F238E27FC236}">
-                <a16:creationId xmlns:a16="http://schemas.microsoft.com/office/drawing/2014/main" id="{009B0DA8-9AE9-2A95-5B46-5858BF3BC709}"/>
-              </a:ext>
-            </a:extLst>
-          </p:cNvPr>
-          <p:cNvSpPr/>
-          <p:nvPr/>
-        </p:nvSpPr>
-        <p:spPr>
-          <a:xfrm>
-            <a:off x="5518768" y="5057522"/>
-            <a:ext cx="1408014" cy="712099"/>
-          </a:xfrm>
-          <a:prstGeom prst="ellipse">
-            <a:avLst/>
-          </a:prstGeom>
-          <a:noFill/>
-          <a:ln w="76200">
-            <a:solidFill>
-              <a:srgbClr val="FF0000"/>
-            </a:solidFill>
-          </a:ln>
-        </p:spPr>
-        <p:style>
-          <a:lnRef idx="2">
-            <a:schemeClr val="accent1">
-              <a:shade val="15000"/>
-            </a:schemeClr>
-          </a:lnRef>
-          <a:fillRef idx="1">
-            <a:schemeClr val="accent1"/>
-          </a:fillRef>
-          <a:effectRef idx="0">
-            <a:schemeClr val="accent1"/>
-          </a:effectRef>
-          <a:fontRef idx="minor">
-            <a:schemeClr val="lt1"/>
-          </a:fontRef>
-        </p:style>
-        <p:txBody>
-          <a:bodyPr rtlCol="0" anchor="ctr"/>
-          <a:lstStyle/>
-          <a:p>
-            <a:pPr algn="ctr"/>
-            <a:endParaRPr lang="en-US"/>
-          </a:p>
-        </p:txBody>
-      </p:sp>
-    </p:spTree>
-    <p:extLst>
-      <p:ext uri="{BB962C8B-B14F-4D97-AF65-F5344CB8AC3E}">
-        <p14:creationId xmlns:p14="http://schemas.microsoft.com/office/powerpoint/2010/main" val="2193341156"/>
-      </p:ext>
-    </p:extLst>
-  </p:cSld>
-  <p:clrMapOvr>
-    <a:masterClrMapping/>
-  </p:clrMapOvr>
-</p:sld>
-</file>
-
-<file path=ppt/slides/slide20.xml><?xml version="1.0" encoding="utf-8"?>
+<file path=ppt/slides/slide21.xml><?xml version="1.0" encoding="utf-8"?>
 <p:sld xmlns:a="http://schemas.openxmlformats.org/drawingml/2006/main" xmlns:r="http://schemas.openxmlformats.org/officeDocument/2006/relationships" xmlns:p="http://schemas.openxmlformats.org/presentationml/2006/main">
   <p:cSld>
     <p:spTree>
@@ -23848,7 +23850,7 @@
           <a:p>
             <a:fld id="{548469FB-C78A-B94B-B04A-B5BC8C934F85}" type="slidenum">
               <a:rPr lang="en-US" smtClean="0"/>
-              <a:t>20</a:t>
+              <a:t>21</a:t>
             </a:fld>
             <a:endParaRPr lang="en-US"/>
           </a:p>
@@ -24275,7 +24277,7 @@
 </p:sld>
 </file>
 
-<file path=ppt/slides/slide21.xml><?xml version="1.0" encoding="utf-8"?>
+<file path=ppt/slides/slide22.xml><?xml version="1.0" encoding="utf-8"?>
 <p:sld xmlns:a="http://schemas.openxmlformats.org/drawingml/2006/main" xmlns:r="http://schemas.openxmlformats.org/officeDocument/2006/relationships" xmlns:p="http://schemas.openxmlformats.org/presentationml/2006/main">
   <p:cSld>
     <p:spTree>
@@ -24385,7 +24387,7 @@
 </p:sld>
 </file>
 
-<file path=ppt/slides/slide22.xml><?xml version="1.0" encoding="utf-8"?>
+<file path=ppt/slides/slide23.xml><?xml version="1.0" encoding="utf-8"?>
 <p:sld xmlns:a="http://schemas.openxmlformats.org/drawingml/2006/main" xmlns:r="http://schemas.openxmlformats.org/officeDocument/2006/relationships" xmlns:p="http://schemas.openxmlformats.org/presentationml/2006/main">
   <p:cSld>
     <p:spTree>
@@ -24715,7 +24717,7 @@
           <a:p>
             <a:fld id="{548469FB-C78A-B94B-B04A-B5BC8C934F85}" type="slidenum">
               <a:rPr lang="en-US" smtClean="0"/>
-              <a:t>22</a:t>
+              <a:t>23</a:t>
             </a:fld>
             <a:endParaRPr lang="en-US"/>
           </a:p>
@@ -24763,7 +24765,7 @@
 </p:sld>
 </file>
 
-<file path=ppt/slides/slide23.xml><?xml version="1.0" encoding="utf-8"?>
+<file path=ppt/slides/slide24.xml><?xml version="1.0" encoding="utf-8"?>
 <p:sld xmlns:a="http://schemas.openxmlformats.org/drawingml/2006/main" xmlns:r="http://schemas.openxmlformats.org/officeDocument/2006/relationships" xmlns:p="http://schemas.openxmlformats.org/presentationml/2006/main">
   <p:cSld>
     <p:spTree>
@@ -24804,7 +24806,7 @@
         </p:nvSpPr>
         <p:spPr>
           <a:xfrm>
-            <a:off x="5072418" y="772990"/>
+            <a:off x="4932365" y="533505"/>
             <a:ext cx="6323463" cy="4044670"/>
           </a:xfrm>
         </p:spPr>
@@ -24841,7 +24843,7 @@
               <a:buChar char="o"/>
             </a:pPr>
             <a:r>
-              <a:rPr lang="en-US" sz="1800" dirty="0">
+              <a:rPr lang="en-US" sz="2000" dirty="0">
                 <a:latin typeface="Avenir Book" panose="02000503020000020003" pitchFamily="2" charset="0"/>
               </a:rPr>
               <a:t>Demographics, conditions, measurements, medications, procedures, and surveys</a:t>
@@ -24858,7 +24860,7 @@
               <a:buFont typeface="Courier New" panose="02070309020205020404" pitchFamily="49" charset="0"/>
               <a:buChar char="o"/>
             </a:pPr>
-            <a:endParaRPr lang="en-US" sz="1800" dirty="0">
+            <a:endParaRPr lang="en-US" sz="2000" dirty="0">
               <a:latin typeface="Avenir Book" panose="02000503020000020003" pitchFamily="2" charset="0"/>
             </a:endParaRPr>
           </a:p>
@@ -24914,7 +24916,7 @@
               <a:buChar char="o"/>
             </a:pPr>
             <a:r>
-              <a:rPr lang="en-US" sz="1800" dirty="0">
+              <a:rPr lang="en-US" sz="2000" dirty="0">
                 <a:latin typeface="Avenir Book" panose="02000503020000020003" pitchFamily="2" charset="0"/>
               </a:rPr>
               <a:t>Illness occurs N days before medication was prescribed</a:t>
@@ -24930,7 +24932,7 @@
               </a:spcBef>
               <a:buNone/>
             </a:pPr>
-            <a:endParaRPr lang="en-US" sz="2400" dirty="0">
+            <a:endParaRPr lang="en-US" dirty="0">
               <a:latin typeface="Avenir Book" panose="02000503020000020003" pitchFamily="2" charset="0"/>
             </a:endParaRPr>
           </a:p>
@@ -24944,7 +24946,7 @@
               </a:spcBef>
               <a:buNone/>
             </a:pPr>
-            <a:endParaRPr lang="en-US" sz="2400" dirty="0">
+            <a:endParaRPr lang="en-US" dirty="0">
               <a:latin typeface="Avenir Book" panose="02000503020000020003" pitchFamily="2" charset="0"/>
             </a:endParaRPr>
           </a:p>
@@ -25011,7 +25013,7 @@
           <a:p>
             <a:fld id="{548469FB-C78A-B94B-B04A-B5BC8C934F85}" type="slidenum">
               <a:rPr lang="en-US" smtClean="0"/>
-              <a:t>23</a:t>
+              <a:t>24</a:t>
             </a:fld>
             <a:endParaRPr lang="en-US"/>
           </a:p>
@@ -25031,7 +25033,7 @@
         </p:nvSpPr>
         <p:spPr>
           <a:xfrm>
-            <a:off x="5181600" y="4141738"/>
+            <a:off x="5798118" y="4202874"/>
             <a:ext cx="4787900" cy="2031325"/>
           </a:xfrm>
           <a:prstGeom prst="rect">
@@ -25437,7 +25439,7 @@
 </p:sld>
 </file>
 
-<file path=ppt/slides/slide24.xml><?xml version="1.0" encoding="utf-8"?>
+<file path=ppt/slides/slide25.xml><?xml version="1.0" encoding="utf-8"?>
 <p:sld xmlns:a="http://schemas.openxmlformats.org/drawingml/2006/main" xmlns:r="http://schemas.openxmlformats.org/officeDocument/2006/relationships" xmlns:p="http://schemas.openxmlformats.org/presentationml/2006/main">
   <p:cSld>
     <p:spTree>
@@ -25617,7 +25619,7 @@
           <a:p>
             <a:fld id="{548469FB-C78A-B94B-B04A-B5BC8C934F85}" type="slidenum">
               <a:rPr lang="en-US" smtClean="0"/>
-              <a:t>24</a:t>
+              <a:t>25</a:t>
             </a:fld>
             <a:endParaRPr lang="en-US"/>
           </a:p>
@@ -27244,7 +27246,7 @@
 </p:sld>
 </file>
 
-<file path=ppt/slides/slide25.xml><?xml version="1.0" encoding="utf-8"?>
+<file path=ppt/slides/slide26.xml><?xml version="1.0" encoding="utf-8"?>
 <p:sld xmlns:a="http://schemas.openxmlformats.org/drawingml/2006/main" xmlns:r="http://schemas.openxmlformats.org/officeDocument/2006/relationships" xmlns:p="http://schemas.openxmlformats.org/presentationml/2006/main">
   <p:cSld>
     <p:spTree>
@@ -27491,7 +27493,7 @@
           <a:p>
             <a:fld id="{548469FB-C78A-B94B-B04A-B5BC8C934F85}" type="slidenum">
               <a:rPr lang="en-US" smtClean="0"/>
-              <a:t>25</a:t>
+              <a:t>26</a:t>
             </a:fld>
             <a:endParaRPr lang="en-US"/>
           </a:p>
@@ -28010,7 +28012,7 @@
 </p:sld>
 </file>
 
-<file path=ppt/slides/slide26.xml><?xml version="1.0" encoding="utf-8"?>
+<file path=ppt/slides/slide27.xml><?xml version="1.0" encoding="utf-8"?>
 <p:sld xmlns:a="http://schemas.openxmlformats.org/drawingml/2006/main" xmlns:r="http://schemas.openxmlformats.org/officeDocument/2006/relationships" xmlns:p="http://schemas.openxmlformats.org/presentationml/2006/main">
   <p:cSld>
     <p:spTree>
@@ -28104,7 +28106,7 @@
             <a:fld id="{00000000-1234-1234-1234-123412341234}" type="slidenum">
               <a:rPr lang="en"/>
               <a:pPr/>
-              <a:t>26</a:t>
+              <a:t>27</a:t>
             </a:fld>
             <a:endParaRPr/>
           </a:p>
@@ -28318,7 +28320,7 @@
 </p:sld>
 </file>
 
-<file path=ppt/slides/slide27.xml><?xml version="1.0" encoding="utf-8"?>
+<file path=ppt/slides/slide28.xml><?xml version="1.0" encoding="utf-8"?>
 <p:sld xmlns:a="http://schemas.openxmlformats.org/drawingml/2006/main" xmlns:r="http://schemas.openxmlformats.org/officeDocument/2006/relationships" xmlns:p="http://schemas.openxmlformats.org/presentationml/2006/main">
   <p:cSld>
     <p:spTree>
@@ -28457,7 +28459,7 @@
           <a:p>
             <a:fld id="{548469FB-C78A-B94B-B04A-B5BC8C934F85}" type="slidenum">
               <a:rPr lang="en-US" smtClean="0"/>
-              <a:t>27</a:t>
+              <a:t>28</a:t>
             </a:fld>
             <a:endParaRPr lang="en-US"/>
           </a:p>
@@ -28806,7 +28808,7 @@
 </p:sld>
 </file>
 
-<file path=ppt/slides/slide28.xml><?xml version="1.0" encoding="utf-8"?>
+<file path=ppt/slides/slide29.xml><?xml version="1.0" encoding="utf-8"?>
 <p:sld xmlns:a="http://schemas.openxmlformats.org/drawingml/2006/main" xmlns:r="http://schemas.openxmlformats.org/officeDocument/2006/relationships" xmlns:p="http://schemas.openxmlformats.org/presentationml/2006/main">
   <p:cSld>
     <p:spTree>
@@ -28932,7 +28934,7 @@
           <a:p>
             <a:fld id="{548469FB-C78A-B94B-B04A-B5BC8C934F85}" type="slidenum">
               <a:rPr lang="en-US" smtClean="0"/>
-              <a:t>28</a:t>
+              <a:t>29</a:t>
             </a:fld>
             <a:endParaRPr lang="en-US"/>
           </a:p>
@@ -29271,116 +29273,6 @@
     <p:extLst>
       <p:ext uri="{BB962C8B-B14F-4D97-AF65-F5344CB8AC3E}">
         <p14:creationId xmlns:p14="http://schemas.microsoft.com/office/powerpoint/2010/main" val="3368575850"/>
-      </p:ext>
-    </p:extLst>
-  </p:cSld>
-  <p:clrMapOvr>
-    <a:masterClrMapping/>
-  </p:clrMapOvr>
-</p:sld>
-</file>
-
-<file path=ppt/slides/slide29.xml><?xml version="1.0" encoding="utf-8"?>
-<p:sld xmlns:a="http://schemas.openxmlformats.org/drawingml/2006/main" xmlns:r="http://schemas.openxmlformats.org/officeDocument/2006/relationships" xmlns:p="http://schemas.openxmlformats.org/presentationml/2006/main">
-  <p:cSld>
-    <p:spTree>
-      <p:nvGrpSpPr>
-        <p:cNvPr id="1" name=""/>
-        <p:cNvGrpSpPr/>
-        <p:nvPr/>
-      </p:nvGrpSpPr>
-      <p:grpSpPr>
-        <a:xfrm>
-          <a:off x="0" y="0"/>
-          <a:ext cx="0" cy="0"/>
-          <a:chOff x="0" y="0"/>
-          <a:chExt cx="0" cy="0"/>
-        </a:xfrm>
-      </p:grpSpPr>
-      <p:sp>
-        <p:nvSpPr>
-          <p:cNvPr id="2" name="Title 1">
-            <a:extLst>
-              <a:ext uri="{FF2B5EF4-FFF2-40B4-BE49-F238E27FC236}">
-                <a16:creationId xmlns:a16="http://schemas.microsoft.com/office/drawing/2014/main" id="{032FAFB0-71AE-69FA-3152-0EEB218AED28}"/>
-              </a:ext>
-            </a:extLst>
-          </p:cNvPr>
-          <p:cNvSpPr>
-            <a:spLocks noGrp="1"/>
-          </p:cNvSpPr>
-          <p:nvPr>
-            <p:ph type="ctrTitle"/>
-          </p:nvPr>
-        </p:nvSpPr>
-        <p:spPr/>
-        <p:txBody>
-          <a:bodyPr/>
-          <a:lstStyle/>
-          <a:p>
-            <a:endParaRPr lang="en-US"/>
-          </a:p>
-        </p:txBody>
-      </p:sp>
-      <p:sp>
-        <p:nvSpPr>
-          <p:cNvPr id="3" name="Subtitle 2">
-            <a:extLst>
-              <a:ext uri="{FF2B5EF4-FFF2-40B4-BE49-F238E27FC236}">
-                <a16:creationId xmlns:a16="http://schemas.microsoft.com/office/drawing/2014/main" id="{106FC365-D38C-467C-885E-A5A3E66894F0}"/>
-              </a:ext>
-            </a:extLst>
-          </p:cNvPr>
-          <p:cNvSpPr>
-            <a:spLocks noGrp="1"/>
-          </p:cNvSpPr>
-          <p:nvPr>
-            <p:ph type="subTitle" idx="1"/>
-          </p:nvPr>
-        </p:nvSpPr>
-        <p:spPr/>
-        <p:txBody>
-          <a:bodyPr/>
-          <a:lstStyle/>
-          <a:p>
-            <a:endParaRPr lang="en-US"/>
-          </a:p>
-        </p:txBody>
-      </p:sp>
-      <p:pic>
-        <p:nvPicPr>
-          <p:cNvPr id="5" name="slide.url=https://www.polleverywhere.com/multiple_choice_polls/7blKFs199cgFMHWWDvnGQ?state=opened&amp;flow=Default&amp;onscreen=persist">
-            <a:extLst>
-              <a:ext uri="{FF2B5EF4-FFF2-40B4-BE49-F238E27FC236}">
-                <a16:creationId xmlns:a16="http://schemas.microsoft.com/office/drawing/2014/main" id="{2FEAA140-33D0-8730-1320-4629836DCD4C}"/>
-              </a:ext>
-            </a:extLst>
-          </p:cNvPr>
-          <p:cNvPicPr>
-            <a:picLocks/>
-          </p:cNvPicPr>
-          <p:nvPr/>
-        </p:nvPicPr>
-        <p:blipFill>
-          <a:blip r:embed="rId3"/>
-          <a:stretch>
-            <a:fillRect/>
-          </a:stretch>
-        </p:blipFill>
-        <p:spPr>
-          <a:xfrm>
-            <a:off x="63500" y="63500"/>
-            <a:ext cx="12065000" cy="6731000"/>
-          </a:xfrm>
-          <a:prstGeom prst="rect">
-            <a:avLst/>
-          </a:prstGeom>
-        </p:spPr>
-      </p:pic>
-    </p:spTree>
-    <p:extLst>
-      <p:ext uri="{BB962C8B-B14F-4D97-AF65-F5344CB8AC3E}">
-        <p14:creationId xmlns:p14="http://schemas.microsoft.com/office/powerpoint/2010/main" val="1091494889"/>
       </p:ext>
     </p:extLst>
   </p:cSld>
@@ -29542,6 +29434,116 @@
           <p:cNvPr id="2" name="Title 1">
             <a:extLst>
               <a:ext uri="{FF2B5EF4-FFF2-40B4-BE49-F238E27FC236}">
+                <a16:creationId xmlns:a16="http://schemas.microsoft.com/office/drawing/2014/main" id="{032FAFB0-71AE-69FA-3152-0EEB218AED28}"/>
+              </a:ext>
+            </a:extLst>
+          </p:cNvPr>
+          <p:cNvSpPr>
+            <a:spLocks noGrp="1"/>
+          </p:cNvSpPr>
+          <p:nvPr>
+            <p:ph type="ctrTitle"/>
+          </p:nvPr>
+        </p:nvSpPr>
+        <p:spPr/>
+        <p:txBody>
+          <a:bodyPr/>
+          <a:lstStyle/>
+          <a:p>
+            <a:endParaRPr lang="en-US"/>
+          </a:p>
+        </p:txBody>
+      </p:sp>
+      <p:sp>
+        <p:nvSpPr>
+          <p:cNvPr id="3" name="Subtitle 2">
+            <a:extLst>
+              <a:ext uri="{FF2B5EF4-FFF2-40B4-BE49-F238E27FC236}">
+                <a16:creationId xmlns:a16="http://schemas.microsoft.com/office/drawing/2014/main" id="{106FC365-D38C-467C-885E-A5A3E66894F0}"/>
+              </a:ext>
+            </a:extLst>
+          </p:cNvPr>
+          <p:cNvSpPr>
+            <a:spLocks noGrp="1"/>
+          </p:cNvSpPr>
+          <p:nvPr>
+            <p:ph type="subTitle" idx="1"/>
+          </p:nvPr>
+        </p:nvSpPr>
+        <p:spPr/>
+        <p:txBody>
+          <a:bodyPr/>
+          <a:lstStyle/>
+          <a:p>
+            <a:endParaRPr lang="en-US"/>
+          </a:p>
+        </p:txBody>
+      </p:sp>
+      <p:pic>
+        <p:nvPicPr>
+          <p:cNvPr id="5" name="slide.url=https://www.polleverywhere.com/multiple_choice_polls/7blKFs199cgFMHWWDvnGQ?state=opened&amp;flow=Default&amp;onscreen=persist">
+            <a:extLst>
+              <a:ext uri="{FF2B5EF4-FFF2-40B4-BE49-F238E27FC236}">
+                <a16:creationId xmlns:a16="http://schemas.microsoft.com/office/drawing/2014/main" id="{2FEAA140-33D0-8730-1320-4629836DCD4C}"/>
+              </a:ext>
+            </a:extLst>
+          </p:cNvPr>
+          <p:cNvPicPr>
+            <a:picLocks/>
+          </p:cNvPicPr>
+          <p:nvPr/>
+        </p:nvPicPr>
+        <p:blipFill>
+          <a:blip r:embed="rId3"/>
+          <a:stretch>
+            <a:fillRect/>
+          </a:stretch>
+        </p:blipFill>
+        <p:spPr>
+          <a:xfrm>
+            <a:off x="63500" y="63500"/>
+            <a:ext cx="12065000" cy="6731000"/>
+          </a:xfrm>
+          <a:prstGeom prst="rect">
+            <a:avLst/>
+          </a:prstGeom>
+        </p:spPr>
+      </p:pic>
+    </p:spTree>
+    <p:extLst>
+      <p:ext uri="{BB962C8B-B14F-4D97-AF65-F5344CB8AC3E}">
+        <p14:creationId xmlns:p14="http://schemas.microsoft.com/office/powerpoint/2010/main" val="1091494889"/>
+      </p:ext>
+    </p:extLst>
+  </p:cSld>
+  <p:clrMapOvr>
+    <a:masterClrMapping/>
+  </p:clrMapOvr>
+</p:sld>
+</file>
+
+<file path=ppt/slides/slide31.xml><?xml version="1.0" encoding="utf-8"?>
+<p:sld xmlns:a="http://schemas.openxmlformats.org/drawingml/2006/main" xmlns:r="http://schemas.openxmlformats.org/officeDocument/2006/relationships" xmlns:p="http://schemas.openxmlformats.org/presentationml/2006/main">
+  <p:cSld>
+    <p:spTree>
+      <p:nvGrpSpPr>
+        <p:cNvPr id="1" name=""/>
+        <p:cNvGrpSpPr/>
+        <p:nvPr/>
+      </p:nvGrpSpPr>
+      <p:grpSpPr>
+        <a:xfrm>
+          <a:off x="0" y="0"/>
+          <a:ext cx="0" cy="0"/>
+          <a:chOff x="0" y="0"/>
+          <a:chExt cx="0" cy="0"/>
+        </a:xfrm>
+      </p:grpSpPr>
+      <p:sp>
+        <p:nvSpPr>
+          <p:cNvPr id="2" name="Title 1">
+            <a:extLst>
+              <a:ext uri="{FF2B5EF4-FFF2-40B4-BE49-F238E27FC236}">
                 <a16:creationId xmlns:a16="http://schemas.microsoft.com/office/drawing/2014/main" id="{89E88A25-3535-FDD5-0C35-E5122C6C6EDA}"/>
               </a:ext>
             </a:extLst>
@@ -29630,7 +29632,7 @@
 </p:sld>
 </file>
 
-<file path=ppt/slides/slide31.xml><?xml version="1.0" encoding="utf-8"?>
+<file path=ppt/slides/slide32.xml><?xml version="1.0" encoding="utf-8"?>
 <p:sld xmlns:a="http://schemas.openxmlformats.org/drawingml/2006/main" xmlns:r="http://schemas.openxmlformats.org/officeDocument/2006/relationships" xmlns:p="http://schemas.openxmlformats.org/presentationml/2006/main">
   <p:cSld>
     <p:spTree>
@@ -29740,7 +29742,7 @@
 </p:sld>
 </file>
 
-<file path=ppt/slides/slide32.xml><?xml version="1.0" encoding="utf-8"?>
+<file path=ppt/slides/slide33.xml><?xml version="1.0" encoding="utf-8"?>
 <p:sld xmlns:a="http://schemas.openxmlformats.org/drawingml/2006/main" xmlns:r="http://schemas.openxmlformats.org/officeDocument/2006/relationships" xmlns:p="http://schemas.openxmlformats.org/presentationml/2006/main">
   <p:cSld>
     <p:spTree>
@@ -29898,7 +29900,7 @@
           <a:p>
             <a:fld id="{548469FB-C78A-B94B-B04A-B5BC8C934F85}" type="slidenum">
               <a:rPr lang="en-US" smtClean="0"/>
-              <a:t>32</a:t>
+              <a:t>33</a:t>
             </a:fld>
             <a:endParaRPr lang="en-US"/>
           </a:p>
@@ -30355,7 +30357,7 @@
 </p:sld>
 </file>
 
-<file path=ppt/slides/slide33.xml><?xml version="1.0" encoding="utf-8"?>
+<file path=ppt/slides/slide34.xml><?xml version="1.0" encoding="utf-8"?>
 <p:sld xmlns:a="http://schemas.openxmlformats.org/drawingml/2006/main" xmlns:r="http://schemas.openxmlformats.org/officeDocument/2006/relationships" xmlns:p="http://schemas.openxmlformats.org/presentationml/2006/main">
   <p:cSld>
     <p:spTree>
@@ -30525,7 +30527,7 @@
           <a:p>
             <a:fld id="{548469FB-C78A-B94B-B04A-B5BC8C934F85}" type="slidenum">
               <a:rPr lang="en-US" smtClean="0"/>
-              <a:t>33</a:t>
+              <a:t>34</a:t>
             </a:fld>
             <a:endParaRPr lang="en-US"/>
           </a:p>
@@ -30788,7 +30790,7 @@
 </p:sld>
 </file>
 
-<file path=ppt/slides/slide34.xml><?xml version="1.0" encoding="utf-8"?>
+<file path=ppt/slides/slide35.xml><?xml version="1.0" encoding="utf-8"?>
 <p:sld xmlns:a="http://schemas.openxmlformats.org/drawingml/2006/main" xmlns:r="http://schemas.openxmlformats.org/officeDocument/2006/relationships" xmlns:p="http://schemas.openxmlformats.org/presentationml/2006/main">
   <p:cSld>
     <p:spTree>
@@ -30898,7 +30900,7 @@
 </p:sld>
 </file>
 
-<file path=ppt/slides/slide35.xml><?xml version="1.0" encoding="utf-8"?>
+<file path=ppt/slides/slide36.xml><?xml version="1.0" encoding="utf-8"?>
 <p:sld xmlns:a="http://schemas.openxmlformats.org/drawingml/2006/main" xmlns:r="http://schemas.openxmlformats.org/officeDocument/2006/relationships" xmlns:p="http://schemas.openxmlformats.org/presentationml/2006/main">
   <p:cSld>
     <p:spTree>
@@ -31161,7 +31163,7 @@
           <a:p>
             <a:fld id="{548469FB-C78A-B94B-B04A-B5BC8C934F85}" type="slidenum">
               <a:rPr lang="en-US" smtClean="0"/>
-              <a:t>35</a:t>
+              <a:t>36</a:t>
             </a:fld>
             <a:endParaRPr lang="en-US"/>
           </a:p>
@@ -31624,7 +31626,7 @@
 </p:sld>
 </file>
 
-<file path=ppt/slides/slide36.xml><?xml version="1.0" encoding="utf-8"?>
+<file path=ppt/slides/slide37.xml><?xml version="1.0" encoding="utf-8"?>
 <p:sld xmlns:a="http://schemas.openxmlformats.org/drawingml/2006/main" xmlns:r="http://schemas.openxmlformats.org/officeDocument/2006/relationships" xmlns:p="http://schemas.openxmlformats.org/presentationml/2006/main">
   <p:cSld>
     <p:spTree>
@@ -31866,7 +31868,7 @@
           <a:p>
             <a:fld id="{548469FB-C78A-B94B-B04A-B5BC8C934F85}" type="slidenum">
               <a:rPr lang="en-US" smtClean="0"/>
-              <a:t>36</a:t>
+              <a:t>37</a:t>
             </a:fld>
             <a:endParaRPr lang="en-US"/>
           </a:p>
@@ -31885,7 +31887,7 @@
 </p:sld>
 </file>
 
-<file path=ppt/slides/slide37.xml><?xml version="1.0" encoding="utf-8"?>
+<file path=ppt/slides/slide38.xml><?xml version="1.0" encoding="utf-8"?>
 <p:sld xmlns:a="http://schemas.openxmlformats.org/drawingml/2006/main" xmlns:r="http://schemas.openxmlformats.org/officeDocument/2006/relationships" xmlns:p="http://schemas.openxmlformats.org/presentationml/2006/main">
   <p:cSld>
     <p:spTree>
@@ -32127,7 +32129,7 @@
           <a:p>
             <a:fld id="{548469FB-C78A-B94B-B04A-B5BC8C934F85}" type="slidenum">
               <a:rPr lang="en-US" smtClean="0"/>
-              <a:t>37</a:t>
+              <a:t>38</a:t>
             </a:fld>
             <a:endParaRPr lang="en-US"/>
           </a:p>
@@ -32146,7 +32148,7 @@
 </p:sld>
 </file>
 
-<file path=ppt/slides/slide38.xml><?xml version="1.0" encoding="utf-8"?>
+<file path=ppt/slides/slide39.xml><?xml version="1.0" encoding="utf-8"?>
 <p:sld xmlns:a="http://schemas.openxmlformats.org/drawingml/2006/main" xmlns:r="http://schemas.openxmlformats.org/officeDocument/2006/relationships" xmlns:p="http://schemas.openxmlformats.org/presentationml/2006/main">
   <p:cSld>
     <p:spTree>
@@ -32227,7 +32229,7 @@
           <a:p>
             <a:fld id="{548469FB-C78A-B94B-B04A-B5BC8C934F85}" type="slidenum">
               <a:rPr lang="en-US" smtClean="0"/>
-              <a:t>38</a:t>
+              <a:t>39</a:t>
             </a:fld>
             <a:endParaRPr lang="en-US"/>
           </a:p>
@@ -32282,7 +32284,215 @@
 </p:sld>
 </file>
 
-<file path=ppt/slides/slide39.xml><?xml version="1.0" encoding="utf-8"?>
+<file path=ppt/slides/slide4.xml><?xml version="1.0" encoding="utf-8"?>
+<p:sld xmlns:a="http://schemas.openxmlformats.org/drawingml/2006/main" xmlns:r="http://schemas.openxmlformats.org/officeDocument/2006/relationships" xmlns:p="http://schemas.openxmlformats.org/presentationml/2006/main">
+  <p:cSld>
+    <p:spTree>
+      <p:nvGrpSpPr>
+        <p:cNvPr id="1" name="">
+          <a:extLst>
+            <a:ext uri="{FF2B5EF4-FFF2-40B4-BE49-F238E27FC236}">
+              <a16:creationId xmlns:a16="http://schemas.microsoft.com/office/drawing/2014/main" id="{138904E8-FE71-7102-7561-05F046E7A718}"/>
+            </a:ext>
+          </a:extLst>
+        </p:cNvPr>
+        <p:cNvGrpSpPr/>
+        <p:nvPr/>
+      </p:nvGrpSpPr>
+      <p:grpSpPr>
+        <a:xfrm>
+          <a:off x="0" y="0"/>
+          <a:ext cx="0" cy="0"/>
+          <a:chOff x="0" y="0"/>
+          <a:chExt cx="0" cy="0"/>
+        </a:xfrm>
+      </p:grpSpPr>
+      <p:sp>
+        <p:nvSpPr>
+          <p:cNvPr id="2" name="Picture Placeholder 1">
+            <a:extLst>
+              <a:ext uri="{FF2B5EF4-FFF2-40B4-BE49-F238E27FC236}">
+                <a16:creationId xmlns:a16="http://schemas.microsoft.com/office/drawing/2014/main" id="{4FB4190B-27CA-E911-E62B-858FB9E062DC}"/>
+              </a:ext>
+            </a:extLst>
+          </p:cNvPr>
+          <p:cNvSpPr>
+            <a:spLocks noGrp="1"/>
+          </p:cNvSpPr>
+          <p:nvPr>
+            <p:ph type="pic" sz="quarter" idx="12"/>
+          </p:nvPr>
+        </p:nvSpPr>
+        <p:spPr>
+          <a:xfrm>
+            <a:off x="5181600" y="1422651"/>
+            <a:ext cx="6628457" cy="5435349"/>
+          </a:xfrm>
+        </p:spPr>
+        <p:txBody>
+          <a:bodyPr>
+            <a:normAutofit/>
+          </a:bodyPr>
+          <a:lstStyle/>
+          <a:p>
+            <a:r>
+              <a:rPr lang="en-US" sz="2000" dirty="0">
+                <a:latin typeface="Avenir Book" panose="02000503020000020003" pitchFamily="2" charset="0"/>
+              </a:rPr>
+              <a:t>Learning objectives</a:t>
+            </a:r>
+          </a:p>
+          <a:p>
+            <a:endParaRPr lang="en-US" sz="2000" dirty="0">
+              <a:latin typeface="Avenir Book" panose="02000503020000020003" pitchFamily="2" charset="0"/>
+            </a:endParaRPr>
+          </a:p>
+          <a:p>
+            <a:r>
+              <a:rPr lang="en-US" sz="2000" dirty="0">
+                <a:latin typeface="Avenir Book" panose="02000503020000020003" pitchFamily="2" charset="0"/>
+              </a:rPr>
+              <a:t>About All of US</a:t>
+            </a:r>
+          </a:p>
+          <a:p>
+            <a:endParaRPr lang="en-US" sz="2000" dirty="0">
+              <a:latin typeface="Avenir Book" panose="02000503020000020003" pitchFamily="2" charset="0"/>
+            </a:endParaRPr>
+          </a:p>
+          <a:p>
+            <a:r>
+              <a:rPr lang="en-US" sz="2000" dirty="0">
+                <a:latin typeface="Avenir Book" panose="02000503020000020003" pitchFamily="2" charset="0"/>
+              </a:rPr>
+              <a:t>Data sources</a:t>
+            </a:r>
+          </a:p>
+          <a:p>
+            <a:endParaRPr lang="en-US" sz="2000" dirty="0">
+              <a:latin typeface="Avenir Book" panose="02000503020000020003" pitchFamily="2" charset="0"/>
+            </a:endParaRPr>
+          </a:p>
+          <a:p>
+            <a:r>
+              <a:rPr lang="en-US" sz="2000" dirty="0">
+                <a:latin typeface="Avenir Book" panose="02000503020000020003" pitchFamily="2" charset="0"/>
+              </a:rPr>
+              <a:t>Accessing data</a:t>
+            </a:r>
+          </a:p>
+          <a:p>
+            <a:endParaRPr lang="en-US" sz="2000" dirty="0">
+              <a:latin typeface="Avenir Book" panose="02000503020000020003" pitchFamily="2" charset="0"/>
+            </a:endParaRPr>
+          </a:p>
+          <a:p>
+            <a:r>
+              <a:rPr lang="en-US" sz="2000" dirty="0">
+                <a:latin typeface="Avenir Book" panose="02000503020000020003" pitchFamily="2" charset="0"/>
+              </a:rPr>
+              <a:t>Analyzing data</a:t>
+            </a:r>
+          </a:p>
+          <a:p>
+            <a:endParaRPr lang="en-US" sz="2000" dirty="0">
+              <a:latin typeface="Avenir Book" panose="02000503020000020003" pitchFamily="2" charset="0"/>
+            </a:endParaRPr>
+          </a:p>
+          <a:p>
+            <a:r>
+              <a:rPr lang="en-US" sz="2000" dirty="0">
+                <a:latin typeface="Avenir Book" panose="02000503020000020003" pitchFamily="2" charset="0"/>
+              </a:rPr>
+              <a:t>Create an All of Us account and Workspace </a:t>
+            </a:r>
+          </a:p>
+          <a:p>
+            <a:endParaRPr lang="en-US" sz="1400" dirty="0">
+              <a:latin typeface="Avenir Book" panose="02000503020000020003" pitchFamily="2" charset="0"/>
+            </a:endParaRPr>
+          </a:p>
+        </p:txBody>
+      </p:sp>
+      <p:sp>
+        <p:nvSpPr>
+          <p:cNvPr id="3" name="Text Placeholder 2">
+            <a:extLst>
+              <a:ext uri="{FF2B5EF4-FFF2-40B4-BE49-F238E27FC236}">
+                <a16:creationId xmlns:a16="http://schemas.microsoft.com/office/drawing/2014/main" id="{1857C7A0-5DE4-540F-C3DA-F3A1D0A8FDF2}"/>
+              </a:ext>
+            </a:extLst>
+          </p:cNvPr>
+          <p:cNvSpPr>
+            <a:spLocks noGrp="1"/>
+          </p:cNvSpPr>
+          <p:nvPr>
+            <p:ph type="body" sz="quarter" idx="11"/>
+          </p:nvPr>
+        </p:nvSpPr>
+        <p:spPr>
+          <a:xfrm>
+            <a:off x="458143" y="3143633"/>
+            <a:ext cx="3034570" cy="722197"/>
+          </a:xfrm>
+        </p:spPr>
+        <p:txBody>
+          <a:bodyPr/>
+          <a:lstStyle/>
+          <a:p>
+            <a:pPr algn="ctr"/>
+            <a:r>
+              <a:rPr lang="en-US" dirty="0">
+                <a:latin typeface="YaleNew" panose="02000602050000020003" pitchFamily="2" charset="77"/>
+              </a:rPr>
+              <a:t>Agenda</a:t>
+            </a:r>
+          </a:p>
+        </p:txBody>
+      </p:sp>
+      <p:sp>
+        <p:nvSpPr>
+          <p:cNvPr id="6" name="Slide Number Placeholder 5">
+            <a:extLst>
+              <a:ext uri="{FF2B5EF4-FFF2-40B4-BE49-F238E27FC236}">
+                <a16:creationId xmlns:a16="http://schemas.microsoft.com/office/drawing/2014/main" id="{ED04705E-0536-8195-659A-45C71DEAB971}"/>
+              </a:ext>
+            </a:extLst>
+          </p:cNvPr>
+          <p:cNvSpPr>
+            <a:spLocks noGrp="1"/>
+          </p:cNvSpPr>
+          <p:nvPr>
+            <p:ph type="sldNum" sz="quarter" idx="18"/>
+          </p:nvPr>
+        </p:nvSpPr>
+        <p:spPr/>
+        <p:txBody>
+          <a:bodyPr/>
+          <a:lstStyle/>
+          <a:p>
+            <a:fld id="{548469FB-C78A-B94B-B04A-B5BC8C934F85}" type="slidenum">
+              <a:rPr lang="en-US" smtClean="0"/>
+              <a:t>4</a:t>
+            </a:fld>
+            <a:endParaRPr lang="en-US"/>
+          </a:p>
+        </p:txBody>
+      </p:sp>
+    </p:spTree>
+    <p:extLst>
+      <p:ext uri="{BB962C8B-B14F-4D97-AF65-F5344CB8AC3E}">
+        <p14:creationId xmlns:p14="http://schemas.microsoft.com/office/powerpoint/2010/main" val="2450962014"/>
+      </p:ext>
+    </p:extLst>
+  </p:cSld>
+  <p:clrMapOvr>
+    <a:masterClrMapping/>
+  </p:clrMapOvr>
+</p:sld>
+</file>
+
+<file path=ppt/slides/slide40.xml><?xml version="1.0" encoding="utf-8"?>
 <p:sld xmlns:a="http://schemas.openxmlformats.org/drawingml/2006/main" xmlns:r="http://schemas.openxmlformats.org/officeDocument/2006/relationships" xmlns:p="http://schemas.openxmlformats.org/presentationml/2006/main">
   <p:cSld>
     <p:spTree>
@@ -32396,7 +32606,7 @@
           <a:p>
             <a:fld id="{548469FB-C78A-B94B-B04A-B5BC8C934F85}" type="slidenum">
               <a:rPr lang="en-US" smtClean="0"/>
-              <a:t>39</a:t>
+              <a:t>40</a:t>
             </a:fld>
             <a:endParaRPr lang="en-US"/>
           </a:p>
@@ -32478,214 +32688,6 @@
     <p:extLst>
       <p:ext uri="{BB962C8B-B14F-4D97-AF65-F5344CB8AC3E}">
         <p14:creationId xmlns:p14="http://schemas.microsoft.com/office/powerpoint/2010/main" val="3292860451"/>
-      </p:ext>
-    </p:extLst>
-  </p:cSld>
-  <p:clrMapOvr>
-    <a:masterClrMapping/>
-  </p:clrMapOvr>
-</p:sld>
-</file>
-
-<file path=ppt/slides/slide4.xml><?xml version="1.0" encoding="utf-8"?>
-<p:sld xmlns:a="http://schemas.openxmlformats.org/drawingml/2006/main" xmlns:r="http://schemas.openxmlformats.org/officeDocument/2006/relationships" xmlns:p="http://schemas.openxmlformats.org/presentationml/2006/main">
-  <p:cSld>
-    <p:spTree>
-      <p:nvGrpSpPr>
-        <p:cNvPr id="1" name="">
-          <a:extLst>
-            <a:ext uri="{FF2B5EF4-FFF2-40B4-BE49-F238E27FC236}">
-              <a16:creationId xmlns:a16="http://schemas.microsoft.com/office/drawing/2014/main" id="{138904E8-FE71-7102-7561-05F046E7A718}"/>
-            </a:ext>
-          </a:extLst>
-        </p:cNvPr>
-        <p:cNvGrpSpPr/>
-        <p:nvPr/>
-      </p:nvGrpSpPr>
-      <p:grpSpPr>
-        <a:xfrm>
-          <a:off x="0" y="0"/>
-          <a:ext cx="0" cy="0"/>
-          <a:chOff x="0" y="0"/>
-          <a:chExt cx="0" cy="0"/>
-        </a:xfrm>
-      </p:grpSpPr>
-      <p:sp>
-        <p:nvSpPr>
-          <p:cNvPr id="2" name="Picture Placeholder 1">
-            <a:extLst>
-              <a:ext uri="{FF2B5EF4-FFF2-40B4-BE49-F238E27FC236}">
-                <a16:creationId xmlns:a16="http://schemas.microsoft.com/office/drawing/2014/main" id="{4FB4190B-27CA-E911-E62B-858FB9E062DC}"/>
-              </a:ext>
-            </a:extLst>
-          </p:cNvPr>
-          <p:cNvSpPr>
-            <a:spLocks noGrp="1"/>
-          </p:cNvSpPr>
-          <p:nvPr>
-            <p:ph type="pic" sz="quarter" idx="12"/>
-          </p:nvPr>
-        </p:nvSpPr>
-        <p:spPr>
-          <a:xfrm>
-            <a:off x="5181600" y="1422651"/>
-            <a:ext cx="6628457" cy="5435349"/>
-          </a:xfrm>
-        </p:spPr>
-        <p:txBody>
-          <a:bodyPr>
-            <a:normAutofit/>
-          </a:bodyPr>
-          <a:lstStyle/>
-          <a:p>
-            <a:r>
-              <a:rPr lang="en-US" sz="2000" dirty="0">
-                <a:latin typeface="Avenir Book" panose="02000503020000020003" pitchFamily="2" charset="0"/>
-              </a:rPr>
-              <a:t>Learning objectives</a:t>
-            </a:r>
-          </a:p>
-          <a:p>
-            <a:endParaRPr lang="en-US" sz="2000" dirty="0">
-              <a:latin typeface="Avenir Book" panose="02000503020000020003" pitchFamily="2" charset="0"/>
-            </a:endParaRPr>
-          </a:p>
-          <a:p>
-            <a:r>
-              <a:rPr lang="en-US" sz="2000" dirty="0">
-                <a:latin typeface="Avenir Book" panose="02000503020000020003" pitchFamily="2" charset="0"/>
-              </a:rPr>
-              <a:t>About All of US</a:t>
-            </a:r>
-          </a:p>
-          <a:p>
-            <a:endParaRPr lang="en-US" sz="2000" dirty="0">
-              <a:latin typeface="Avenir Book" panose="02000503020000020003" pitchFamily="2" charset="0"/>
-            </a:endParaRPr>
-          </a:p>
-          <a:p>
-            <a:r>
-              <a:rPr lang="en-US" sz="2000" dirty="0">
-                <a:latin typeface="Avenir Book" panose="02000503020000020003" pitchFamily="2" charset="0"/>
-              </a:rPr>
-              <a:t>Data sources</a:t>
-            </a:r>
-          </a:p>
-          <a:p>
-            <a:endParaRPr lang="en-US" sz="2000" dirty="0">
-              <a:latin typeface="Avenir Book" panose="02000503020000020003" pitchFamily="2" charset="0"/>
-            </a:endParaRPr>
-          </a:p>
-          <a:p>
-            <a:r>
-              <a:rPr lang="en-US" sz="2000" dirty="0">
-                <a:latin typeface="Avenir Book" panose="02000503020000020003" pitchFamily="2" charset="0"/>
-              </a:rPr>
-              <a:t>Accessing data</a:t>
-            </a:r>
-          </a:p>
-          <a:p>
-            <a:endParaRPr lang="en-US" sz="2000" dirty="0">
-              <a:latin typeface="Avenir Book" panose="02000503020000020003" pitchFamily="2" charset="0"/>
-            </a:endParaRPr>
-          </a:p>
-          <a:p>
-            <a:r>
-              <a:rPr lang="en-US" sz="2000" dirty="0">
-                <a:latin typeface="Avenir Book" panose="02000503020000020003" pitchFamily="2" charset="0"/>
-              </a:rPr>
-              <a:t>Analyzing data</a:t>
-            </a:r>
-          </a:p>
-          <a:p>
-            <a:endParaRPr lang="en-US" sz="2000" dirty="0">
-              <a:latin typeface="Avenir Book" panose="02000503020000020003" pitchFamily="2" charset="0"/>
-            </a:endParaRPr>
-          </a:p>
-          <a:p>
-            <a:r>
-              <a:rPr lang="en-US" sz="2000" dirty="0">
-                <a:latin typeface="Avenir Book" panose="02000503020000020003" pitchFamily="2" charset="0"/>
-              </a:rPr>
-              <a:t>Create an All of Us account and Workspace </a:t>
-            </a:r>
-          </a:p>
-          <a:p>
-            <a:endParaRPr lang="en-US" sz="1400" dirty="0">
-              <a:latin typeface="Avenir Book" panose="02000503020000020003" pitchFamily="2" charset="0"/>
-            </a:endParaRPr>
-          </a:p>
-        </p:txBody>
-      </p:sp>
-      <p:sp>
-        <p:nvSpPr>
-          <p:cNvPr id="3" name="Text Placeholder 2">
-            <a:extLst>
-              <a:ext uri="{FF2B5EF4-FFF2-40B4-BE49-F238E27FC236}">
-                <a16:creationId xmlns:a16="http://schemas.microsoft.com/office/drawing/2014/main" id="{1857C7A0-5DE4-540F-C3DA-F3A1D0A8FDF2}"/>
-              </a:ext>
-            </a:extLst>
-          </p:cNvPr>
-          <p:cNvSpPr>
-            <a:spLocks noGrp="1"/>
-          </p:cNvSpPr>
-          <p:nvPr>
-            <p:ph type="body" sz="quarter" idx="11"/>
-          </p:nvPr>
-        </p:nvSpPr>
-        <p:spPr>
-          <a:xfrm>
-            <a:off x="458143" y="3143633"/>
-            <a:ext cx="3034570" cy="722197"/>
-          </a:xfrm>
-        </p:spPr>
-        <p:txBody>
-          <a:bodyPr/>
-          <a:lstStyle/>
-          <a:p>
-            <a:pPr algn="ctr"/>
-            <a:r>
-              <a:rPr lang="en-US" dirty="0">
-                <a:latin typeface="YaleNew" panose="02000602050000020003" pitchFamily="2" charset="77"/>
-              </a:rPr>
-              <a:t>Agenda</a:t>
-            </a:r>
-          </a:p>
-        </p:txBody>
-      </p:sp>
-      <p:sp>
-        <p:nvSpPr>
-          <p:cNvPr id="6" name="Slide Number Placeholder 5">
-            <a:extLst>
-              <a:ext uri="{FF2B5EF4-FFF2-40B4-BE49-F238E27FC236}">
-                <a16:creationId xmlns:a16="http://schemas.microsoft.com/office/drawing/2014/main" id="{ED04705E-0536-8195-659A-45C71DEAB971}"/>
-              </a:ext>
-            </a:extLst>
-          </p:cNvPr>
-          <p:cNvSpPr>
-            <a:spLocks noGrp="1"/>
-          </p:cNvSpPr>
-          <p:nvPr>
-            <p:ph type="sldNum" sz="quarter" idx="18"/>
-          </p:nvPr>
-        </p:nvSpPr>
-        <p:spPr/>
-        <p:txBody>
-          <a:bodyPr/>
-          <a:lstStyle/>
-          <a:p>
-            <a:fld id="{548469FB-C78A-B94B-B04A-B5BC8C934F85}" type="slidenum">
-              <a:rPr lang="en-US" smtClean="0"/>
-              <a:t>4</a:t>
-            </a:fld>
-            <a:endParaRPr lang="en-US"/>
-          </a:p>
-        </p:txBody>
-      </p:sp>
-    </p:spTree>
-    <p:extLst>
-      <p:ext uri="{BB962C8B-B14F-4D97-AF65-F5344CB8AC3E}">
-        <p14:creationId xmlns:p14="http://schemas.microsoft.com/office/powerpoint/2010/main" val="2450962014"/>
       </p:ext>
     </p:extLst>
   </p:cSld>

</xml_diff>

<commit_message>
updated Session 2 code and presentation
</commit_message>
<xml_diff>
--- a/Session 1/Intro to All of Us.pptx
+++ b/Session 1/Intro to All of Us.pptx
@@ -5,7 +5,7 @@
     <p:sldMasterId id="2147483648" r:id="rId1"/>
   </p:sldMasterIdLst>
   <p:notesMasterIdLst>
-    <p:notesMasterId r:id="rId42"/>
+    <p:notesMasterId r:id="rId43"/>
   </p:notesMasterIdLst>
   <p:sldIdLst>
     <p:sldId id="262" r:id="rId2"/>
@@ -25,29 +25,30 @@
     <p:sldId id="412" r:id="rId16"/>
     <p:sldId id="408" r:id="rId17"/>
     <p:sldId id="409" r:id="rId18"/>
-    <p:sldId id="410" r:id="rId19"/>
-    <p:sldId id="416" r:id="rId20"/>
-    <p:sldId id="403" r:id="rId21"/>
-    <p:sldId id="366" r:id="rId22"/>
-    <p:sldId id="404" r:id="rId23"/>
-    <p:sldId id="367" r:id="rId24"/>
-    <p:sldId id="368" r:id="rId25"/>
-    <p:sldId id="369" r:id="rId26"/>
-    <p:sldId id="370" r:id="rId27"/>
-    <p:sldId id="268" r:id="rId28"/>
-    <p:sldId id="407" r:id="rId29"/>
-    <p:sldId id="415" r:id="rId30"/>
-    <p:sldId id="401" r:id="rId31"/>
-    <p:sldId id="400" r:id="rId32"/>
-    <p:sldId id="402" r:id="rId33"/>
-    <p:sldId id="371" r:id="rId34"/>
-    <p:sldId id="373" r:id="rId35"/>
-    <p:sldId id="406" r:id="rId36"/>
-    <p:sldId id="374" r:id="rId37"/>
-    <p:sldId id="375" r:id="rId38"/>
-    <p:sldId id="376" r:id="rId39"/>
-    <p:sldId id="378" r:id="rId40"/>
-    <p:sldId id="414" r:id="rId41"/>
+    <p:sldId id="417" r:id="rId19"/>
+    <p:sldId id="410" r:id="rId20"/>
+    <p:sldId id="416" r:id="rId21"/>
+    <p:sldId id="403" r:id="rId22"/>
+    <p:sldId id="366" r:id="rId23"/>
+    <p:sldId id="404" r:id="rId24"/>
+    <p:sldId id="367" r:id="rId25"/>
+    <p:sldId id="368" r:id="rId26"/>
+    <p:sldId id="369" r:id="rId27"/>
+    <p:sldId id="370" r:id="rId28"/>
+    <p:sldId id="268" r:id="rId29"/>
+    <p:sldId id="407" r:id="rId30"/>
+    <p:sldId id="415" r:id="rId31"/>
+    <p:sldId id="401" r:id="rId32"/>
+    <p:sldId id="400" r:id="rId33"/>
+    <p:sldId id="402" r:id="rId34"/>
+    <p:sldId id="371" r:id="rId35"/>
+    <p:sldId id="373" r:id="rId36"/>
+    <p:sldId id="406" r:id="rId37"/>
+    <p:sldId id="374" r:id="rId38"/>
+    <p:sldId id="375" r:id="rId39"/>
+    <p:sldId id="376" r:id="rId40"/>
+    <p:sldId id="378" r:id="rId41"/>
+    <p:sldId id="414" r:id="rId42"/>
   </p:sldIdLst>
   <p:sldSz cx="12192000" cy="6858000"/>
   <p:notesSz cx="6858000" cy="9144000"/>
@@ -178,7 +179,7 @@
 <file path=ppt/revisionInfo.xml><?xml version="1.0" encoding="utf-8"?>
 <p1510:revInfo xmlns:a="http://schemas.openxmlformats.org/drawingml/2006/main" xmlns:r="http://schemas.openxmlformats.org/officeDocument/2006/relationships" xmlns:p1510="http://schemas.microsoft.com/office/powerpoint/2015/10/main">
   <p1510:revLst>
-    <p1510:client id="{0A4A6351-75C9-6B47-B7E1-DE14CDAAC0D7}" v="17" dt="2026-01-29T20:46:02.260"/>
+    <p1510:client id="{0A4A6351-75C9-6B47-B7E1-DE14CDAAC0D7}" v="25" dt="2026-02-16T17:18:12.471"/>
   </p1510:revLst>
 </p1510:revInfo>
 </file>
@@ -188,7 +189,7 @@
   <pc:docChgLst>
     <pc:chgData name="Wegener, Maximilian" userId="00319a47-5df7-4a7f-b5fd-8c1aef3f7443" providerId="ADAL" clId="{CF2CAE99-D8F5-51A4-A68C-79C1C32033F6}"/>
     <pc:docChg chg="undo custSel addSld delSld modSld sldOrd">
-      <pc:chgData name="Wegener, Maximilian" userId="00319a47-5df7-4a7f-b5fd-8c1aef3f7443" providerId="ADAL" clId="{CF2CAE99-D8F5-51A4-A68C-79C1C32033F6}" dt="2026-01-29T20:46:44.865" v="3199" actId="20577"/>
+      <pc:chgData name="Wegener, Maximilian" userId="00319a47-5df7-4a7f-b5fd-8c1aef3f7443" providerId="ADAL" clId="{CF2CAE99-D8F5-51A4-A68C-79C1C32033F6}" dt="2026-02-16T17:18:17.063" v="3629" actId="20577"/>
       <pc:docMkLst>
         <pc:docMk/>
       </pc:docMkLst>
@@ -199,65 +200,18 @@
           <pc:sldMk cId="2367016627" sldId="368"/>
         </pc:sldMkLst>
       </pc:sldChg>
-      <pc:sldChg chg="addSp modSp add del mod ord modNotes">
-        <pc:chgData name="Wegener, Maximilian" userId="00319a47-5df7-4a7f-b5fd-8c1aef3f7443" providerId="ADAL" clId="{CF2CAE99-D8F5-51A4-A68C-79C1C32033F6}" dt="2026-01-29T20:33:00.945" v="2555" actId="2696"/>
-        <pc:sldMkLst>
-          <pc:docMk/>
-          <pc:sldMk cId="17989362" sldId="416"/>
-        </pc:sldMkLst>
-        <pc:picChg chg="add mod">
-          <ac:chgData name="Wegener, Maximilian" userId="00319a47-5df7-4a7f-b5fd-8c1aef3f7443" providerId="ADAL" clId="{CF2CAE99-D8F5-51A4-A68C-79C1C32033F6}" dt="2026-01-29T20:31:08.330" v="2552"/>
-          <ac:picMkLst>
-            <pc:docMk/>
-            <pc:sldMk cId="17989362" sldId="416"/>
-            <ac:picMk id="5" creationId="{11A872DC-26C7-6BE8-4901-11FB4E2E37EA}"/>
-          </ac:picMkLst>
-        </pc:picChg>
-      </pc:sldChg>
       <pc:sldChg chg="addSp delSp modSp new mod">
         <pc:chgData name="Wegener, Maximilian" userId="00319a47-5df7-4a7f-b5fd-8c1aef3f7443" providerId="ADAL" clId="{CF2CAE99-D8F5-51A4-A68C-79C1C32033F6}" dt="2026-01-29T20:40:35.410" v="2992" actId="20577"/>
         <pc:sldMkLst>
           <pc:docMk/>
           <pc:sldMk cId="1265380304" sldId="416"/>
         </pc:sldMkLst>
-        <pc:spChg chg="del">
-          <ac:chgData name="Wegener, Maximilian" userId="00319a47-5df7-4a7f-b5fd-8c1aef3f7443" providerId="ADAL" clId="{CF2CAE99-D8F5-51A4-A68C-79C1C32033F6}" dt="2026-01-29T20:34:42.914" v="2583" actId="478"/>
-          <ac:spMkLst>
-            <pc:docMk/>
-            <pc:sldMk cId="1265380304" sldId="416"/>
-            <ac:spMk id="2" creationId="{33EF2F05-2899-DF03-44E6-8D897B8E91AE}"/>
-          </ac:spMkLst>
-        </pc:spChg>
         <pc:spChg chg="mod">
           <ac:chgData name="Wegener, Maximilian" userId="00319a47-5df7-4a7f-b5fd-8c1aef3f7443" providerId="ADAL" clId="{CF2CAE99-D8F5-51A4-A68C-79C1C32033F6}" dt="2026-01-29T20:34:36.658" v="2581" actId="20577"/>
           <ac:spMkLst>
             <pc:docMk/>
             <pc:sldMk cId="1265380304" sldId="416"/>
             <ac:spMk id="3" creationId="{DB15BF82-222D-4F21-FC15-F9270DA65858}"/>
-          </ac:spMkLst>
-        </pc:spChg>
-        <pc:spChg chg="del">
-          <ac:chgData name="Wegener, Maximilian" userId="00319a47-5df7-4a7f-b5fd-8c1aef3f7443" providerId="ADAL" clId="{CF2CAE99-D8F5-51A4-A68C-79C1C32033F6}" dt="2026-01-29T20:34:38.972" v="2582" actId="478"/>
-          <ac:spMkLst>
-            <pc:docMk/>
-            <pc:sldMk cId="1265380304" sldId="416"/>
-            <ac:spMk id="4" creationId="{5AC895C3-3862-23E2-67EB-C96054C88E19}"/>
-          </ac:spMkLst>
-        </pc:spChg>
-        <pc:spChg chg="add del mod">
-          <ac:chgData name="Wegener, Maximilian" userId="00319a47-5df7-4a7f-b5fd-8c1aef3f7443" providerId="ADAL" clId="{CF2CAE99-D8F5-51A4-A68C-79C1C32033F6}" dt="2026-01-29T20:36:02.220" v="2589"/>
-          <ac:spMkLst>
-            <pc:docMk/>
-            <pc:sldMk cId="1265380304" sldId="416"/>
-            <ac:spMk id="6" creationId="{7C4A95BA-5B18-3310-5FA8-979D17F7A5A3}"/>
-          </ac:spMkLst>
-        </pc:spChg>
-        <pc:spChg chg="add del mod">
-          <ac:chgData name="Wegener, Maximilian" userId="00319a47-5df7-4a7f-b5fd-8c1aef3f7443" providerId="ADAL" clId="{CF2CAE99-D8F5-51A4-A68C-79C1C32033F6}" dt="2026-01-29T20:35:57.693" v="2587"/>
-          <ac:spMkLst>
-            <pc:docMk/>
-            <pc:sldMk cId="1265380304" sldId="416"/>
-            <ac:spMk id="7" creationId="{A885BDA9-A911-4D0E-0DD4-BFFF3E868C1E}"/>
           </ac:spMkLst>
         </pc:spChg>
         <pc:spChg chg="add mod">
@@ -274,6 +228,45 @@
             <pc:docMk/>
             <pc:sldMk cId="1265380304" sldId="416"/>
             <ac:spMk id="9" creationId="{05D4A543-36A2-AAFD-BF06-E8BDCAA00048}"/>
+          </ac:spMkLst>
+        </pc:spChg>
+      </pc:sldChg>
+      <pc:sldChg chg="addSp delSp modSp new mod">
+        <pc:chgData name="Wegener, Maximilian" userId="00319a47-5df7-4a7f-b5fd-8c1aef3f7443" providerId="ADAL" clId="{CF2CAE99-D8F5-51A4-A68C-79C1C32033F6}" dt="2026-02-16T17:18:17.063" v="3629" actId="20577"/>
+        <pc:sldMkLst>
+          <pc:docMk/>
+          <pc:sldMk cId="872780695" sldId="417"/>
+        </pc:sldMkLst>
+        <pc:spChg chg="del mod">
+          <ac:chgData name="Wegener, Maximilian" userId="00319a47-5df7-4a7f-b5fd-8c1aef3f7443" providerId="ADAL" clId="{CF2CAE99-D8F5-51A4-A68C-79C1C32033F6}" dt="2026-02-16T17:11:18.567" v="3251" actId="478"/>
+          <ac:spMkLst>
+            <pc:docMk/>
+            <pc:sldMk cId="872780695" sldId="417"/>
+            <ac:spMk id="2" creationId="{2DB985FF-5E7F-1CC9-B022-EC3E433F76F5}"/>
+          </ac:spMkLst>
+        </pc:spChg>
+        <pc:spChg chg="mod">
+          <ac:chgData name="Wegener, Maximilian" userId="00319a47-5df7-4a7f-b5fd-8c1aef3f7443" providerId="ADAL" clId="{CF2CAE99-D8F5-51A4-A68C-79C1C32033F6}" dt="2026-02-16T17:10:19.568" v="3205" actId="20577"/>
+          <ac:spMkLst>
+            <pc:docMk/>
+            <pc:sldMk cId="872780695" sldId="417"/>
+            <ac:spMk id="3" creationId="{8B5B5BBF-52D1-6895-6701-FCA84A38DA35}"/>
+          </ac:spMkLst>
+        </pc:spChg>
+        <pc:spChg chg="mod">
+          <ac:chgData name="Wegener, Maximilian" userId="00319a47-5df7-4a7f-b5fd-8c1aef3f7443" providerId="ADAL" clId="{CF2CAE99-D8F5-51A4-A68C-79C1C32033F6}" dt="2026-02-16T17:10:59.739" v="3233" actId="20577"/>
+          <ac:spMkLst>
+            <pc:docMk/>
+            <pc:sldMk cId="872780695" sldId="417"/>
+            <ac:spMk id="4" creationId="{DBCBC422-140D-ECB5-02EA-207AF2C534EA}"/>
+          </ac:spMkLst>
+        </pc:spChg>
+        <pc:spChg chg="add mod">
+          <ac:chgData name="Wegener, Maximilian" userId="00319a47-5df7-4a7f-b5fd-8c1aef3f7443" providerId="ADAL" clId="{CF2CAE99-D8F5-51A4-A68C-79C1C32033F6}" dt="2026-02-16T17:18:17.063" v="3629" actId="20577"/>
+          <ac:spMkLst>
+            <pc:docMk/>
+            <pc:sldMk cId="872780695" sldId="417"/>
+            <ac:spMk id="6" creationId="{0F5BD5C5-B894-1DE1-D326-447BABF0DDE4}"/>
           </ac:spMkLst>
         </pc:spChg>
       </pc:sldChg>
@@ -8460,7 +8453,7 @@
           <a:p>
             <a:fld id="{F0B8440E-8C35-1142-93FC-F32DCB9C4FDA}" type="datetimeFigureOut">
               <a:rPr lang="en-US" smtClean="0"/>
-              <a:t>1/29/26</a:t>
+              <a:t>2/16/26</a:t>
             </a:fld>
             <a:endParaRPr lang="en-US"/>
           </a:p>
@@ -10026,7 +10019,7 @@
           <a:p>
             <a:fld id="{A5B4ED3A-914E-6443-A2E7-C28A873C6BCA}" type="slidenum">
               <a:rPr lang="en-US" smtClean="0"/>
-              <a:t>18</a:t>
+              <a:t>19</a:t>
             </a:fld>
             <a:endParaRPr lang="en-US"/>
           </a:p>
@@ -10121,7 +10114,7 @@
           <a:p>
             <a:fld id="{A5B4ED3A-914E-6443-A2E7-C28A873C6BCA}" type="slidenum">
               <a:rPr lang="en-US" smtClean="0"/>
-              <a:t>20</a:t>
+              <a:t>21</a:t>
             </a:fld>
             <a:endParaRPr lang="en-US"/>
           </a:p>
@@ -10337,7 +10330,7 @@
           <a:p>
             <a:fld id="{A5B4ED3A-914E-6443-A2E7-C28A873C6BCA}" type="slidenum">
               <a:rPr lang="en-US" smtClean="0"/>
-              <a:t>21</a:t>
+              <a:t>22</a:t>
             </a:fld>
             <a:endParaRPr lang="en-US"/>
           </a:p>
@@ -10432,7 +10425,7 @@
           <a:p>
             <a:fld id="{A5B4ED3A-914E-6443-A2E7-C28A873C6BCA}" type="slidenum">
               <a:rPr lang="en-US" smtClean="0"/>
-              <a:t>22</a:t>
+              <a:t>23</a:t>
             </a:fld>
             <a:endParaRPr lang="en-US"/>
           </a:p>
@@ -10540,7 +10533,7 @@
           <a:p>
             <a:fld id="{A5B4ED3A-914E-6443-A2E7-C28A873C6BCA}" type="slidenum">
               <a:rPr lang="en-US" smtClean="0"/>
-              <a:t>23</a:t>
+              <a:t>24</a:t>
             </a:fld>
             <a:endParaRPr lang="en-US"/>
           </a:p>
@@ -10673,7 +10666,7 @@
           <a:p>
             <a:fld id="{A5B4ED3A-914E-6443-A2E7-C28A873C6BCA}" type="slidenum">
               <a:rPr lang="en-US" smtClean="0"/>
-              <a:t>24</a:t>
+              <a:t>25</a:t>
             </a:fld>
             <a:endParaRPr lang="en-US"/>
           </a:p>
@@ -10781,7 +10774,7 @@
           <a:p>
             <a:fld id="{A5B4ED3A-914E-6443-A2E7-C28A873C6BCA}" type="slidenum">
               <a:rPr lang="en-US" smtClean="0"/>
-              <a:t>25</a:t>
+              <a:t>26</a:t>
             </a:fld>
             <a:endParaRPr lang="en-US"/>
           </a:p>
@@ -10889,7 +10882,7 @@
           <a:p>
             <a:fld id="{A5B4ED3A-914E-6443-A2E7-C28A873C6BCA}" type="slidenum">
               <a:rPr lang="en-US" smtClean="0"/>
-              <a:t>26</a:t>
+              <a:t>27</a:t>
             </a:fld>
             <a:endParaRPr lang="en-US"/>
           </a:p>
@@ -11484,7 +11477,7 @@
           <a:p>
             <a:fld id="{A5B4ED3A-914E-6443-A2E7-C28A873C6BCA}" type="slidenum">
               <a:rPr lang="en-US" smtClean="0"/>
-              <a:t>28</a:t>
+              <a:t>29</a:t>
             </a:fld>
             <a:endParaRPr lang="en-US"/>
           </a:p>
@@ -12222,7 +12215,7 @@
           <a:p>
             <a:fld id="{A5B4ED3A-914E-6443-A2E7-C28A873C6BCA}" type="slidenum">
               <a:rPr lang="en-US" smtClean="0"/>
-              <a:t>29</a:t>
+              <a:t>30</a:t>
             </a:fld>
             <a:endParaRPr lang="en-US"/>
           </a:p>
@@ -12317,7 +12310,7 @@
           <a:p>
             <a:fld id="{A5B4ED3A-914E-6443-A2E7-C28A873C6BCA}" type="slidenum">
               <a:rPr lang="en-US" smtClean="0"/>
-              <a:t>30</a:t>
+              <a:t>31</a:t>
             </a:fld>
             <a:endParaRPr lang="en-US"/>
           </a:p>
@@ -12520,7 +12513,7 @@
           <a:p>
             <a:fld id="{A5B4ED3A-914E-6443-A2E7-C28A873C6BCA}" type="slidenum">
               <a:rPr lang="en-US" smtClean="0"/>
-              <a:t>31</a:t>
+              <a:t>32</a:t>
             </a:fld>
             <a:endParaRPr lang="en-US"/>
           </a:p>
@@ -12615,7 +12608,7 @@
           <a:p>
             <a:fld id="{A5B4ED3A-914E-6443-A2E7-C28A873C6BCA}" type="slidenum">
               <a:rPr lang="en-US" smtClean="0"/>
-              <a:t>32</a:t>
+              <a:t>33</a:t>
             </a:fld>
             <a:endParaRPr lang="en-US"/>
           </a:p>
@@ -12723,7 +12716,7 @@
           <a:p>
             <a:fld id="{A5B4ED3A-914E-6443-A2E7-C28A873C6BCA}" type="slidenum">
               <a:rPr lang="en-US" smtClean="0"/>
-              <a:t>33</a:t>
+              <a:t>34</a:t>
             </a:fld>
             <a:endParaRPr lang="en-US"/>
           </a:p>
@@ -12831,7 +12824,7 @@
           <a:p>
             <a:fld id="{A5B4ED3A-914E-6443-A2E7-C28A873C6BCA}" type="slidenum">
               <a:rPr lang="en-US" smtClean="0"/>
-              <a:t>34</a:t>
+              <a:t>35</a:t>
             </a:fld>
             <a:endParaRPr lang="en-US"/>
           </a:p>
@@ -12926,7 +12919,7 @@
           <a:p>
             <a:fld id="{A5B4ED3A-914E-6443-A2E7-C28A873C6BCA}" type="slidenum">
               <a:rPr lang="en-US" smtClean="0"/>
-              <a:t>35</a:t>
+              <a:t>36</a:t>
             </a:fld>
             <a:endParaRPr lang="en-US"/>
           </a:p>
@@ -13034,7 +13027,7 @@
           <a:p>
             <a:fld id="{A5B4ED3A-914E-6443-A2E7-C28A873C6BCA}" type="slidenum">
               <a:rPr lang="en-US" smtClean="0"/>
-              <a:t>36</a:t>
+              <a:t>37</a:t>
             </a:fld>
             <a:endParaRPr lang="en-US"/>
           </a:p>
@@ -13142,7 +13135,7 @@
           <a:p>
             <a:fld id="{A5B4ED3A-914E-6443-A2E7-C28A873C6BCA}" type="slidenum">
               <a:rPr lang="en-US" smtClean="0"/>
-              <a:t>37</a:t>
+              <a:t>38</a:t>
             </a:fld>
             <a:endParaRPr lang="en-US"/>
           </a:p>
@@ -13250,7 +13243,7 @@
           <a:p>
             <a:fld id="{A5B4ED3A-914E-6443-A2E7-C28A873C6BCA}" type="slidenum">
               <a:rPr lang="en-US" smtClean="0"/>
-              <a:t>38</a:t>
+              <a:t>39</a:t>
             </a:fld>
             <a:endParaRPr lang="en-US"/>
           </a:p>
@@ -13358,7 +13351,7 @@
           <a:p>
             <a:fld id="{50049E44-D13C-C54E-8DA3-DB5207EAD25C}" type="slidenum">
               <a:rPr lang="en-US" smtClean="0"/>
-              <a:t>39</a:t>
+              <a:t>40</a:t>
             </a:fld>
             <a:endParaRPr lang="en-US"/>
           </a:p>
@@ -13442,7 +13435,7 @@
           <a:p>
             <a:fld id="{A5B4ED3A-914E-6443-A2E7-C28A873C6BCA}" type="slidenum">
               <a:rPr lang="en-US" smtClean="0"/>
-              <a:t>40</a:t>
+              <a:t>41</a:t>
             </a:fld>
             <a:endParaRPr lang="en-US"/>
           </a:p>
@@ -22657,6 +22650,242 @@
   <p:cSld>
     <p:spTree>
       <p:nvGrpSpPr>
+        <p:cNvPr id="1" name=""/>
+        <p:cNvGrpSpPr/>
+        <p:nvPr/>
+      </p:nvGrpSpPr>
+      <p:grpSpPr>
+        <a:xfrm>
+          <a:off x="0" y="0"/>
+          <a:ext cx="0" cy="0"/>
+          <a:chOff x="0" y="0"/>
+          <a:chExt cx="0" cy="0"/>
+        </a:xfrm>
+      </p:grpSpPr>
+      <p:sp>
+        <p:nvSpPr>
+          <p:cNvPr id="3" name="Text Placeholder 2">
+            <a:extLst>
+              <a:ext uri="{FF2B5EF4-FFF2-40B4-BE49-F238E27FC236}">
+                <a16:creationId xmlns:a16="http://schemas.microsoft.com/office/drawing/2014/main" id="{8B5B5BBF-52D1-6895-6701-FCA84A38DA35}"/>
+              </a:ext>
+            </a:extLst>
+          </p:cNvPr>
+          <p:cNvSpPr>
+            <a:spLocks noGrp="1"/>
+          </p:cNvSpPr>
+          <p:nvPr>
+            <p:ph type="body" sz="quarter" idx="11"/>
+          </p:nvPr>
+        </p:nvSpPr>
+        <p:spPr/>
+        <p:txBody>
+          <a:bodyPr/>
+          <a:lstStyle/>
+          <a:p>
+            <a:r>
+              <a:rPr lang="en-US" dirty="0"/>
+              <a:t>NOTES</a:t>
+            </a:r>
+          </a:p>
+        </p:txBody>
+      </p:sp>
+      <p:sp>
+        <p:nvSpPr>
+          <p:cNvPr id="4" name="Text Placeholder 3">
+            <a:extLst>
+              <a:ext uri="{FF2B5EF4-FFF2-40B4-BE49-F238E27FC236}">
+                <a16:creationId xmlns:a16="http://schemas.microsoft.com/office/drawing/2014/main" id="{DBCBC422-140D-ECB5-02EA-207AF2C534EA}"/>
+              </a:ext>
+            </a:extLst>
+          </p:cNvPr>
+          <p:cNvSpPr>
+            <a:spLocks noGrp="1"/>
+          </p:cNvSpPr>
+          <p:nvPr>
+            <p:ph type="body" sz="quarter" idx="15"/>
+          </p:nvPr>
+        </p:nvSpPr>
+        <p:spPr/>
+        <p:txBody>
+          <a:bodyPr/>
+          <a:lstStyle/>
+          <a:p>
+            <a:r>
+              <a:rPr lang="en-US" dirty="0"/>
+              <a:t>Set up a billing on your own</a:t>
+            </a:r>
+          </a:p>
+        </p:txBody>
+      </p:sp>
+      <p:sp>
+        <p:nvSpPr>
+          <p:cNvPr id="5" name="Slide Number Placeholder 4">
+            <a:extLst>
+              <a:ext uri="{FF2B5EF4-FFF2-40B4-BE49-F238E27FC236}">
+                <a16:creationId xmlns:a16="http://schemas.microsoft.com/office/drawing/2014/main" id="{2058D705-1A01-7860-BB0D-29167360B0B2}"/>
+              </a:ext>
+            </a:extLst>
+          </p:cNvPr>
+          <p:cNvSpPr>
+            <a:spLocks noGrp="1"/>
+          </p:cNvSpPr>
+          <p:nvPr>
+            <p:ph type="sldNum" sz="quarter" idx="18"/>
+          </p:nvPr>
+        </p:nvSpPr>
+        <p:spPr/>
+        <p:txBody>
+          <a:bodyPr/>
+          <a:lstStyle/>
+          <a:p>
+            <a:fld id="{548469FB-C78A-B94B-B04A-B5BC8C934F85}" type="slidenum">
+              <a:rPr lang="en-US" smtClean="0"/>
+              <a:t>18</a:t>
+            </a:fld>
+            <a:endParaRPr lang="en-US"/>
+          </a:p>
+        </p:txBody>
+      </p:sp>
+      <p:sp>
+        <p:nvSpPr>
+          <p:cNvPr id="6" name="TextBox 5">
+            <a:extLst>
+              <a:ext uri="{FF2B5EF4-FFF2-40B4-BE49-F238E27FC236}">
+                <a16:creationId xmlns:a16="http://schemas.microsoft.com/office/drawing/2014/main" id="{0F5BD5C5-B894-1DE1-D326-447BABF0DDE4}"/>
+              </a:ext>
+            </a:extLst>
+          </p:cNvPr>
+          <p:cNvSpPr txBox="1"/>
+          <p:nvPr/>
+        </p:nvSpPr>
+        <p:spPr>
+          <a:xfrm>
+            <a:off x="4686300" y="644979"/>
+            <a:ext cx="6482443" cy="3139321"/>
+          </a:xfrm>
+          <a:prstGeom prst="rect">
+            <a:avLst/>
+          </a:prstGeom>
+          <a:noFill/>
+        </p:spPr>
+        <p:txBody>
+          <a:bodyPr wrap="square" rtlCol="0">
+            <a:spAutoFit/>
+          </a:bodyPr>
+          <a:lstStyle/>
+          <a:p>
+            <a:pPr marL="342900" indent="-342900">
+              <a:buFont typeface="+mj-lt"/>
+              <a:buAutoNum type="arabicPeriod"/>
+            </a:pPr>
+            <a:r>
+              <a:rPr lang="en-US" dirty="0"/>
+              <a:t>Need to get permission from the AoU billing administrator at Yale</a:t>
+            </a:r>
+          </a:p>
+          <a:p>
+            <a:pPr marL="800100" lvl="1" indent="-342900">
+              <a:buFont typeface="Arial" panose="020B0604020202020204" pitchFamily="34" charset="0"/>
+              <a:buChar char="•"/>
+            </a:pPr>
+            <a:r>
+              <a:rPr lang="en-US" dirty="0"/>
+              <a:t>who?</a:t>
+            </a:r>
+          </a:p>
+          <a:p>
+            <a:pPr marL="342900" indent="-342900">
+              <a:buFont typeface="+mj-lt"/>
+              <a:buAutoNum type="arabicPeriod"/>
+            </a:pPr>
+            <a:r>
+              <a:rPr lang="en-US" dirty="0"/>
+              <a:t>Need to set up billing account with credit card on a different google account other than you AoU one</a:t>
+            </a:r>
+          </a:p>
+          <a:p>
+            <a:pPr marL="800100" lvl="1" indent="-342900">
+              <a:buFont typeface="Arial" panose="020B0604020202020204" pitchFamily="34" charset="0"/>
+              <a:buChar char="•"/>
+            </a:pPr>
+            <a:r>
+              <a:rPr lang="en-US" dirty="0">
+                <a:solidFill>
+                  <a:schemeClr val="bg1"/>
+                </a:solidFill>
+                <a:latin typeface="YaleNew" panose="02000602050000020003" pitchFamily="2" charset="77"/>
+                <a:hlinkClick r:id="rId2"/>
+              </a:rPr>
+              <a:t>Set up a billing account to continue your work</a:t>
+            </a:r>
+            <a:endParaRPr lang="en-US" dirty="0">
+              <a:solidFill>
+                <a:schemeClr val="bg1"/>
+              </a:solidFill>
+              <a:latin typeface="YaleNew" panose="02000602050000020003" pitchFamily="2" charset="77"/>
+            </a:endParaRPr>
+          </a:p>
+          <a:p>
+            <a:pPr marL="800100" lvl="1" indent="-342900">
+              <a:buFont typeface="Arial" panose="020B0604020202020204" pitchFamily="34" charset="0"/>
+              <a:buChar char="•"/>
+            </a:pPr>
+            <a:r>
+              <a:rPr lang="en-US" dirty="0"/>
+              <a:t>Create a google account through Yale IT using </a:t>
+            </a:r>
+            <a:r>
+              <a:rPr lang="en-US" dirty="0">
+                <a:hlinkClick r:id="rId3"/>
+              </a:rPr>
+              <a:t>NETID@yale.edu</a:t>
+            </a:r>
+            <a:endParaRPr lang="en-US" dirty="0"/>
+          </a:p>
+          <a:p>
+            <a:pPr marL="342900" indent="-342900">
+              <a:buFont typeface="+mj-lt"/>
+              <a:buAutoNum type="arabicPeriod"/>
+            </a:pPr>
+            <a:r>
+              <a:rPr lang="en-US" dirty="0"/>
+              <a:t>Link this billing account with your AoU account</a:t>
+            </a:r>
+          </a:p>
+          <a:p>
+            <a:pPr marL="800100" lvl="1" indent="-342900">
+              <a:buFont typeface="+mj-lt"/>
+              <a:buAutoNum type="arabicPeriod"/>
+            </a:pPr>
+            <a:r>
+              <a:rPr lang="en-US" dirty="0">
+                <a:hlinkClick r:id="rId4"/>
+              </a:rPr>
+              <a:t>Enabling and Disabling a Google Cloud Platform (GCP) Billing Account</a:t>
+            </a:r>
+            <a:endParaRPr lang="en-US" dirty="0"/>
+          </a:p>
+        </p:txBody>
+      </p:sp>
+    </p:spTree>
+    <p:extLst>
+      <p:ext uri="{BB962C8B-B14F-4D97-AF65-F5344CB8AC3E}">
+        <p14:creationId xmlns:p14="http://schemas.microsoft.com/office/powerpoint/2010/main" val="872780695"/>
+      </p:ext>
+    </p:extLst>
+  </p:cSld>
+  <p:clrMapOvr>
+    <a:masterClrMapping/>
+  </p:clrMapOvr>
+</p:sld>
+</file>
+
+<file path=ppt/slides/slide19.xml><?xml version="1.0" encoding="utf-8"?>
+<p:sld xmlns:a="http://schemas.openxmlformats.org/drawingml/2006/main" xmlns:r="http://schemas.openxmlformats.org/officeDocument/2006/relationships" xmlns:p="http://schemas.openxmlformats.org/presentationml/2006/main">
+  <p:cSld>
+    <p:spTree>
+      <p:nvGrpSpPr>
         <p:cNvPr id="1" name="">
           <a:extLst>
             <a:ext uri="{FF2B5EF4-FFF2-40B4-BE49-F238E27FC236}">
@@ -22698,7 +22927,7 @@
           <a:p>
             <a:fld id="{548469FB-C78A-B94B-B04A-B5BC8C934F85}" type="slidenum">
               <a:rPr lang="en-US" smtClean="0"/>
-              <a:t>18</a:t>
+              <a:t>19</a:t>
             </a:fld>
             <a:endParaRPr lang="en-US"/>
           </a:p>
@@ -22936,361 +23165,6 @@
     <p:extLst>
       <p:ext uri="{BB962C8B-B14F-4D97-AF65-F5344CB8AC3E}">
         <p14:creationId xmlns:p14="http://schemas.microsoft.com/office/powerpoint/2010/main" val="2479410611"/>
-      </p:ext>
-    </p:extLst>
-  </p:cSld>
-  <p:clrMapOvr>
-    <a:masterClrMapping/>
-  </p:clrMapOvr>
-</p:sld>
-</file>
-
-<file path=ppt/slides/slide19.xml><?xml version="1.0" encoding="utf-8"?>
-<p:sld xmlns:a="http://schemas.openxmlformats.org/drawingml/2006/main" xmlns:r="http://schemas.openxmlformats.org/officeDocument/2006/relationships" xmlns:p="http://schemas.openxmlformats.org/presentationml/2006/main">
-  <p:cSld>
-    <p:spTree>
-      <p:nvGrpSpPr>
-        <p:cNvPr id="1" name=""/>
-        <p:cNvGrpSpPr/>
-        <p:nvPr/>
-      </p:nvGrpSpPr>
-      <p:grpSpPr>
-        <a:xfrm>
-          <a:off x="0" y="0"/>
-          <a:ext cx="0" cy="0"/>
-          <a:chOff x="0" y="0"/>
-          <a:chExt cx="0" cy="0"/>
-        </a:xfrm>
-      </p:grpSpPr>
-      <p:sp>
-        <p:nvSpPr>
-          <p:cNvPr id="3" name="Text Placeholder 2">
-            <a:extLst>
-              <a:ext uri="{FF2B5EF4-FFF2-40B4-BE49-F238E27FC236}">
-                <a16:creationId xmlns:a16="http://schemas.microsoft.com/office/drawing/2014/main" id="{DB15BF82-222D-4F21-FC15-F9270DA65858}"/>
-              </a:ext>
-            </a:extLst>
-          </p:cNvPr>
-          <p:cNvSpPr>
-            <a:spLocks noGrp="1"/>
-          </p:cNvSpPr>
-          <p:nvPr>
-            <p:ph type="body" sz="quarter" idx="11"/>
-          </p:nvPr>
-        </p:nvSpPr>
-        <p:spPr/>
-        <p:txBody>
-          <a:bodyPr/>
-          <a:lstStyle/>
-          <a:p>
-            <a:r>
-              <a:rPr lang="en-US" dirty="0">
-                <a:hlinkClick r:id="rId2"/>
-              </a:rPr>
-              <a:t>My AoU Cost Estimator App</a:t>
-            </a:r>
-            <a:endParaRPr lang="en-US" dirty="0"/>
-          </a:p>
-        </p:txBody>
-      </p:sp>
-      <p:sp>
-        <p:nvSpPr>
-          <p:cNvPr id="5" name="Slide Number Placeholder 4">
-            <a:extLst>
-              <a:ext uri="{FF2B5EF4-FFF2-40B4-BE49-F238E27FC236}">
-                <a16:creationId xmlns:a16="http://schemas.microsoft.com/office/drawing/2014/main" id="{DBE3D5F8-9199-1BA4-626D-CBF8BCB02CB6}"/>
-              </a:ext>
-            </a:extLst>
-          </p:cNvPr>
-          <p:cNvSpPr>
-            <a:spLocks noGrp="1"/>
-          </p:cNvSpPr>
-          <p:nvPr>
-            <p:ph type="sldNum" sz="quarter" idx="18"/>
-          </p:nvPr>
-        </p:nvSpPr>
-        <p:spPr/>
-        <p:txBody>
-          <a:bodyPr/>
-          <a:lstStyle/>
-          <a:p>
-            <a:fld id="{548469FB-C78A-B94B-B04A-B5BC8C934F85}" type="slidenum">
-              <a:rPr lang="en-US" smtClean="0"/>
-              <a:t>19</a:t>
-            </a:fld>
-            <a:endParaRPr lang="en-US"/>
-          </a:p>
-        </p:txBody>
-      </p:sp>
-      <p:sp>
-        <p:nvSpPr>
-          <p:cNvPr id="8" name="TextBox 7">
-            <a:extLst>
-              <a:ext uri="{FF2B5EF4-FFF2-40B4-BE49-F238E27FC236}">
-                <a16:creationId xmlns:a16="http://schemas.microsoft.com/office/drawing/2014/main" id="{FB28D8FF-D33B-4062-B26E-B5631CF251CA}"/>
-              </a:ext>
-            </a:extLst>
-          </p:cNvPr>
-          <p:cNvSpPr txBox="1"/>
-          <p:nvPr/>
-        </p:nvSpPr>
-        <p:spPr>
-          <a:xfrm>
-            <a:off x="4705141" y="1118522"/>
-            <a:ext cx="6648659" cy="4462760"/>
-          </a:xfrm>
-          <a:prstGeom prst="rect">
-            <a:avLst/>
-          </a:prstGeom>
-          <a:noFill/>
-        </p:spPr>
-        <p:txBody>
-          <a:bodyPr wrap="square" rtlCol="0">
-            <a:spAutoFit/>
-          </a:bodyPr>
-          <a:lstStyle/>
-          <a:p>
-            <a:r>
-              <a:rPr lang="en-US" sz="3000" b="1" dirty="0">
-                <a:solidFill>
-                  <a:srgbClr val="002060"/>
-                </a:solidFill>
-                <a:latin typeface="Avenir Book" panose="02000503020000020003" pitchFamily="2" charset="0"/>
-              </a:rPr>
-              <a:t>Can use this application to estimate the following:</a:t>
-            </a:r>
-          </a:p>
-          <a:p>
-            <a:pPr marL="285750" indent="-285750">
-              <a:buFont typeface="Arial" panose="020B0604020202020204" pitchFamily="34" charset="0"/>
-              <a:buChar char="•"/>
-            </a:pPr>
-            <a:endParaRPr lang="en-US" sz="3200" dirty="0">
-              <a:latin typeface="Avenir Book" panose="02000503020000020003" pitchFamily="2" charset="0"/>
-            </a:endParaRPr>
-          </a:p>
-          <a:p>
-            <a:pPr marL="342900" indent="-342900">
-              <a:buFont typeface="Arial" panose="020B0604020202020204" pitchFamily="34" charset="0"/>
-              <a:buChar char="•"/>
-            </a:pPr>
-            <a:r>
-              <a:rPr lang="en-US" sz="2400" dirty="0">
-                <a:latin typeface="Avenir Book" panose="02000503020000020003" pitchFamily="2" charset="0"/>
-              </a:rPr>
-              <a:t>Upfront costs</a:t>
-            </a:r>
-          </a:p>
-          <a:p>
-            <a:pPr marL="342900" indent="-342900">
-              <a:buFont typeface="Arial" panose="020B0604020202020204" pitchFamily="34" charset="0"/>
-              <a:buChar char="•"/>
-            </a:pPr>
-            <a:endParaRPr lang="en-US" sz="2400" dirty="0">
-              <a:latin typeface="Avenir Book" panose="02000503020000020003" pitchFamily="2" charset="0"/>
-            </a:endParaRPr>
-          </a:p>
-          <a:p>
-            <a:pPr marL="342900" indent="-342900">
-              <a:buFont typeface="Arial" panose="020B0604020202020204" pitchFamily="34" charset="0"/>
-              <a:buChar char="•"/>
-            </a:pPr>
-            <a:r>
-              <a:rPr lang="en-US" sz="2400" dirty="0">
-                <a:latin typeface="Avenir Book" panose="02000503020000020003" pitchFamily="2" charset="0"/>
-              </a:rPr>
-              <a:t>Total compute costs</a:t>
-            </a:r>
-          </a:p>
-          <a:p>
-            <a:pPr marL="457200" indent="-457200">
-              <a:buFont typeface="Arial" panose="020B0604020202020204" pitchFamily="34" charset="0"/>
-              <a:buChar char="•"/>
-            </a:pPr>
-            <a:endParaRPr lang="en-US" sz="2400" dirty="0">
-              <a:latin typeface="Avenir Book" panose="02000503020000020003" pitchFamily="2" charset="0"/>
-            </a:endParaRPr>
-          </a:p>
-          <a:p>
-            <a:pPr marL="457200" indent="-457200">
-              <a:buFont typeface="Arial" panose="020B0604020202020204" pitchFamily="34" charset="0"/>
-              <a:buChar char="•"/>
-            </a:pPr>
-            <a:r>
-              <a:rPr lang="en-US" sz="2400" dirty="0">
-                <a:latin typeface="Avenir Book" panose="02000503020000020003" pitchFamily="2" charset="0"/>
-              </a:rPr>
-              <a:t>Data storage costs for duration of the project</a:t>
-            </a:r>
-          </a:p>
-          <a:p>
-            <a:pPr marL="457200" indent="-457200">
-              <a:buFont typeface="Arial" panose="020B0604020202020204" pitchFamily="34" charset="0"/>
-              <a:buChar char="•"/>
-            </a:pPr>
-            <a:endParaRPr lang="en-US" sz="2400" dirty="0">
-              <a:latin typeface="Avenir Book" panose="02000503020000020003" pitchFamily="2" charset="0"/>
-            </a:endParaRPr>
-          </a:p>
-          <a:p>
-            <a:pPr marL="457200" indent="-457200">
-              <a:buFont typeface="Arial" panose="020B0604020202020204" pitchFamily="34" charset="0"/>
-              <a:buChar char="•"/>
-            </a:pPr>
-            <a:r>
-              <a:rPr lang="en-US" sz="2400" dirty="0">
-                <a:latin typeface="Avenir Book" panose="02000503020000020003" pitchFamily="2" charset="0"/>
-              </a:rPr>
-              <a:t>Total project cost</a:t>
-            </a:r>
-          </a:p>
-        </p:txBody>
-      </p:sp>
-      <p:sp>
-        <p:nvSpPr>
-          <p:cNvPr id="9" name="TextBox 8">
-            <a:extLst>
-              <a:ext uri="{FF2B5EF4-FFF2-40B4-BE49-F238E27FC236}">
-                <a16:creationId xmlns:a16="http://schemas.microsoft.com/office/drawing/2014/main" id="{05D4A543-36A2-AAFD-BF06-E8BDCAA00048}"/>
-              </a:ext>
-            </a:extLst>
-          </p:cNvPr>
-          <p:cNvSpPr txBox="1"/>
-          <p:nvPr/>
-        </p:nvSpPr>
-        <p:spPr>
-          <a:xfrm>
-            <a:off x="152696" y="3692765"/>
-            <a:ext cx="3717890" cy="2102692"/>
-          </a:xfrm>
-          <a:prstGeom prst="rect">
-            <a:avLst/>
-          </a:prstGeom>
-          <a:noFill/>
-        </p:spPr>
-        <p:txBody>
-          <a:bodyPr wrap="square" rtlCol="0">
-            <a:spAutoFit/>
-          </a:bodyPr>
-          <a:lstStyle/>
-          <a:p>
-            <a:pPr>
-              <a:lnSpc>
-                <a:spcPct val="90000"/>
-              </a:lnSpc>
-              <a:spcBef>
-                <a:spcPts val="1000"/>
-              </a:spcBef>
-            </a:pPr>
-            <a:r>
-              <a:rPr lang="en-US" b="1" dirty="0">
-                <a:solidFill>
-                  <a:schemeClr val="bg1"/>
-                </a:solidFill>
-                <a:latin typeface="YaleNew" panose="02000602050000020003" pitchFamily="2" charset="77"/>
-                <a:cs typeface="Calibri" panose="020F0502020204030204" pitchFamily="34" charset="0"/>
-              </a:rPr>
-              <a:t>NOTES</a:t>
-            </a:r>
-          </a:p>
-          <a:p>
-            <a:pPr marL="285750" indent="-285750">
-              <a:lnSpc>
-                <a:spcPct val="90000"/>
-              </a:lnSpc>
-              <a:spcBef>
-                <a:spcPts val="1000"/>
-              </a:spcBef>
-              <a:buSzPct val="80000"/>
-              <a:buFont typeface="Arial" panose="020B0604020202020204" pitchFamily="34" charset="0"/>
-              <a:buChar char="•"/>
-            </a:pPr>
-            <a:r>
-              <a:rPr lang="en-US" dirty="0">
-                <a:solidFill>
-                  <a:schemeClr val="bg1"/>
-                </a:solidFill>
-                <a:latin typeface="YaleNew" panose="02000602050000020003" pitchFamily="2" charset="77"/>
-                <a:cs typeface="Calibri" panose="020F0502020204030204" pitchFamily="34" charset="0"/>
-              </a:rPr>
-              <a:t>Beta phase (updates will be made)</a:t>
-            </a:r>
-          </a:p>
-          <a:p>
-            <a:pPr marL="285750" indent="-285750">
-              <a:lnSpc>
-                <a:spcPct val="90000"/>
-              </a:lnSpc>
-              <a:spcBef>
-                <a:spcPts val="1000"/>
-              </a:spcBef>
-              <a:buSzPct val="80000"/>
-              <a:buFont typeface="Arial" panose="020B0604020202020204" pitchFamily="34" charset="0"/>
-              <a:buChar char="•"/>
-            </a:pPr>
-            <a:r>
-              <a:rPr lang="en-US" dirty="0">
-                <a:solidFill>
-                  <a:schemeClr val="bg1"/>
-                </a:solidFill>
-                <a:latin typeface="YaleNew" panose="02000602050000020003" pitchFamily="2" charset="77"/>
-                <a:cs typeface="Calibri" panose="020F0502020204030204" pitchFamily="34" charset="0"/>
-              </a:rPr>
-              <a:t>Not an official AoU app</a:t>
-            </a:r>
-          </a:p>
-          <a:p>
-            <a:pPr marL="285750" indent="-285750">
-              <a:lnSpc>
-                <a:spcPct val="90000"/>
-              </a:lnSpc>
-              <a:spcBef>
-                <a:spcPts val="1000"/>
-              </a:spcBef>
-              <a:buSzPct val="80000"/>
-              <a:buFont typeface="Arial" panose="020B0604020202020204" pitchFamily="34" charset="0"/>
-              <a:buChar char="•"/>
-            </a:pPr>
-            <a:r>
-              <a:rPr lang="en-US" dirty="0">
-                <a:solidFill>
-                  <a:schemeClr val="bg1"/>
-                </a:solidFill>
-                <a:latin typeface="YaleNew" panose="02000602050000020003" pitchFamily="2" charset="77"/>
-                <a:cs typeface="Calibri" panose="020F0502020204030204" pitchFamily="34" charset="0"/>
-              </a:rPr>
-              <a:t>Pay attention to the parameters you need</a:t>
-            </a:r>
-          </a:p>
-          <a:p>
-            <a:pPr marL="285750" indent="-285750">
-              <a:lnSpc>
-                <a:spcPct val="90000"/>
-              </a:lnSpc>
-              <a:spcBef>
-                <a:spcPts val="1000"/>
-              </a:spcBef>
-              <a:buSzPct val="80000"/>
-              <a:buFont typeface="Arial" panose="020B0604020202020204" pitchFamily="34" charset="0"/>
-              <a:buChar char="•"/>
-            </a:pPr>
-            <a:r>
-              <a:rPr lang="en-US" dirty="0">
-                <a:solidFill>
-                  <a:schemeClr val="bg1"/>
-                </a:solidFill>
-                <a:latin typeface="YaleNew" panose="02000602050000020003" pitchFamily="2" charset="77"/>
-                <a:cs typeface="Calibri" panose="020F0502020204030204" pitchFamily="34" charset="0"/>
-              </a:rPr>
-              <a:t>Please provide feedback</a:t>
-            </a:r>
-          </a:p>
-        </p:txBody>
-      </p:sp>
-    </p:spTree>
-    <p:extLst>
-      <p:ext uri="{BB962C8B-B14F-4D97-AF65-F5344CB8AC3E}">
-        <p14:creationId xmlns:p14="http://schemas.microsoft.com/office/powerpoint/2010/main" val="1265380304"/>
       </p:ext>
     </p:extLst>
   </p:cSld>
@@ -23483,6 +23357,361 @@
 </file>
 
 <file path=ppt/slides/slide20.xml><?xml version="1.0" encoding="utf-8"?>
+<p:sld xmlns:a="http://schemas.openxmlformats.org/drawingml/2006/main" xmlns:r="http://schemas.openxmlformats.org/officeDocument/2006/relationships" xmlns:p="http://schemas.openxmlformats.org/presentationml/2006/main">
+  <p:cSld>
+    <p:spTree>
+      <p:nvGrpSpPr>
+        <p:cNvPr id="1" name=""/>
+        <p:cNvGrpSpPr/>
+        <p:nvPr/>
+      </p:nvGrpSpPr>
+      <p:grpSpPr>
+        <a:xfrm>
+          <a:off x="0" y="0"/>
+          <a:ext cx="0" cy="0"/>
+          <a:chOff x="0" y="0"/>
+          <a:chExt cx="0" cy="0"/>
+        </a:xfrm>
+      </p:grpSpPr>
+      <p:sp>
+        <p:nvSpPr>
+          <p:cNvPr id="3" name="Text Placeholder 2">
+            <a:extLst>
+              <a:ext uri="{FF2B5EF4-FFF2-40B4-BE49-F238E27FC236}">
+                <a16:creationId xmlns:a16="http://schemas.microsoft.com/office/drawing/2014/main" id="{DB15BF82-222D-4F21-FC15-F9270DA65858}"/>
+              </a:ext>
+            </a:extLst>
+          </p:cNvPr>
+          <p:cNvSpPr>
+            <a:spLocks noGrp="1"/>
+          </p:cNvSpPr>
+          <p:nvPr>
+            <p:ph type="body" sz="quarter" idx="11"/>
+          </p:nvPr>
+        </p:nvSpPr>
+        <p:spPr/>
+        <p:txBody>
+          <a:bodyPr/>
+          <a:lstStyle/>
+          <a:p>
+            <a:r>
+              <a:rPr lang="en-US" dirty="0">
+                <a:hlinkClick r:id="rId2"/>
+              </a:rPr>
+              <a:t>My AoU Cost Estimator App</a:t>
+            </a:r>
+            <a:endParaRPr lang="en-US" dirty="0"/>
+          </a:p>
+        </p:txBody>
+      </p:sp>
+      <p:sp>
+        <p:nvSpPr>
+          <p:cNvPr id="5" name="Slide Number Placeholder 4">
+            <a:extLst>
+              <a:ext uri="{FF2B5EF4-FFF2-40B4-BE49-F238E27FC236}">
+                <a16:creationId xmlns:a16="http://schemas.microsoft.com/office/drawing/2014/main" id="{DBE3D5F8-9199-1BA4-626D-CBF8BCB02CB6}"/>
+              </a:ext>
+            </a:extLst>
+          </p:cNvPr>
+          <p:cNvSpPr>
+            <a:spLocks noGrp="1"/>
+          </p:cNvSpPr>
+          <p:nvPr>
+            <p:ph type="sldNum" sz="quarter" idx="18"/>
+          </p:nvPr>
+        </p:nvSpPr>
+        <p:spPr/>
+        <p:txBody>
+          <a:bodyPr/>
+          <a:lstStyle/>
+          <a:p>
+            <a:fld id="{548469FB-C78A-B94B-B04A-B5BC8C934F85}" type="slidenum">
+              <a:rPr lang="en-US" smtClean="0"/>
+              <a:t>20</a:t>
+            </a:fld>
+            <a:endParaRPr lang="en-US"/>
+          </a:p>
+        </p:txBody>
+      </p:sp>
+      <p:sp>
+        <p:nvSpPr>
+          <p:cNvPr id="8" name="TextBox 7">
+            <a:extLst>
+              <a:ext uri="{FF2B5EF4-FFF2-40B4-BE49-F238E27FC236}">
+                <a16:creationId xmlns:a16="http://schemas.microsoft.com/office/drawing/2014/main" id="{FB28D8FF-D33B-4062-B26E-B5631CF251CA}"/>
+              </a:ext>
+            </a:extLst>
+          </p:cNvPr>
+          <p:cNvSpPr txBox="1"/>
+          <p:nvPr/>
+        </p:nvSpPr>
+        <p:spPr>
+          <a:xfrm>
+            <a:off x="4705141" y="1118522"/>
+            <a:ext cx="6648659" cy="4462760"/>
+          </a:xfrm>
+          <a:prstGeom prst="rect">
+            <a:avLst/>
+          </a:prstGeom>
+          <a:noFill/>
+        </p:spPr>
+        <p:txBody>
+          <a:bodyPr wrap="square" rtlCol="0">
+            <a:spAutoFit/>
+          </a:bodyPr>
+          <a:lstStyle/>
+          <a:p>
+            <a:r>
+              <a:rPr lang="en-US" sz="3000" b="1" dirty="0">
+                <a:solidFill>
+                  <a:srgbClr val="002060"/>
+                </a:solidFill>
+                <a:latin typeface="Avenir Book" panose="02000503020000020003" pitchFamily="2" charset="0"/>
+              </a:rPr>
+              <a:t>Can use this application to estimate the following:</a:t>
+            </a:r>
+          </a:p>
+          <a:p>
+            <a:pPr marL="285750" indent="-285750">
+              <a:buFont typeface="Arial" panose="020B0604020202020204" pitchFamily="34" charset="0"/>
+              <a:buChar char="•"/>
+            </a:pPr>
+            <a:endParaRPr lang="en-US" sz="3200" dirty="0">
+              <a:latin typeface="Avenir Book" panose="02000503020000020003" pitchFamily="2" charset="0"/>
+            </a:endParaRPr>
+          </a:p>
+          <a:p>
+            <a:pPr marL="342900" indent="-342900">
+              <a:buFont typeface="Arial" panose="020B0604020202020204" pitchFamily="34" charset="0"/>
+              <a:buChar char="•"/>
+            </a:pPr>
+            <a:r>
+              <a:rPr lang="en-US" sz="2400" dirty="0">
+                <a:latin typeface="Avenir Book" panose="02000503020000020003" pitchFamily="2" charset="0"/>
+              </a:rPr>
+              <a:t>Upfront costs</a:t>
+            </a:r>
+          </a:p>
+          <a:p>
+            <a:pPr marL="342900" indent="-342900">
+              <a:buFont typeface="Arial" panose="020B0604020202020204" pitchFamily="34" charset="0"/>
+              <a:buChar char="•"/>
+            </a:pPr>
+            <a:endParaRPr lang="en-US" sz="2400" dirty="0">
+              <a:latin typeface="Avenir Book" panose="02000503020000020003" pitchFamily="2" charset="0"/>
+            </a:endParaRPr>
+          </a:p>
+          <a:p>
+            <a:pPr marL="342900" indent="-342900">
+              <a:buFont typeface="Arial" panose="020B0604020202020204" pitchFamily="34" charset="0"/>
+              <a:buChar char="•"/>
+            </a:pPr>
+            <a:r>
+              <a:rPr lang="en-US" sz="2400" dirty="0">
+                <a:latin typeface="Avenir Book" panose="02000503020000020003" pitchFamily="2" charset="0"/>
+              </a:rPr>
+              <a:t>Total compute costs</a:t>
+            </a:r>
+          </a:p>
+          <a:p>
+            <a:pPr marL="457200" indent="-457200">
+              <a:buFont typeface="Arial" panose="020B0604020202020204" pitchFamily="34" charset="0"/>
+              <a:buChar char="•"/>
+            </a:pPr>
+            <a:endParaRPr lang="en-US" sz="2400" dirty="0">
+              <a:latin typeface="Avenir Book" panose="02000503020000020003" pitchFamily="2" charset="0"/>
+            </a:endParaRPr>
+          </a:p>
+          <a:p>
+            <a:pPr marL="457200" indent="-457200">
+              <a:buFont typeface="Arial" panose="020B0604020202020204" pitchFamily="34" charset="0"/>
+              <a:buChar char="•"/>
+            </a:pPr>
+            <a:r>
+              <a:rPr lang="en-US" sz="2400" dirty="0">
+                <a:latin typeface="Avenir Book" panose="02000503020000020003" pitchFamily="2" charset="0"/>
+              </a:rPr>
+              <a:t>Data storage costs for duration of the project</a:t>
+            </a:r>
+          </a:p>
+          <a:p>
+            <a:pPr marL="457200" indent="-457200">
+              <a:buFont typeface="Arial" panose="020B0604020202020204" pitchFamily="34" charset="0"/>
+              <a:buChar char="•"/>
+            </a:pPr>
+            <a:endParaRPr lang="en-US" sz="2400" dirty="0">
+              <a:latin typeface="Avenir Book" panose="02000503020000020003" pitchFamily="2" charset="0"/>
+            </a:endParaRPr>
+          </a:p>
+          <a:p>
+            <a:pPr marL="457200" indent="-457200">
+              <a:buFont typeface="Arial" panose="020B0604020202020204" pitchFamily="34" charset="0"/>
+              <a:buChar char="•"/>
+            </a:pPr>
+            <a:r>
+              <a:rPr lang="en-US" sz="2400" dirty="0">
+                <a:latin typeface="Avenir Book" panose="02000503020000020003" pitchFamily="2" charset="0"/>
+              </a:rPr>
+              <a:t>Total project cost</a:t>
+            </a:r>
+          </a:p>
+        </p:txBody>
+      </p:sp>
+      <p:sp>
+        <p:nvSpPr>
+          <p:cNvPr id="9" name="TextBox 8">
+            <a:extLst>
+              <a:ext uri="{FF2B5EF4-FFF2-40B4-BE49-F238E27FC236}">
+                <a16:creationId xmlns:a16="http://schemas.microsoft.com/office/drawing/2014/main" id="{05D4A543-36A2-AAFD-BF06-E8BDCAA00048}"/>
+              </a:ext>
+            </a:extLst>
+          </p:cNvPr>
+          <p:cNvSpPr txBox="1"/>
+          <p:nvPr/>
+        </p:nvSpPr>
+        <p:spPr>
+          <a:xfrm>
+            <a:off x="152696" y="3692765"/>
+            <a:ext cx="3717890" cy="2102692"/>
+          </a:xfrm>
+          <a:prstGeom prst="rect">
+            <a:avLst/>
+          </a:prstGeom>
+          <a:noFill/>
+        </p:spPr>
+        <p:txBody>
+          <a:bodyPr wrap="square" rtlCol="0">
+            <a:spAutoFit/>
+          </a:bodyPr>
+          <a:lstStyle/>
+          <a:p>
+            <a:pPr>
+              <a:lnSpc>
+                <a:spcPct val="90000"/>
+              </a:lnSpc>
+              <a:spcBef>
+                <a:spcPts val="1000"/>
+              </a:spcBef>
+            </a:pPr>
+            <a:r>
+              <a:rPr lang="en-US" b="1" dirty="0">
+                <a:solidFill>
+                  <a:schemeClr val="bg1"/>
+                </a:solidFill>
+                <a:latin typeface="YaleNew" panose="02000602050000020003" pitchFamily="2" charset="77"/>
+                <a:cs typeface="Calibri" panose="020F0502020204030204" pitchFamily="34" charset="0"/>
+              </a:rPr>
+              <a:t>NOTES</a:t>
+            </a:r>
+          </a:p>
+          <a:p>
+            <a:pPr marL="285750" indent="-285750">
+              <a:lnSpc>
+                <a:spcPct val="90000"/>
+              </a:lnSpc>
+              <a:spcBef>
+                <a:spcPts val="1000"/>
+              </a:spcBef>
+              <a:buSzPct val="80000"/>
+              <a:buFont typeface="Arial" panose="020B0604020202020204" pitchFamily="34" charset="0"/>
+              <a:buChar char="•"/>
+            </a:pPr>
+            <a:r>
+              <a:rPr lang="en-US" dirty="0">
+                <a:solidFill>
+                  <a:schemeClr val="bg1"/>
+                </a:solidFill>
+                <a:latin typeface="YaleNew" panose="02000602050000020003" pitchFamily="2" charset="77"/>
+                <a:cs typeface="Calibri" panose="020F0502020204030204" pitchFamily="34" charset="0"/>
+              </a:rPr>
+              <a:t>Beta phase (updates will be made)</a:t>
+            </a:r>
+          </a:p>
+          <a:p>
+            <a:pPr marL="285750" indent="-285750">
+              <a:lnSpc>
+                <a:spcPct val="90000"/>
+              </a:lnSpc>
+              <a:spcBef>
+                <a:spcPts val="1000"/>
+              </a:spcBef>
+              <a:buSzPct val="80000"/>
+              <a:buFont typeface="Arial" panose="020B0604020202020204" pitchFamily="34" charset="0"/>
+              <a:buChar char="•"/>
+            </a:pPr>
+            <a:r>
+              <a:rPr lang="en-US" dirty="0">
+                <a:solidFill>
+                  <a:schemeClr val="bg1"/>
+                </a:solidFill>
+                <a:latin typeface="YaleNew" panose="02000602050000020003" pitchFamily="2" charset="77"/>
+                <a:cs typeface="Calibri" panose="020F0502020204030204" pitchFamily="34" charset="0"/>
+              </a:rPr>
+              <a:t>Not an official AoU app</a:t>
+            </a:r>
+          </a:p>
+          <a:p>
+            <a:pPr marL="285750" indent="-285750">
+              <a:lnSpc>
+                <a:spcPct val="90000"/>
+              </a:lnSpc>
+              <a:spcBef>
+                <a:spcPts val="1000"/>
+              </a:spcBef>
+              <a:buSzPct val="80000"/>
+              <a:buFont typeface="Arial" panose="020B0604020202020204" pitchFamily="34" charset="0"/>
+              <a:buChar char="•"/>
+            </a:pPr>
+            <a:r>
+              <a:rPr lang="en-US" dirty="0">
+                <a:solidFill>
+                  <a:schemeClr val="bg1"/>
+                </a:solidFill>
+                <a:latin typeface="YaleNew" panose="02000602050000020003" pitchFamily="2" charset="77"/>
+                <a:cs typeface="Calibri" panose="020F0502020204030204" pitchFamily="34" charset="0"/>
+              </a:rPr>
+              <a:t>Pay attention to the parameters you need</a:t>
+            </a:r>
+          </a:p>
+          <a:p>
+            <a:pPr marL="285750" indent="-285750">
+              <a:lnSpc>
+                <a:spcPct val="90000"/>
+              </a:lnSpc>
+              <a:spcBef>
+                <a:spcPts val="1000"/>
+              </a:spcBef>
+              <a:buSzPct val="80000"/>
+              <a:buFont typeface="Arial" panose="020B0604020202020204" pitchFamily="34" charset="0"/>
+              <a:buChar char="•"/>
+            </a:pPr>
+            <a:r>
+              <a:rPr lang="en-US" dirty="0">
+                <a:solidFill>
+                  <a:schemeClr val="bg1"/>
+                </a:solidFill>
+                <a:latin typeface="YaleNew" panose="02000602050000020003" pitchFamily="2" charset="77"/>
+                <a:cs typeface="Calibri" panose="020F0502020204030204" pitchFamily="34" charset="0"/>
+              </a:rPr>
+              <a:t>Please provide feedback</a:t>
+            </a:r>
+          </a:p>
+        </p:txBody>
+      </p:sp>
+    </p:spTree>
+    <p:extLst>
+      <p:ext uri="{BB962C8B-B14F-4D97-AF65-F5344CB8AC3E}">
+        <p14:creationId xmlns:p14="http://schemas.microsoft.com/office/powerpoint/2010/main" val="1265380304"/>
+      </p:ext>
+    </p:extLst>
+  </p:cSld>
+  <p:clrMapOvr>
+    <a:masterClrMapping/>
+  </p:clrMapOvr>
+</p:sld>
+</file>
+
+<file path=ppt/slides/slide21.xml><?xml version="1.0" encoding="utf-8"?>
 <p:sld xmlns:a="http://schemas.openxmlformats.org/drawingml/2006/main" xmlns:r="http://schemas.openxmlformats.org/officeDocument/2006/relationships" xmlns:p="http://schemas.openxmlformats.org/presentationml/2006/main">
   <p:cSld>
     <p:spTree>
@@ -23592,7 +23821,7 @@
 </p:sld>
 </file>
 
-<file path=ppt/slides/slide21.xml><?xml version="1.0" encoding="utf-8"?>
+<file path=ppt/slides/slide22.xml><?xml version="1.0" encoding="utf-8"?>
 <p:sld xmlns:a="http://schemas.openxmlformats.org/drawingml/2006/main" xmlns:r="http://schemas.openxmlformats.org/officeDocument/2006/relationships" xmlns:p="http://schemas.openxmlformats.org/presentationml/2006/main">
   <p:cSld>
     <p:spTree>
@@ -23850,7 +24079,7 @@
           <a:p>
             <a:fld id="{548469FB-C78A-B94B-B04A-B5BC8C934F85}" type="slidenum">
               <a:rPr lang="en-US" smtClean="0"/>
-              <a:t>21</a:t>
+              <a:t>22</a:t>
             </a:fld>
             <a:endParaRPr lang="en-US"/>
           </a:p>
@@ -24277,7 +24506,7 @@
 </p:sld>
 </file>
 
-<file path=ppt/slides/slide22.xml><?xml version="1.0" encoding="utf-8"?>
+<file path=ppt/slides/slide23.xml><?xml version="1.0" encoding="utf-8"?>
 <p:sld xmlns:a="http://schemas.openxmlformats.org/drawingml/2006/main" xmlns:r="http://schemas.openxmlformats.org/officeDocument/2006/relationships" xmlns:p="http://schemas.openxmlformats.org/presentationml/2006/main">
   <p:cSld>
     <p:spTree>
@@ -24387,7 +24616,7 @@
 </p:sld>
 </file>
 
-<file path=ppt/slides/slide23.xml><?xml version="1.0" encoding="utf-8"?>
+<file path=ppt/slides/slide24.xml><?xml version="1.0" encoding="utf-8"?>
 <p:sld xmlns:a="http://schemas.openxmlformats.org/drawingml/2006/main" xmlns:r="http://schemas.openxmlformats.org/officeDocument/2006/relationships" xmlns:p="http://schemas.openxmlformats.org/presentationml/2006/main">
   <p:cSld>
     <p:spTree>
@@ -24717,7 +24946,7 @@
           <a:p>
             <a:fld id="{548469FB-C78A-B94B-B04A-B5BC8C934F85}" type="slidenum">
               <a:rPr lang="en-US" smtClean="0"/>
-              <a:t>23</a:t>
+              <a:t>24</a:t>
             </a:fld>
             <a:endParaRPr lang="en-US"/>
           </a:p>
@@ -24765,7 +24994,7 @@
 </p:sld>
 </file>
 
-<file path=ppt/slides/slide24.xml><?xml version="1.0" encoding="utf-8"?>
+<file path=ppt/slides/slide25.xml><?xml version="1.0" encoding="utf-8"?>
 <p:sld xmlns:a="http://schemas.openxmlformats.org/drawingml/2006/main" xmlns:r="http://schemas.openxmlformats.org/officeDocument/2006/relationships" xmlns:p="http://schemas.openxmlformats.org/presentationml/2006/main">
   <p:cSld>
     <p:spTree>
@@ -25013,7 +25242,7 @@
           <a:p>
             <a:fld id="{548469FB-C78A-B94B-B04A-B5BC8C934F85}" type="slidenum">
               <a:rPr lang="en-US" smtClean="0"/>
-              <a:t>24</a:t>
+              <a:t>25</a:t>
             </a:fld>
             <a:endParaRPr lang="en-US"/>
           </a:p>
@@ -25439,7 +25668,7 @@
 </p:sld>
 </file>
 
-<file path=ppt/slides/slide25.xml><?xml version="1.0" encoding="utf-8"?>
+<file path=ppt/slides/slide26.xml><?xml version="1.0" encoding="utf-8"?>
 <p:sld xmlns:a="http://schemas.openxmlformats.org/drawingml/2006/main" xmlns:r="http://schemas.openxmlformats.org/officeDocument/2006/relationships" xmlns:p="http://schemas.openxmlformats.org/presentationml/2006/main">
   <p:cSld>
     <p:spTree>
@@ -25619,7 +25848,7 @@
           <a:p>
             <a:fld id="{548469FB-C78A-B94B-B04A-B5BC8C934F85}" type="slidenum">
               <a:rPr lang="en-US" smtClean="0"/>
-              <a:t>25</a:t>
+              <a:t>26</a:t>
             </a:fld>
             <a:endParaRPr lang="en-US"/>
           </a:p>
@@ -27246,7 +27475,7 @@
 </p:sld>
 </file>
 
-<file path=ppt/slides/slide26.xml><?xml version="1.0" encoding="utf-8"?>
+<file path=ppt/slides/slide27.xml><?xml version="1.0" encoding="utf-8"?>
 <p:sld xmlns:a="http://schemas.openxmlformats.org/drawingml/2006/main" xmlns:r="http://schemas.openxmlformats.org/officeDocument/2006/relationships" xmlns:p="http://schemas.openxmlformats.org/presentationml/2006/main">
   <p:cSld>
     <p:spTree>
@@ -27493,7 +27722,7 @@
           <a:p>
             <a:fld id="{548469FB-C78A-B94B-B04A-B5BC8C934F85}" type="slidenum">
               <a:rPr lang="en-US" smtClean="0"/>
-              <a:t>26</a:t>
+              <a:t>27</a:t>
             </a:fld>
             <a:endParaRPr lang="en-US"/>
           </a:p>
@@ -28012,7 +28241,7 @@
 </p:sld>
 </file>
 
-<file path=ppt/slides/slide27.xml><?xml version="1.0" encoding="utf-8"?>
+<file path=ppt/slides/slide28.xml><?xml version="1.0" encoding="utf-8"?>
 <p:sld xmlns:a="http://schemas.openxmlformats.org/drawingml/2006/main" xmlns:r="http://schemas.openxmlformats.org/officeDocument/2006/relationships" xmlns:p="http://schemas.openxmlformats.org/presentationml/2006/main">
   <p:cSld>
     <p:spTree>
@@ -28106,7 +28335,7 @@
             <a:fld id="{00000000-1234-1234-1234-123412341234}" type="slidenum">
               <a:rPr lang="en"/>
               <a:pPr/>
-              <a:t>27</a:t>
+              <a:t>28</a:t>
             </a:fld>
             <a:endParaRPr/>
           </a:p>
@@ -28320,7 +28549,7 @@
 </p:sld>
 </file>
 
-<file path=ppt/slides/slide28.xml><?xml version="1.0" encoding="utf-8"?>
+<file path=ppt/slides/slide29.xml><?xml version="1.0" encoding="utf-8"?>
 <p:sld xmlns:a="http://schemas.openxmlformats.org/drawingml/2006/main" xmlns:r="http://schemas.openxmlformats.org/officeDocument/2006/relationships" xmlns:p="http://schemas.openxmlformats.org/presentationml/2006/main">
   <p:cSld>
     <p:spTree>
@@ -28459,7 +28688,7 @@
           <a:p>
             <a:fld id="{548469FB-C78A-B94B-B04A-B5BC8C934F85}" type="slidenum">
               <a:rPr lang="en-US" smtClean="0"/>
-              <a:t>28</a:t>
+              <a:t>29</a:t>
             </a:fld>
             <a:endParaRPr lang="en-US"/>
           </a:p>
@@ -28799,480 +29028,6 @@
     <p:extLst>
       <p:ext uri="{BB962C8B-B14F-4D97-AF65-F5344CB8AC3E}">
         <p14:creationId xmlns:p14="http://schemas.microsoft.com/office/powerpoint/2010/main" val="1184809725"/>
-      </p:ext>
-    </p:extLst>
-  </p:cSld>
-  <p:clrMapOvr>
-    <a:masterClrMapping/>
-  </p:clrMapOvr>
-</p:sld>
-</file>
-
-<file path=ppt/slides/slide29.xml><?xml version="1.0" encoding="utf-8"?>
-<p:sld xmlns:a="http://schemas.openxmlformats.org/drawingml/2006/main" xmlns:r="http://schemas.openxmlformats.org/officeDocument/2006/relationships" xmlns:p="http://schemas.openxmlformats.org/presentationml/2006/main">
-  <p:cSld>
-    <p:spTree>
-      <p:nvGrpSpPr>
-        <p:cNvPr id="1" name="">
-          <a:extLst>
-            <a:ext uri="{FF2B5EF4-FFF2-40B4-BE49-F238E27FC236}">
-              <a16:creationId xmlns:a16="http://schemas.microsoft.com/office/drawing/2014/main" id="{37760B17-F039-67A5-0AB0-2DAC061E5A60}"/>
-            </a:ext>
-          </a:extLst>
-        </p:cNvPr>
-        <p:cNvGrpSpPr/>
-        <p:nvPr/>
-      </p:nvGrpSpPr>
-      <p:grpSpPr>
-        <a:xfrm>
-          <a:off x="0" y="0"/>
-          <a:ext cx="0" cy="0"/>
-          <a:chOff x="0" y="0"/>
-          <a:chExt cx="0" cy="0"/>
-        </a:xfrm>
-      </p:grpSpPr>
-      <p:sp>
-        <p:nvSpPr>
-          <p:cNvPr id="3" name="Text Placeholder 2">
-            <a:extLst>
-              <a:ext uri="{FF2B5EF4-FFF2-40B4-BE49-F238E27FC236}">
-                <a16:creationId xmlns:a16="http://schemas.microsoft.com/office/drawing/2014/main" id="{4259CA2D-73EF-9212-B21A-644BD13C35AA}"/>
-              </a:ext>
-            </a:extLst>
-          </p:cNvPr>
-          <p:cNvSpPr>
-            <a:spLocks noGrp="1"/>
-          </p:cNvSpPr>
-          <p:nvPr>
-            <p:ph type="body" sz="quarter" idx="11"/>
-          </p:nvPr>
-        </p:nvSpPr>
-        <p:spPr/>
-        <p:txBody>
-          <a:bodyPr/>
-          <a:lstStyle/>
-          <a:p>
-            <a:r>
-              <a:rPr lang="en-US" dirty="0">
-                <a:latin typeface="YaleNew" panose="02000602050000020003" pitchFamily="2" charset="77"/>
-              </a:rPr>
-              <a:t>Accessing </a:t>
-            </a:r>
-          </a:p>
-          <a:p>
-            <a:r>
-              <a:rPr lang="en-US" dirty="0">
-                <a:latin typeface="YaleNew" panose="02000602050000020003" pitchFamily="2" charset="77"/>
-              </a:rPr>
-              <a:t>Data</a:t>
-            </a:r>
-          </a:p>
-        </p:txBody>
-      </p:sp>
-      <p:sp>
-        <p:nvSpPr>
-          <p:cNvPr id="4" name="Text Placeholder 3">
-            <a:extLst>
-              <a:ext uri="{FF2B5EF4-FFF2-40B4-BE49-F238E27FC236}">
-                <a16:creationId xmlns:a16="http://schemas.microsoft.com/office/drawing/2014/main" id="{2C0E88D1-7BB3-C90E-3DDC-48BA3992414D}"/>
-              </a:ext>
-            </a:extLst>
-          </p:cNvPr>
-          <p:cNvSpPr>
-            <a:spLocks noGrp="1"/>
-          </p:cNvSpPr>
-          <p:nvPr>
-            <p:ph type="body" sz="quarter" idx="15"/>
-          </p:nvPr>
-        </p:nvSpPr>
-        <p:spPr>
-          <a:xfrm>
-            <a:off x="497984" y="3185056"/>
-            <a:ext cx="3281536" cy="3171294"/>
-          </a:xfrm>
-        </p:spPr>
-        <p:txBody>
-          <a:bodyPr/>
-          <a:lstStyle/>
-          <a:p>
-            <a:r>
-              <a:rPr lang="en-US" dirty="0"/>
-              <a:t>Observational Medical Outcomes Partnership (OMOP) CDM Concepts</a:t>
-            </a:r>
-          </a:p>
-          <a:p>
-            <a:endParaRPr lang="en-US" dirty="0"/>
-          </a:p>
-          <a:p>
-            <a:r>
-              <a:rPr lang="en-US" altLang="en-US" i="0" dirty="0"/>
-              <a:t>SNOMED-CT and OMOP CDM</a:t>
-            </a:r>
-          </a:p>
-        </p:txBody>
-      </p:sp>
-      <p:sp>
-        <p:nvSpPr>
-          <p:cNvPr id="5" name="Slide Number Placeholder 4">
-            <a:extLst>
-              <a:ext uri="{FF2B5EF4-FFF2-40B4-BE49-F238E27FC236}">
-                <a16:creationId xmlns:a16="http://schemas.microsoft.com/office/drawing/2014/main" id="{2DF4A532-A937-E61A-C4D3-66AADD1512F5}"/>
-              </a:ext>
-            </a:extLst>
-          </p:cNvPr>
-          <p:cNvSpPr>
-            <a:spLocks noGrp="1"/>
-          </p:cNvSpPr>
-          <p:nvPr>
-            <p:ph type="sldNum" sz="quarter" idx="18"/>
-          </p:nvPr>
-        </p:nvSpPr>
-        <p:spPr/>
-        <p:txBody>
-          <a:bodyPr/>
-          <a:lstStyle/>
-          <a:p>
-            <a:fld id="{548469FB-C78A-B94B-B04A-B5BC8C934F85}" type="slidenum">
-              <a:rPr lang="en-US" smtClean="0"/>
-              <a:t>29</a:t>
-            </a:fld>
-            <a:endParaRPr lang="en-US"/>
-          </a:p>
-        </p:txBody>
-      </p:sp>
-      <p:sp>
-        <p:nvSpPr>
-          <p:cNvPr id="2" name="TextBox 1">
-            <a:extLst>
-              <a:ext uri="{FF2B5EF4-FFF2-40B4-BE49-F238E27FC236}">
-                <a16:creationId xmlns:a16="http://schemas.microsoft.com/office/drawing/2014/main" id="{F36FD501-EB22-A0C8-7B41-6299FD690A13}"/>
-              </a:ext>
-            </a:extLst>
-          </p:cNvPr>
-          <p:cNvSpPr txBox="1"/>
-          <p:nvPr/>
-        </p:nvSpPr>
-        <p:spPr>
-          <a:xfrm>
-            <a:off x="4753811" y="573771"/>
-            <a:ext cx="6599989" cy="5940088"/>
-          </a:xfrm>
-          <a:prstGeom prst="rect">
-            <a:avLst/>
-          </a:prstGeom>
-          <a:noFill/>
-        </p:spPr>
-        <p:txBody>
-          <a:bodyPr wrap="square" rtlCol="0">
-            <a:spAutoFit/>
-          </a:bodyPr>
-          <a:lstStyle/>
-          <a:p>
-            <a:r>
-              <a:rPr lang="en-US" b="1" dirty="0">
-                <a:latin typeface="Avenir Book" panose="02000503020000020003" pitchFamily="2" charset="0"/>
-              </a:rPr>
-              <a:t>Domains that use SNOMED-CT, </a:t>
-            </a:r>
-            <a:r>
-              <a:rPr lang="en-US" altLang="en-US" dirty="0">
-                <a:solidFill>
-                  <a:srgbClr val="000000"/>
-                </a:solidFill>
-                <a:latin typeface="Avenir Book" panose="02000503020000020003" pitchFamily="2" charset="0"/>
-              </a:rPr>
-              <a:t>often use disparate, non-standard </a:t>
-            </a:r>
-            <a:r>
-              <a:rPr lang="en-US" altLang="en-US" b="1" dirty="0">
-                <a:solidFill>
-                  <a:srgbClr val="000000"/>
-                </a:solidFill>
-                <a:latin typeface="Avenir Book" panose="02000503020000020003" pitchFamily="2" charset="0"/>
-              </a:rPr>
-              <a:t>source codes</a:t>
-            </a:r>
-            <a:r>
-              <a:rPr lang="en-US" altLang="en-US" dirty="0">
-                <a:solidFill>
-                  <a:srgbClr val="000000"/>
-                </a:solidFill>
-                <a:latin typeface="Avenir Book" panose="02000503020000020003" pitchFamily="2" charset="0"/>
-              </a:rPr>
-              <a:t> primarily designed for billing</a:t>
-            </a:r>
-            <a:endParaRPr lang="en-US" altLang="en-US" dirty="0">
-              <a:latin typeface="Avenir Book" panose="02000503020000020003" pitchFamily="2" charset="0"/>
-            </a:endParaRPr>
-          </a:p>
-          <a:p>
-            <a:endParaRPr lang="en-US" dirty="0">
-              <a:latin typeface="Avenir Book" panose="02000503020000020003" pitchFamily="2" charset="0"/>
-            </a:endParaRPr>
-          </a:p>
-          <a:p>
-            <a:r>
-              <a:rPr lang="en-US" dirty="0">
-                <a:latin typeface="Avenir Book" panose="02000503020000020003" pitchFamily="2" charset="0"/>
-              </a:rPr>
-              <a:t>Source codes include:</a:t>
-            </a:r>
-          </a:p>
-          <a:p>
-            <a:pPr marL="285750" indent="-285750">
-              <a:buFont typeface="Arial" panose="020B0604020202020204" pitchFamily="34" charset="0"/>
-              <a:buChar char="•"/>
-            </a:pPr>
-            <a:r>
-              <a:rPr lang="en-US" altLang="en-US" dirty="0">
-                <a:solidFill>
-                  <a:srgbClr val="000000"/>
-                </a:solidFill>
-                <a:latin typeface="Avenir Book" panose="02000503020000020003" pitchFamily="2" charset="0"/>
-              </a:rPr>
-              <a:t>ICD9/10 (</a:t>
-            </a:r>
-            <a:r>
-              <a:rPr lang="en-US" dirty="0">
-                <a:latin typeface="Avenir Book" panose="02000503020000020003" pitchFamily="2" charset="0"/>
-              </a:rPr>
-              <a:t>international Classification of Diseases)</a:t>
-            </a:r>
-            <a:endParaRPr lang="en-US" altLang="en-US" dirty="0">
-              <a:solidFill>
-                <a:srgbClr val="000000"/>
-              </a:solidFill>
-              <a:latin typeface="Avenir Book" panose="02000503020000020003" pitchFamily="2" charset="0"/>
-            </a:endParaRPr>
-          </a:p>
-          <a:p>
-            <a:pPr marL="285750" indent="-285750">
-              <a:buFont typeface="Arial" panose="020B0604020202020204" pitchFamily="34" charset="0"/>
-              <a:buChar char="•"/>
-            </a:pPr>
-            <a:r>
-              <a:rPr lang="en-US" altLang="en-US" dirty="0">
-                <a:solidFill>
-                  <a:srgbClr val="000000"/>
-                </a:solidFill>
-                <a:latin typeface="Avenir Book" panose="02000503020000020003" pitchFamily="2" charset="0"/>
-              </a:rPr>
-              <a:t>CPT4 (</a:t>
-            </a:r>
-            <a:r>
-              <a:rPr lang="en-US" dirty="0">
-                <a:latin typeface="Avenir Book" panose="02000503020000020003" pitchFamily="2" charset="0"/>
-              </a:rPr>
-              <a:t>Current Procedural Terminology)</a:t>
-            </a:r>
-            <a:endParaRPr lang="en-US" altLang="en-US" dirty="0">
-              <a:solidFill>
-                <a:srgbClr val="000000"/>
-              </a:solidFill>
-              <a:latin typeface="Avenir Book" panose="02000503020000020003" pitchFamily="2" charset="0"/>
-            </a:endParaRPr>
-          </a:p>
-          <a:p>
-            <a:pPr marL="285750" indent="-285750">
-              <a:buFont typeface="Arial" panose="020B0604020202020204" pitchFamily="34" charset="0"/>
-              <a:buChar char="•"/>
-            </a:pPr>
-            <a:r>
-              <a:rPr lang="en-US" dirty="0">
-                <a:latin typeface="Avenir Book" panose="02000503020000020003" pitchFamily="2" charset="0"/>
-              </a:rPr>
-              <a:t>Local/Proprietary Codes</a:t>
-            </a:r>
-          </a:p>
-          <a:p>
-            <a:pPr marL="285750" indent="-285750">
-              <a:buFont typeface="Arial" panose="020B0604020202020204" pitchFamily="34" charset="0"/>
-              <a:buChar char="•"/>
-            </a:pPr>
-            <a:r>
-              <a:rPr lang="en-US" dirty="0">
-                <a:latin typeface="Avenir Book" panose="02000503020000020003" pitchFamily="2" charset="0"/>
-              </a:rPr>
-              <a:t>Source SNOMED-CT</a:t>
-            </a:r>
-            <a:endParaRPr lang="en-US" altLang="en-US" dirty="0">
-              <a:solidFill>
-                <a:srgbClr val="000000"/>
-              </a:solidFill>
-              <a:latin typeface="Avenir Book" panose="02000503020000020003" pitchFamily="2" charset="0"/>
-            </a:endParaRPr>
-          </a:p>
-          <a:p>
-            <a:endParaRPr lang="en-US" altLang="en-US" b="1" dirty="0">
-              <a:solidFill>
-                <a:srgbClr val="000000"/>
-              </a:solidFill>
-              <a:latin typeface="Avenir Book" panose="02000503020000020003" pitchFamily="2" charset="0"/>
-            </a:endParaRPr>
-          </a:p>
-          <a:p>
-            <a:r>
-              <a:rPr lang="en-US" altLang="en-US" dirty="0">
-                <a:solidFill>
-                  <a:srgbClr val="000000"/>
-                </a:solidFill>
-                <a:latin typeface="Avenir Book" panose="02000503020000020003" pitchFamily="2" charset="0"/>
-              </a:rPr>
-              <a:t>SNOMED-CT is designated as the standard for OMOP Concept IDs because of its </a:t>
-            </a:r>
-            <a:r>
-              <a:rPr lang="en-US" altLang="en-US" b="1" dirty="0">
-                <a:solidFill>
-                  <a:srgbClr val="000000"/>
-                </a:solidFill>
-                <a:latin typeface="Avenir Book" panose="02000503020000020003" pitchFamily="2" charset="0"/>
-              </a:rPr>
-              <a:t>hierarchal structure</a:t>
-            </a:r>
-            <a:r>
-              <a:rPr lang="en-US" altLang="en-US" dirty="0">
-                <a:solidFill>
-                  <a:srgbClr val="000000"/>
-                </a:solidFill>
-                <a:latin typeface="Avenir Book" panose="02000503020000020003" pitchFamily="2" charset="0"/>
-              </a:rPr>
-              <a:t> and </a:t>
-            </a:r>
-            <a:r>
-              <a:rPr lang="en-US" altLang="en-US" b="1" dirty="0">
-                <a:solidFill>
-                  <a:srgbClr val="000000"/>
-                </a:solidFill>
-                <a:latin typeface="Avenir Book" panose="02000503020000020003" pitchFamily="2" charset="0"/>
-              </a:rPr>
-              <a:t>clinical granularity</a:t>
-            </a:r>
-          </a:p>
-          <a:p>
-            <a:endParaRPr lang="en-US" altLang="en-US" b="1" dirty="0">
-              <a:solidFill>
-                <a:srgbClr val="000000"/>
-              </a:solidFill>
-              <a:latin typeface="Avenir Book" panose="02000503020000020003" pitchFamily="2" charset="0"/>
-            </a:endParaRPr>
-          </a:p>
-          <a:p>
-            <a:r>
-              <a:rPr lang="en-US" altLang="en-US" b="1" dirty="0">
-                <a:solidFill>
-                  <a:srgbClr val="000000"/>
-                </a:solidFill>
-                <a:latin typeface="Avenir Book" panose="02000503020000020003" pitchFamily="2" charset="0"/>
-              </a:rPr>
-              <a:t>This way </a:t>
-            </a:r>
-            <a:r>
-              <a:rPr lang="en-US" altLang="en-US" dirty="0">
-                <a:solidFill>
-                  <a:srgbClr val="000000"/>
-                </a:solidFill>
-                <a:latin typeface="Avenir Book" panose="02000503020000020003" pitchFamily="2" charset="0"/>
-              </a:rPr>
-              <a:t>a patient coded with </a:t>
-            </a:r>
-            <a:r>
-              <a:rPr lang="en-US" altLang="en-US" b="1" dirty="0">
-                <a:solidFill>
-                  <a:srgbClr val="000000"/>
-                </a:solidFill>
-                <a:latin typeface="Avenir Book" panose="02000503020000020003" pitchFamily="2" charset="0"/>
-              </a:rPr>
-              <a:t>ICD-10</a:t>
-            </a:r>
-            <a:r>
-              <a:rPr lang="en-US" altLang="en-US" dirty="0">
-                <a:solidFill>
-                  <a:srgbClr val="000000"/>
-                </a:solidFill>
-                <a:latin typeface="Avenir Book" panose="02000503020000020003" pitchFamily="2" charset="0"/>
-              </a:rPr>
-              <a:t> in one site maps to the </a:t>
-            </a:r>
-            <a:r>
-              <a:rPr lang="en-US" altLang="en-US" b="1" dirty="0">
-                <a:solidFill>
-                  <a:srgbClr val="000000"/>
-                </a:solidFill>
-                <a:latin typeface="Avenir Book" panose="02000503020000020003" pitchFamily="2" charset="0"/>
-              </a:rPr>
-              <a:t>exact same ID</a:t>
-            </a:r>
-            <a:r>
-              <a:rPr lang="en-US" altLang="en-US" dirty="0">
-                <a:solidFill>
-                  <a:srgbClr val="000000"/>
-                </a:solidFill>
-                <a:latin typeface="Avenir Book" panose="02000503020000020003" pitchFamily="2" charset="0"/>
-              </a:rPr>
-              <a:t> as a patient coded with </a:t>
-            </a:r>
-            <a:r>
-              <a:rPr lang="en-US" altLang="en-US" b="1" dirty="0">
-                <a:solidFill>
-                  <a:srgbClr val="000000"/>
-                </a:solidFill>
-                <a:latin typeface="Avenir Book" panose="02000503020000020003" pitchFamily="2" charset="0"/>
-              </a:rPr>
-              <a:t>SNOMED CT</a:t>
-            </a:r>
-            <a:r>
-              <a:rPr lang="en-US" altLang="en-US" dirty="0">
-                <a:solidFill>
-                  <a:srgbClr val="000000"/>
-                </a:solidFill>
-                <a:latin typeface="Avenir Book" panose="02000503020000020003" pitchFamily="2" charset="0"/>
-              </a:rPr>
-              <a:t> in another site</a:t>
-            </a:r>
-            <a:endParaRPr lang="en-US" altLang="en-US" dirty="0">
-              <a:latin typeface="Avenir Book" panose="02000503020000020003" pitchFamily="2" charset="0"/>
-            </a:endParaRPr>
-          </a:p>
-          <a:p>
-            <a:endParaRPr lang="en-US" altLang="en-US" b="1" dirty="0">
-              <a:solidFill>
-                <a:srgbClr val="000000"/>
-              </a:solidFill>
-              <a:latin typeface="Avenir Book" panose="02000503020000020003" pitchFamily="2" charset="0"/>
-            </a:endParaRPr>
-          </a:p>
-          <a:p>
-            <a:r>
-              <a:rPr lang="en-US" altLang="en-US" sz="2800" b="1" dirty="0">
-                <a:latin typeface="Avenir Book" panose="02000503020000020003" pitchFamily="2" charset="0"/>
-              </a:rPr>
-              <a:t>*Explore these standardized vocabularies through </a:t>
-            </a:r>
-            <a:r>
-              <a:rPr lang="en-US" altLang="en-US" sz="2800" b="1" dirty="0">
-                <a:latin typeface="Avenir Book" panose="02000503020000020003" pitchFamily="2" charset="0"/>
-                <a:hlinkClick r:id="rId3"/>
-              </a:rPr>
-              <a:t>Athena</a:t>
-            </a:r>
-            <a:endParaRPr lang="en-US" altLang="en-US" sz="2800" b="1" dirty="0">
-              <a:latin typeface="Avenir Book" panose="02000503020000020003" pitchFamily="2" charset="0"/>
-            </a:endParaRPr>
-          </a:p>
-          <a:p>
-            <a:endParaRPr lang="en-US" altLang="en-US" b="1" dirty="0">
-              <a:solidFill>
-                <a:srgbClr val="000000"/>
-              </a:solidFill>
-              <a:latin typeface="Avenir Book" panose="02000503020000020003" pitchFamily="2" charset="0"/>
-            </a:endParaRPr>
-          </a:p>
-        </p:txBody>
-      </p:sp>
-    </p:spTree>
-    <p:extLst>
-      <p:ext uri="{BB962C8B-B14F-4D97-AF65-F5344CB8AC3E}">
-        <p14:creationId xmlns:p14="http://schemas.microsoft.com/office/powerpoint/2010/main" val="3368575850"/>
       </p:ext>
     </p:extLst>
   </p:cSld>
@@ -29417,6 +29172,480 @@
   <p:cSld>
     <p:spTree>
       <p:nvGrpSpPr>
+        <p:cNvPr id="1" name="">
+          <a:extLst>
+            <a:ext uri="{FF2B5EF4-FFF2-40B4-BE49-F238E27FC236}">
+              <a16:creationId xmlns:a16="http://schemas.microsoft.com/office/drawing/2014/main" id="{37760B17-F039-67A5-0AB0-2DAC061E5A60}"/>
+            </a:ext>
+          </a:extLst>
+        </p:cNvPr>
+        <p:cNvGrpSpPr/>
+        <p:nvPr/>
+      </p:nvGrpSpPr>
+      <p:grpSpPr>
+        <a:xfrm>
+          <a:off x="0" y="0"/>
+          <a:ext cx="0" cy="0"/>
+          <a:chOff x="0" y="0"/>
+          <a:chExt cx="0" cy="0"/>
+        </a:xfrm>
+      </p:grpSpPr>
+      <p:sp>
+        <p:nvSpPr>
+          <p:cNvPr id="3" name="Text Placeholder 2">
+            <a:extLst>
+              <a:ext uri="{FF2B5EF4-FFF2-40B4-BE49-F238E27FC236}">
+                <a16:creationId xmlns:a16="http://schemas.microsoft.com/office/drawing/2014/main" id="{4259CA2D-73EF-9212-B21A-644BD13C35AA}"/>
+              </a:ext>
+            </a:extLst>
+          </p:cNvPr>
+          <p:cNvSpPr>
+            <a:spLocks noGrp="1"/>
+          </p:cNvSpPr>
+          <p:nvPr>
+            <p:ph type="body" sz="quarter" idx="11"/>
+          </p:nvPr>
+        </p:nvSpPr>
+        <p:spPr/>
+        <p:txBody>
+          <a:bodyPr/>
+          <a:lstStyle/>
+          <a:p>
+            <a:r>
+              <a:rPr lang="en-US" dirty="0">
+                <a:latin typeface="YaleNew" panose="02000602050000020003" pitchFamily="2" charset="77"/>
+              </a:rPr>
+              <a:t>Accessing </a:t>
+            </a:r>
+          </a:p>
+          <a:p>
+            <a:r>
+              <a:rPr lang="en-US" dirty="0">
+                <a:latin typeface="YaleNew" panose="02000602050000020003" pitchFamily="2" charset="77"/>
+              </a:rPr>
+              <a:t>Data</a:t>
+            </a:r>
+          </a:p>
+        </p:txBody>
+      </p:sp>
+      <p:sp>
+        <p:nvSpPr>
+          <p:cNvPr id="4" name="Text Placeholder 3">
+            <a:extLst>
+              <a:ext uri="{FF2B5EF4-FFF2-40B4-BE49-F238E27FC236}">
+                <a16:creationId xmlns:a16="http://schemas.microsoft.com/office/drawing/2014/main" id="{2C0E88D1-7BB3-C90E-3DDC-48BA3992414D}"/>
+              </a:ext>
+            </a:extLst>
+          </p:cNvPr>
+          <p:cNvSpPr>
+            <a:spLocks noGrp="1"/>
+          </p:cNvSpPr>
+          <p:nvPr>
+            <p:ph type="body" sz="quarter" idx="15"/>
+          </p:nvPr>
+        </p:nvSpPr>
+        <p:spPr>
+          <a:xfrm>
+            <a:off x="497984" y="3185056"/>
+            <a:ext cx="3281536" cy="3171294"/>
+          </a:xfrm>
+        </p:spPr>
+        <p:txBody>
+          <a:bodyPr/>
+          <a:lstStyle/>
+          <a:p>
+            <a:r>
+              <a:rPr lang="en-US" dirty="0"/>
+              <a:t>Observational Medical Outcomes Partnership (OMOP) CDM Concepts</a:t>
+            </a:r>
+          </a:p>
+          <a:p>
+            <a:endParaRPr lang="en-US" dirty="0"/>
+          </a:p>
+          <a:p>
+            <a:r>
+              <a:rPr lang="en-US" altLang="en-US" i="0" dirty="0"/>
+              <a:t>SNOMED-CT and OMOP CDM</a:t>
+            </a:r>
+          </a:p>
+        </p:txBody>
+      </p:sp>
+      <p:sp>
+        <p:nvSpPr>
+          <p:cNvPr id="5" name="Slide Number Placeholder 4">
+            <a:extLst>
+              <a:ext uri="{FF2B5EF4-FFF2-40B4-BE49-F238E27FC236}">
+                <a16:creationId xmlns:a16="http://schemas.microsoft.com/office/drawing/2014/main" id="{2DF4A532-A937-E61A-C4D3-66AADD1512F5}"/>
+              </a:ext>
+            </a:extLst>
+          </p:cNvPr>
+          <p:cNvSpPr>
+            <a:spLocks noGrp="1"/>
+          </p:cNvSpPr>
+          <p:nvPr>
+            <p:ph type="sldNum" sz="quarter" idx="18"/>
+          </p:nvPr>
+        </p:nvSpPr>
+        <p:spPr/>
+        <p:txBody>
+          <a:bodyPr/>
+          <a:lstStyle/>
+          <a:p>
+            <a:fld id="{548469FB-C78A-B94B-B04A-B5BC8C934F85}" type="slidenum">
+              <a:rPr lang="en-US" smtClean="0"/>
+              <a:t>30</a:t>
+            </a:fld>
+            <a:endParaRPr lang="en-US"/>
+          </a:p>
+        </p:txBody>
+      </p:sp>
+      <p:sp>
+        <p:nvSpPr>
+          <p:cNvPr id="2" name="TextBox 1">
+            <a:extLst>
+              <a:ext uri="{FF2B5EF4-FFF2-40B4-BE49-F238E27FC236}">
+                <a16:creationId xmlns:a16="http://schemas.microsoft.com/office/drawing/2014/main" id="{F36FD501-EB22-A0C8-7B41-6299FD690A13}"/>
+              </a:ext>
+            </a:extLst>
+          </p:cNvPr>
+          <p:cNvSpPr txBox="1"/>
+          <p:nvPr/>
+        </p:nvSpPr>
+        <p:spPr>
+          <a:xfrm>
+            <a:off x="4753811" y="573771"/>
+            <a:ext cx="6599989" cy="5940088"/>
+          </a:xfrm>
+          <a:prstGeom prst="rect">
+            <a:avLst/>
+          </a:prstGeom>
+          <a:noFill/>
+        </p:spPr>
+        <p:txBody>
+          <a:bodyPr wrap="square" rtlCol="0">
+            <a:spAutoFit/>
+          </a:bodyPr>
+          <a:lstStyle/>
+          <a:p>
+            <a:r>
+              <a:rPr lang="en-US" b="1" dirty="0">
+                <a:latin typeface="Avenir Book" panose="02000503020000020003" pitchFamily="2" charset="0"/>
+              </a:rPr>
+              <a:t>Domains that use SNOMED-CT, </a:t>
+            </a:r>
+            <a:r>
+              <a:rPr lang="en-US" altLang="en-US" dirty="0">
+                <a:solidFill>
+                  <a:srgbClr val="000000"/>
+                </a:solidFill>
+                <a:latin typeface="Avenir Book" panose="02000503020000020003" pitchFamily="2" charset="0"/>
+              </a:rPr>
+              <a:t>often use disparate, non-standard </a:t>
+            </a:r>
+            <a:r>
+              <a:rPr lang="en-US" altLang="en-US" b="1" dirty="0">
+                <a:solidFill>
+                  <a:srgbClr val="000000"/>
+                </a:solidFill>
+                <a:latin typeface="Avenir Book" panose="02000503020000020003" pitchFamily="2" charset="0"/>
+              </a:rPr>
+              <a:t>source codes</a:t>
+            </a:r>
+            <a:r>
+              <a:rPr lang="en-US" altLang="en-US" dirty="0">
+                <a:solidFill>
+                  <a:srgbClr val="000000"/>
+                </a:solidFill>
+                <a:latin typeface="Avenir Book" panose="02000503020000020003" pitchFamily="2" charset="0"/>
+              </a:rPr>
+              <a:t> primarily designed for billing</a:t>
+            </a:r>
+            <a:endParaRPr lang="en-US" altLang="en-US" dirty="0">
+              <a:latin typeface="Avenir Book" panose="02000503020000020003" pitchFamily="2" charset="0"/>
+            </a:endParaRPr>
+          </a:p>
+          <a:p>
+            <a:endParaRPr lang="en-US" dirty="0">
+              <a:latin typeface="Avenir Book" panose="02000503020000020003" pitchFamily="2" charset="0"/>
+            </a:endParaRPr>
+          </a:p>
+          <a:p>
+            <a:r>
+              <a:rPr lang="en-US" dirty="0">
+                <a:latin typeface="Avenir Book" panose="02000503020000020003" pitchFamily="2" charset="0"/>
+              </a:rPr>
+              <a:t>Source codes include:</a:t>
+            </a:r>
+          </a:p>
+          <a:p>
+            <a:pPr marL="285750" indent="-285750">
+              <a:buFont typeface="Arial" panose="020B0604020202020204" pitchFamily="34" charset="0"/>
+              <a:buChar char="•"/>
+            </a:pPr>
+            <a:r>
+              <a:rPr lang="en-US" altLang="en-US" dirty="0">
+                <a:solidFill>
+                  <a:srgbClr val="000000"/>
+                </a:solidFill>
+                <a:latin typeface="Avenir Book" panose="02000503020000020003" pitchFamily="2" charset="0"/>
+              </a:rPr>
+              <a:t>ICD9/10 (</a:t>
+            </a:r>
+            <a:r>
+              <a:rPr lang="en-US" dirty="0">
+                <a:latin typeface="Avenir Book" panose="02000503020000020003" pitchFamily="2" charset="0"/>
+              </a:rPr>
+              <a:t>international Classification of Diseases)</a:t>
+            </a:r>
+            <a:endParaRPr lang="en-US" altLang="en-US" dirty="0">
+              <a:solidFill>
+                <a:srgbClr val="000000"/>
+              </a:solidFill>
+              <a:latin typeface="Avenir Book" panose="02000503020000020003" pitchFamily="2" charset="0"/>
+            </a:endParaRPr>
+          </a:p>
+          <a:p>
+            <a:pPr marL="285750" indent="-285750">
+              <a:buFont typeface="Arial" panose="020B0604020202020204" pitchFamily="34" charset="0"/>
+              <a:buChar char="•"/>
+            </a:pPr>
+            <a:r>
+              <a:rPr lang="en-US" altLang="en-US" dirty="0">
+                <a:solidFill>
+                  <a:srgbClr val="000000"/>
+                </a:solidFill>
+                <a:latin typeface="Avenir Book" panose="02000503020000020003" pitchFamily="2" charset="0"/>
+              </a:rPr>
+              <a:t>CPT4 (</a:t>
+            </a:r>
+            <a:r>
+              <a:rPr lang="en-US" dirty="0">
+                <a:latin typeface="Avenir Book" panose="02000503020000020003" pitchFamily="2" charset="0"/>
+              </a:rPr>
+              <a:t>Current Procedural Terminology)</a:t>
+            </a:r>
+            <a:endParaRPr lang="en-US" altLang="en-US" dirty="0">
+              <a:solidFill>
+                <a:srgbClr val="000000"/>
+              </a:solidFill>
+              <a:latin typeface="Avenir Book" panose="02000503020000020003" pitchFamily="2" charset="0"/>
+            </a:endParaRPr>
+          </a:p>
+          <a:p>
+            <a:pPr marL="285750" indent="-285750">
+              <a:buFont typeface="Arial" panose="020B0604020202020204" pitchFamily="34" charset="0"/>
+              <a:buChar char="•"/>
+            </a:pPr>
+            <a:r>
+              <a:rPr lang="en-US" dirty="0">
+                <a:latin typeface="Avenir Book" panose="02000503020000020003" pitchFamily="2" charset="0"/>
+              </a:rPr>
+              <a:t>Local/Proprietary Codes</a:t>
+            </a:r>
+          </a:p>
+          <a:p>
+            <a:pPr marL="285750" indent="-285750">
+              <a:buFont typeface="Arial" panose="020B0604020202020204" pitchFamily="34" charset="0"/>
+              <a:buChar char="•"/>
+            </a:pPr>
+            <a:r>
+              <a:rPr lang="en-US" dirty="0">
+                <a:latin typeface="Avenir Book" panose="02000503020000020003" pitchFamily="2" charset="0"/>
+              </a:rPr>
+              <a:t>Source SNOMED-CT</a:t>
+            </a:r>
+            <a:endParaRPr lang="en-US" altLang="en-US" dirty="0">
+              <a:solidFill>
+                <a:srgbClr val="000000"/>
+              </a:solidFill>
+              <a:latin typeface="Avenir Book" panose="02000503020000020003" pitchFamily="2" charset="0"/>
+            </a:endParaRPr>
+          </a:p>
+          <a:p>
+            <a:endParaRPr lang="en-US" altLang="en-US" b="1" dirty="0">
+              <a:solidFill>
+                <a:srgbClr val="000000"/>
+              </a:solidFill>
+              <a:latin typeface="Avenir Book" panose="02000503020000020003" pitchFamily="2" charset="0"/>
+            </a:endParaRPr>
+          </a:p>
+          <a:p>
+            <a:r>
+              <a:rPr lang="en-US" altLang="en-US" dirty="0">
+                <a:solidFill>
+                  <a:srgbClr val="000000"/>
+                </a:solidFill>
+                <a:latin typeface="Avenir Book" panose="02000503020000020003" pitchFamily="2" charset="0"/>
+              </a:rPr>
+              <a:t>SNOMED-CT is designated as the standard for OMOP Concept IDs because of its </a:t>
+            </a:r>
+            <a:r>
+              <a:rPr lang="en-US" altLang="en-US" b="1" dirty="0">
+                <a:solidFill>
+                  <a:srgbClr val="000000"/>
+                </a:solidFill>
+                <a:latin typeface="Avenir Book" panose="02000503020000020003" pitchFamily="2" charset="0"/>
+              </a:rPr>
+              <a:t>hierarchal structure</a:t>
+            </a:r>
+            <a:r>
+              <a:rPr lang="en-US" altLang="en-US" dirty="0">
+                <a:solidFill>
+                  <a:srgbClr val="000000"/>
+                </a:solidFill>
+                <a:latin typeface="Avenir Book" panose="02000503020000020003" pitchFamily="2" charset="0"/>
+              </a:rPr>
+              <a:t> and </a:t>
+            </a:r>
+            <a:r>
+              <a:rPr lang="en-US" altLang="en-US" b="1" dirty="0">
+                <a:solidFill>
+                  <a:srgbClr val="000000"/>
+                </a:solidFill>
+                <a:latin typeface="Avenir Book" panose="02000503020000020003" pitchFamily="2" charset="0"/>
+              </a:rPr>
+              <a:t>clinical granularity</a:t>
+            </a:r>
+          </a:p>
+          <a:p>
+            <a:endParaRPr lang="en-US" altLang="en-US" b="1" dirty="0">
+              <a:solidFill>
+                <a:srgbClr val="000000"/>
+              </a:solidFill>
+              <a:latin typeface="Avenir Book" panose="02000503020000020003" pitchFamily="2" charset="0"/>
+            </a:endParaRPr>
+          </a:p>
+          <a:p>
+            <a:r>
+              <a:rPr lang="en-US" altLang="en-US" b="1" dirty="0">
+                <a:solidFill>
+                  <a:srgbClr val="000000"/>
+                </a:solidFill>
+                <a:latin typeface="Avenir Book" panose="02000503020000020003" pitchFamily="2" charset="0"/>
+              </a:rPr>
+              <a:t>This way </a:t>
+            </a:r>
+            <a:r>
+              <a:rPr lang="en-US" altLang="en-US" dirty="0">
+                <a:solidFill>
+                  <a:srgbClr val="000000"/>
+                </a:solidFill>
+                <a:latin typeface="Avenir Book" panose="02000503020000020003" pitchFamily="2" charset="0"/>
+              </a:rPr>
+              <a:t>a patient coded with </a:t>
+            </a:r>
+            <a:r>
+              <a:rPr lang="en-US" altLang="en-US" b="1" dirty="0">
+                <a:solidFill>
+                  <a:srgbClr val="000000"/>
+                </a:solidFill>
+                <a:latin typeface="Avenir Book" panose="02000503020000020003" pitchFamily="2" charset="0"/>
+              </a:rPr>
+              <a:t>ICD-10</a:t>
+            </a:r>
+            <a:r>
+              <a:rPr lang="en-US" altLang="en-US" dirty="0">
+                <a:solidFill>
+                  <a:srgbClr val="000000"/>
+                </a:solidFill>
+                <a:latin typeface="Avenir Book" panose="02000503020000020003" pitchFamily="2" charset="0"/>
+              </a:rPr>
+              <a:t> in one site maps to the </a:t>
+            </a:r>
+            <a:r>
+              <a:rPr lang="en-US" altLang="en-US" b="1" dirty="0">
+                <a:solidFill>
+                  <a:srgbClr val="000000"/>
+                </a:solidFill>
+                <a:latin typeface="Avenir Book" panose="02000503020000020003" pitchFamily="2" charset="0"/>
+              </a:rPr>
+              <a:t>exact same ID</a:t>
+            </a:r>
+            <a:r>
+              <a:rPr lang="en-US" altLang="en-US" dirty="0">
+                <a:solidFill>
+                  <a:srgbClr val="000000"/>
+                </a:solidFill>
+                <a:latin typeface="Avenir Book" panose="02000503020000020003" pitchFamily="2" charset="0"/>
+              </a:rPr>
+              <a:t> as a patient coded with </a:t>
+            </a:r>
+            <a:r>
+              <a:rPr lang="en-US" altLang="en-US" b="1" dirty="0">
+                <a:solidFill>
+                  <a:srgbClr val="000000"/>
+                </a:solidFill>
+                <a:latin typeface="Avenir Book" panose="02000503020000020003" pitchFamily="2" charset="0"/>
+              </a:rPr>
+              <a:t>SNOMED CT</a:t>
+            </a:r>
+            <a:r>
+              <a:rPr lang="en-US" altLang="en-US" dirty="0">
+                <a:solidFill>
+                  <a:srgbClr val="000000"/>
+                </a:solidFill>
+                <a:latin typeface="Avenir Book" panose="02000503020000020003" pitchFamily="2" charset="0"/>
+              </a:rPr>
+              <a:t> in another site</a:t>
+            </a:r>
+            <a:endParaRPr lang="en-US" altLang="en-US" dirty="0">
+              <a:latin typeface="Avenir Book" panose="02000503020000020003" pitchFamily="2" charset="0"/>
+            </a:endParaRPr>
+          </a:p>
+          <a:p>
+            <a:endParaRPr lang="en-US" altLang="en-US" b="1" dirty="0">
+              <a:solidFill>
+                <a:srgbClr val="000000"/>
+              </a:solidFill>
+              <a:latin typeface="Avenir Book" panose="02000503020000020003" pitchFamily="2" charset="0"/>
+            </a:endParaRPr>
+          </a:p>
+          <a:p>
+            <a:r>
+              <a:rPr lang="en-US" altLang="en-US" sz="2800" b="1" dirty="0">
+                <a:latin typeface="Avenir Book" panose="02000503020000020003" pitchFamily="2" charset="0"/>
+              </a:rPr>
+              <a:t>*Explore these standardized vocabularies through </a:t>
+            </a:r>
+            <a:r>
+              <a:rPr lang="en-US" altLang="en-US" sz="2800" b="1" dirty="0">
+                <a:latin typeface="Avenir Book" panose="02000503020000020003" pitchFamily="2" charset="0"/>
+                <a:hlinkClick r:id="rId3"/>
+              </a:rPr>
+              <a:t>Athena</a:t>
+            </a:r>
+            <a:endParaRPr lang="en-US" altLang="en-US" sz="2800" b="1" dirty="0">
+              <a:latin typeface="Avenir Book" panose="02000503020000020003" pitchFamily="2" charset="0"/>
+            </a:endParaRPr>
+          </a:p>
+          <a:p>
+            <a:endParaRPr lang="en-US" altLang="en-US" b="1" dirty="0">
+              <a:solidFill>
+                <a:srgbClr val="000000"/>
+              </a:solidFill>
+              <a:latin typeface="Avenir Book" panose="02000503020000020003" pitchFamily="2" charset="0"/>
+            </a:endParaRPr>
+          </a:p>
+        </p:txBody>
+      </p:sp>
+    </p:spTree>
+    <p:extLst>
+      <p:ext uri="{BB962C8B-B14F-4D97-AF65-F5344CB8AC3E}">
+        <p14:creationId xmlns:p14="http://schemas.microsoft.com/office/powerpoint/2010/main" val="3368575850"/>
+      </p:ext>
+    </p:extLst>
+  </p:cSld>
+  <p:clrMapOvr>
+    <a:masterClrMapping/>
+  </p:clrMapOvr>
+</p:sld>
+</file>
+
+<file path=ppt/slides/slide31.xml><?xml version="1.0" encoding="utf-8"?>
+<p:sld xmlns:a="http://schemas.openxmlformats.org/drawingml/2006/main" xmlns:r="http://schemas.openxmlformats.org/officeDocument/2006/relationships" xmlns:p="http://schemas.openxmlformats.org/presentationml/2006/main">
+  <p:cSld>
+    <p:spTree>
+      <p:nvGrpSpPr>
         <p:cNvPr id="1" name=""/>
         <p:cNvGrpSpPr/>
         <p:nvPr/>
@@ -29522,7 +29751,7 @@
 </p:sld>
 </file>
 
-<file path=ppt/slides/slide31.xml><?xml version="1.0" encoding="utf-8"?>
+<file path=ppt/slides/slide32.xml><?xml version="1.0" encoding="utf-8"?>
 <p:sld xmlns:a="http://schemas.openxmlformats.org/drawingml/2006/main" xmlns:r="http://schemas.openxmlformats.org/officeDocument/2006/relationships" xmlns:p="http://schemas.openxmlformats.org/presentationml/2006/main">
   <p:cSld>
     <p:spTree>
@@ -29632,7 +29861,7 @@
 </p:sld>
 </file>
 
-<file path=ppt/slides/slide32.xml><?xml version="1.0" encoding="utf-8"?>
+<file path=ppt/slides/slide33.xml><?xml version="1.0" encoding="utf-8"?>
 <p:sld xmlns:a="http://schemas.openxmlformats.org/drawingml/2006/main" xmlns:r="http://schemas.openxmlformats.org/officeDocument/2006/relationships" xmlns:p="http://schemas.openxmlformats.org/presentationml/2006/main">
   <p:cSld>
     <p:spTree>
@@ -29742,7 +29971,7 @@
 </p:sld>
 </file>
 
-<file path=ppt/slides/slide33.xml><?xml version="1.0" encoding="utf-8"?>
+<file path=ppt/slides/slide34.xml><?xml version="1.0" encoding="utf-8"?>
 <p:sld xmlns:a="http://schemas.openxmlformats.org/drawingml/2006/main" xmlns:r="http://schemas.openxmlformats.org/officeDocument/2006/relationships" xmlns:p="http://schemas.openxmlformats.org/presentationml/2006/main">
   <p:cSld>
     <p:spTree>
@@ -29900,7 +30129,7 @@
           <a:p>
             <a:fld id="{548469FB-C78A-B94B-B04A-B5BC8C934F85}" type="slidenum">
               <a:rPr lang="en-US" smtClean="0"/>
-              <a:t>33</a:t>
+              <a:t>34</a:t>
             </a:fld>
             <a:endParaRPr lang="en-US"/>
           </a:p>
@@ -30357,7 +30586,7 @@
 </p:sld>
 </file>
 
-<file path=ppt/slides/slide34.xml><?xml version="1.0" encoding="utf-8"?>
+<file path=ppt/slides/slide35.xml><?xml version="1.0" encoding="utf-8"?>
 <p:sld xmlns:a="http://schemas.openxmlformats.org/drawingml/2006/main" xmlns:r="http://schemas.openxmlformats.org/officeDocument/2006/relationships" xmlns:p="http://schemas.openxmlformats.org/presentationml/2006/main">
   <p:cSld>
     <p:spTree>
@@ -30527,7 +30756,7 @@
           <a:p>
             <a:fld id="{548469FB-C78A-B94B-B04A-B5BC8C934F85}" type="slidenum">
               <a:rPr lang="en-US" smtClean="0"/>
-              <a:t>34</a:t>
+              <a:t>35</a:t>
             </a:fld>
             <a:endParaRPr lang="en-US"/>
           </a:p>
@@ -30790,7 +31019,7 @@
 </p:sld>
 </file>
 
-<file path=ppt/slides/slide35.xml><?xml version="1.0" encoding="utf-8"?>
+<file path=ppt/slides/slide36.xml><?xml version="1.0" encoding="utf-8"?>
 <p:sld xmlns:a="http://schemas.openxmlformats.org/drawingml/2006/main" xmlns:r="http://schemas.openxmlformats.org/officeDocument/2006/relationships" xmlns:p="http://schemas.openxmlformats.org/presentationml/2006/main">
   <p:cSld>
     <p:spTree>
@@ -30900,7 +31129,7 @@
 </p:sld>
 </file>
 
-<file path=ppt/slides/slide36.xml><?xml version="1.0" encoding="utf-8"?>
+<file path=ppt/slides/slide37.xml><?xml version="1.0" encoding="utf-8"?>
 <p:sld xmlns:a="http://schemas.openxmlformats.org/drawingml/2006/main" xmlns:r="http://schemas.openxmlformats.org/officeDocument/2006/relationships" xmlns:p="http://schemas.openxmlformats.org/presentationml/2006/main">
   <p:cSld>
     <p:spTree>
@@ -31163,7 +31392,7 @@
           <a:p>
             <a:fld id="{548469FB-C78A-B94B-B04A-B5BC8C934F85}" type="slidenum">
               <a:rPr lang="en-US" smtClean="0"/>
-              <a:t>36</a:t>
+              <a:t>37</a:t>
             </a:fld>
             <a:endParaRPr lang="en-US"/>
           </a:p>
@@ -31626,7 +31855,7 @@
 </p:sld>
 </file>
 
-<file path=ppt/slides/slide37.xml><?xml version="1.0" encoding="utf-8"?>
+<file path=ppt/slides/slide38.xml><?xml version="1.0" encoding="utf-8"?>
 <p:sld xmlns:a="http://schemas.openxmlformats.org/drawingml/2006/main" xmlns:r="http://schemas.openxmlformats.org/officeDocument/2006/relationships" xmlns:p="http://schemas.openxmlformats.org/presentationml/2006/main">
   <p:cSld>
     <p:spTree>
@@ -31868,7 +32097,7 @@
           <a:p>
             <a:fld id="{548469FB-C78A-B94B-B04A-B5BC8C934F85}" type="slidenum">
               <a:rPr lang="en-US" smtClean="0"/>
-              <a:t>37</a:t>
+              <a:t>38</a:t>
             </a:fld>
             <a:endParaRPr lang="en-US"/>
           </a:p>
@@ -31887,7 +32116,7 @@
 </p:sld>
 </file>
 
-<file path=ppt/slides/slide38.xml><?xml version="1.0" encoding="utf-8"?>
+<file path=ppt/slides/slide39.xml><?xml version="1.0" encoding="utf-8"?>
 <p:sld xmlns:a="http://schemas.openxmlformats.org/drawingml/2006/main" xmlns:r="http://schemas.openxmlformats.org/officeDocument/2006/relationships" xmlns:p="http://schemas.openxmlformats.org/presentationml/2006/main">
   <p:cSld>
     <p:spTree>
@@ -32129,7 +32358,7 @@
           <a:p>
             <a:fld id="{548469FB-C78A-B94B-B04A-B5BC8C934F85}" type="slidenum">
               <a:rPr lang="en-US" smtClean="0"/>
-              <a:t>38</a:t>
+              <a:t>39</a:t>
             </a:fld>
             <a:endParaRPr lang="en-US"/>
           </a:p>
@@ -32148,7 +32377,215 @@
 </p:sld>
 </file>
 
-<file path=ppt/slides/slide39.xml><?xml version="1.0" encoding="utf-8"?>
+<file path=ppt/slides/slide4.xml><?xml version="1.0" encoding="utf-8"?>
+<p:sld xmlns:a="http://schemas.openxmlformats.org/drawingml/2006/main" xmlns:r="http://schemas.openxmlformats.org/officeDocument/2006/relationships" xmlns:p="http://schemas.openxmlformats.org/presentationml/2006/main">
+  <p:cSld>
+    <p:spTree>
+      <p:nvGrpSpPr>
+        <p:cNvPr id="1" name="">
+          <a:extLst>
+            <a:ext uri="{FF2B5EF4-FFF2-40B4-BE49-F238E27FC236}">
+              <a16:creationId xmlns:a16="http://schemas.microsoft.com/office/drawing/2014/main" id="{138904E8-FE71-7102-7561-05F046E7A718}"/>
+            </a:ext>
+          </a:extLst>
+        </p:cNvPr>
+        <p:cNvGrpSpPr/>
+        <p:nvPr/>
+      </p:nvGrpSpPr>
+      <p:grpSpPr>
+        <a:xfrm>
+          <a:off x="0" y="0"/>
+          <a:ext cx="0" cy="0"/>
+          <a:chOff x="0" y="0"/>
+          <a:chExt cx="0" cy="0"/>
+        </a:xfrm>
+      </p:grpSpPr>
+      <p:sp>
+        <p:nvSpPr>
+          <p:cNvPr id="2" name="Picture Placeholder 1">
+            <a:extLst>
+              <a:ext uri="{FF2B5EF4-FFF2-40B4-BE49-F238E27FC236}">
+                <a16:creationId xmlns:a16="http://schemas.microsoft.com/office/drawing/2014/main" id="{4FB4190B-27CA-E911-E62B-858FB9E062DC}"/>
+              </a:ext>
+            </a:extLst>
+          </p:cNvPr>
+          <p:cNvSpPr>
+            <a:spLocks noGrp="1"/>
+          </p:cNvSpPr>
+          <p:nvPr>
+            <p:ph type="pic" sz="quarter" idx="12"/>
+          </p:nvPr>
+        </p:nvSpPr>
+        <p:spPr>
+          <a:xfrm>
+            <a:off x="5181600" y="1422651"/>
+            <a:ext cx="6628457" cy="5435349"/>
+          </a:xfrm>
+        </p:spPr>
+        <p:txBody>
+          <a:bodyPr>
+            <a:normAutofit/>
+          </a:bodyPr>
+          <a:lstStyle/>
+          <a:p>
+            <a:r>
+              <a:rPr lang="en-US" sz="2000" dirty="0">
+                <a:latin typeface="Avenir Book" panose="02000503020000020003" pitchFamily="2" charset="0"/>
+              </a:rPr>
+              <a:t>Learning objectives</a:t>
+            </a:r>
+          </a:p>
+          <a:p>
+            <a:endParaRPr lang="en-US" sz="2000" dirty="0">
+              <a:latin typeface="Avenir Book" panose="02000503020000020003" pitchFamily="2" charset="0"/>
+            </a:endParaRPr>
+          </a:p>
+          <a:p>
+            <a:r>
+              <a:rPr lang="en-US" sz="2000" dirty="0">
+                <a:latin typeface="Avenir Book" panose="02000503020000020003" pitchFamily="2" charset="0"/>
+              </a:rPr>
+              <a:t>About All of US</a:t>
+            </a:r>
+          </a:p>
+          <a:p>
+            <a:endParaRPr lang="en-US" sz="2000" dirty="0">
+              <a:latin typeface="Avenir Book" panose="02000503020000020003" pitchFamily="2" charset="0"/>
+            </a:endParaRPr>
+          </a:p>
+          <a:p>
+            <a:r>
+              <a:rPr lang="en-US" sz="2000" dirty="0">
+                <a:latin typeface="Avenir Book" panose="02000503020000020003" pitchFamily="2" charset="0"/>
+              </a:rPr>
+              <a:t>Data sources</a:t>
+            </a:r>
+          </a:p>
+          <a:p>
+            <a:endParaRPr lang="en-US" sz="2000" dirty="0">
+              <a:latin typeface="Avenir Book" panose="02000503020000020003" pitchFamily="2" charset="0"/>
+            </a:endParaRPr>
+          </a:p>
+          <a:p>
+            <a:r>
+              <a:rPr lang="en-US" sz="2000" dirty="0">
+                <a:latin typeface="Avenir Book" panose="02000503020000020003" pitchFamily="2" charset="0"/>
+              </a:rPr>
+              <a:t>Accessing data</a:t>
+            </a:r>
+          </a:p>
+          <a:p>
+            <a:endParaRPr lang="en-US" sz="2000" dirty="0">
+              <a:latin typeface="Avenir Book" panose="02000503020000020003" pitchFamily="2" charset="0"/>
+            </a:endParaRPr>
+          </a:p>
+          <a:p>
+            <a:r>
+              <a:rPr lang="en-US" sz="2000" dirty="0">
+                <a:latin typeface="Avenir Book" panose="02000503020000020003" pitchFamily="2" charset="0"/>
+              </a:rPr>
+              <a:t>Analyzing data</a:t>
+            </a:r>
+          </a:p>
+          <a:p>
+            <a:endParaRPr lang="en-US" sz="2000" dirty="0">
+              <a:latin typeface="Avenir Book" panose="02000503020000020003" pitchFamily="2" charset="0"/>
+            </a:endParaRPr>
+          </a:p>
+          <a:p>
+            <a:r>
+              <a:rPr lang="en-US" sz="2000" dirty="0">
+                <a:latin typeface="Avenir Book" panose="02000503020000020003" pitchFamily="2" charset="0"/>
+              </a:rPr>
+              <a:t>Create an All of Us account and Workspace </a:t>
+            </a:r>
+          </a:p>
+          <a:p>
+            <a:endParaRPr lang="en-US" sz="1400" dirty="0">
+              <a:latin typeface="Avenir Book" panose="02000503020000020003" pitchFamily="2" charset="0"/>
+            </a:endParaRPr>
+          </a:p>
+        </p:txBody>
+      </p:sp>
+      <p:sp>
+        <p:nvSpPr>
+          <p:cNvPr id="3" name="Text Placeholder 2">
+            <a:extLst>
+              <a:ext uri="{FF2B5EF4-FFF2-40B4-BE49-F238E27FC236}">
+                <a16:creationId xmlns:a16="http://schemas.microsoft.com/office/drawing/2014/main" id="{1857C7A0-5DE4-540F-C3DA-F3A1D0A8FDF2}"/>
+              </a:ext>
+            </a:extLst>
+          </p:cNvPr>
+          <p:cNvSpPr>
+            <a:spLocks noGrp="1"/>
+          </p:cNvSpPr>
+          <p:nvPr>
+            <p:ph type="body" sz="quarter" idx="11"/>
+          </p:nvPr>
+        </p:nvSpPr>
+        <p:spPr>
+          <a:xfrm>
+            <a:off x="458143" y="3143633"/>
+            <a:ext cx="3034570" cy="722197"/>
+          </a:xfrm>
+        </p:spPr>
+        <p:txBody>
+          <a:bodyPr/>
+          <a:lstStyle/>
+          <a:p>
+            <a:pPr algn="ctr"/>
+            <a:r>
+              <a:rPr lang="en-US" dirty="0">
+                <a:latin typeface="YaleNew" panose="02000602050000020003" pitchFamily="2" charset="77"/>
+              </a:rPr>
+              <a:t>Agenda</a:t>
+            </a:r>
+          </a:p>
+        </p:txBody>
+      </p:sp>
+      <p:sp>
+        <p:nvSpPr>
+          <p:cNvPr id="6" name="Slide Number Placeholder 5">
+            <a:extLst>
+              <a:ext uri="{FF2B5EF4-FFF2-40B4-BE49-F238E27FC236}">
+                <a16:creationId xmlns:a16="http://schemas.microsoft.com/office/drawing/2014/main" id="{ED04705E-0536-8195-659A-45C71DEAB971}"/>
+              </a:ext>
+            </a:extLst>
+          </p:cNvPr>
+          <p:cNvSpPr>
+            <a:spLocks noGrp="1"/>
+          </p:cNvSpPr>
+          <p:nvPr>
+            <p:ph type="sldNum" sz="quarter" idx="18"/>
+          </p:nvPr>
+        </p:nvSpPr>
+        <p:spPr/>
+        <p:txBody>
+          <a:bodyPr/>
+          <a:lstStyle/>
+          <a:p>
+            <a:fld id="{548469FB-C78A-B94B-B04A-B5BC8C934F85}" type="slidenum">
+              <a:rPr lang="en-US" smtClean="0"/>
+              <a:t>4</a:t>
+            </a:fld>
+            <a:endParaRPr lang="en-US"/>
+          </a:p>
+        </p:txBody>
+      </p:sp>
+    </p:spTree>
+    <p:extLst>
+      <p:ext uri="{BB962C8B-B14F-4D97-AF65-F5344CB8AC3E}">
+        <p14:creationId xmlns:p14="http://schemas.microsoft.com/office/powerpoint/2010/main" val="2450962014"/>
+      </p:ext>
+    </p:extLst>
+  </p:cSld>
+  <p:clrMapOvr>
+    <a:masterClrMapping/>
+  </p:clrMapOvr>
+</p:sld>
+</file>
+
+<file path=ppt/slides/slide40.xml><?xml version="1.0" encoding="utf-8"?>
 <p:sld xmlns:a="http://schemas.openxmlformats.org/drawingml/2006/main" xmlns:r="http://schemas.openxmlformats.org/officeDocument/2006/relationships" xmlns:p="http://schemas.openxmlformats.org/presentationml/2006/main">
   <p:cSld>
     <p:spTree>
@@ -32229,7 +32666,7 @@
           <a:p>
             <a:fld id="{548469FB-C78A-B94B-B04A-B5BC8C934F85}" type="slidenum">
               <a:rPr lang="en-US" smtClean="0"/>
-              <a:t>39</a:t>
+              <a:t>40</a:t>
             </a:fld>
             <a:endParaRPr lang="en-US"/>
           </a:p>
@@ -32284,215 +32721,7 @@
 </p:sld>
 </file>
 
-<file path=ppt/slides/slide4.xml><?xml version="1.0" encoding="utf-8"?>
-<p:sld xmlns:a="http://schemas.openxmlformats.org/drawingml/2006/main" xmlns:r="http://schemas.openxmlformats.org/officeDocument/2006/relationships" xmlns:p="http://schemas.openxmlformats.org/presentationml/2006/main">
-  <p:cSld>
-    <p:spTree>
-      <p:nvGrpSpPr>
-        <p:cNvPr id="1" name="">
-          <a:extLst>
-            <a:ext uri="{FF2B5EF4-FFF2-40B4-BE49-F238E27FC236}">
-              <a16:creationId xmlns:a16="http://schemas.microsoft.com/office/drawing/2014/main" id="{138904E8-FE71-7102-7561-05F046E7A718}"/>
-            </a:ext>
-          </a:extLst>
-        </p:cNvPr>
-        <p:cNvGrpSpPr/>
-        <p:nvPr/>
-      </p:nvGrpSpPr>
-      <p:grpSpPr>
-        <a:xfrm>
-          <a:off x="0" y="0"/>
-          <a:ext cx="0" cy="0"/>
-          <a:chOff x="0" y="0"/>
-          <a:chExt cx="0" cy="0"/>
-        </a:xfrm>
-      </p:grpSpPr>
-      <p:sp>
-        <p:nvSpPr>
-          <p:cNvPr id="2" name="Picture Placeholder 1">
-            <a:extLst>
-              <a:ext uri="{FF2B5EF4-FFF2-40B4-BE49-F238E27FC236}">
-                <a16:creationId xmlns:a16="http://schemas.microsoft.com/office/drawing/2014/main" id="{4FB4190B-27CA-E911-E62B-858FB9E062DC}"/>
-              </a:ext>
-            </a:extLst>
-          </p:cNvPr>
-          <p:cNvSpPr>
-            <a:spLocks noGrp="1"/>
-          </p:cNvSpPr>
-          <p:nvPr>
-            <p:ph type="pic" sz="quarter" idx="12"/>
-          </p:nvPr>
-        </p:nvSpPr>
-        <p:spPr>
-          <a:xfrm>
-            <a:off x="5181600" y="1422651"/>
-            <a:ext cx="6628457" cy="5435349"/>
-          </a:xfrm>
-        </p:spPr>
-        <p:txBody>
-          <a:bodyPr>
-            <a:normAutofit/>
-          </a:bodyPr>
-          <a:lstStyle/>
-          <a:p>
-            <a:r>
-              <a:rPr lang="en-US" sz="2000" dirty="0">
-                <a:latin typeface="Avenir Book" panose="02000503020000020003" pitchFamily="2" charset="0"/>
-              </a:rPr>
-              <a:t>Learning objectives</a:t>
-            </a:r>
-          </a:p>
-          <a:p>
-            <a:endParaRPr lang="en-US" sz="2000" dirty="0">
-              <a:latin typeface="Avenir Book" panose="02000503020000020003" pitchFamily="2" charset="0"/>
-            </a:endParaRPr>
-          </a:p>
-          <a:p>
-            <a:r>
-              <a:rPr lang="en-US" sz="2000" dirty="0">
-                <a:latin typeface="Avenir Book" panose="02000503020000020003" pitchFamily="2" charset="0"/>
-              </a:rPr>
-              <a:t>About All of US</a:t>
-            </a:r>
-          </a:p>
-          <a:p>
-            <a:endParaRPr lang="en-US" sz="2000" dirty="0">
-              <a:latin typeface="Avenir Book" panose="02000503020000020003" pitchFamily="2" charset="0"/>
-            </a:endParaRPr>
-          </a:p>
-          <a:p>
-            <a:r>
-              <a:rPr lang="en-US" sz="2000" dirty="0">
-                <a:latin typeface="Avenir Book" panose="02000503020000020003" pitchFamily="2" charset="0"/>
-              </a:rPr>
-              <a:t>Data sources</a:t>
-            </a:r>
-          </a:p>
-          <a:p>
-            <a:endParaRPr lang="en-US" sz="2000" dirty="0">
-              <a:latin typeface="Avenir Book" panose="02000503020000020003" pitchFamily="2" charset="0"/>
-            </a:endParaRPr>
-          </a:p>
-          <a:p>
-            <a:r>
-              <a:rPr lang="en-US" sz="2000" dirty="0">
-                <a:latin typeface="Avenir Book" panose="02000503020000020003" pitchFamily="2" charset="0"/>
-              </a:rPr>
-              <a:t>Accessing data</a:t>
-            </a:r>
-          </a:p>
-          <a:p>
-            <a:endParaRPr lang="en-US" sz="2000" dirty="0">
-              <a:latin typeface="Avenir Book" panose="02000503020000020003" pitchFamily="2" charset="0"/>
-            </a:endParaRPr>
-          </a:p>
-          <a:p>
-            <a:r>
-              <a:rPr lang="en-US" sz="2000" dirty="0">
-                <a:latin typeface="Avenir Book" panose="02000503020000020003" pitchFamily="2" charset="0"/>
-              </a:rPr>
-              <a:t>Analyzing data</a:t>
-            </a:r>
-          </a:p>
-          <a:p>
-            <a:endParaRPr lang="en-US" sz="2000" dirty="0">
-              <a:latin typeface="Avenir Book" panose="02000503020000020003" pitchFamily="2" charset="0"/>
-            </a:endParaRPr>
-          </a:p>
-          <a:p>
-            <a:r>
-              <a:rPr lang="en-US" sz="2000" dirty="0">
-                <a:latin typeface="Avenir Book" panose="02000503020000020003" pitchFamily="2" charset="0"/>
-              </a:rPr>
-              <a:t>Create an All of Us account and Workspace </a:t>
-            </a:r>
-          </a:p>
-          <a:p>
-            <a:endParaRPr lang="en-US" sz="1400" dirty="0">
-              <a:latin typeface="Avenir Book" panose="02000503020000020003" pitchFamily="2" charset="0"/>
-            </a:endParaRPr>
-          </a:p>
-        </p:txBody>
-      </p:sp>
-      <p:sp>
-        <p:nvSpPr>
-          <p:cNvPr id="3" name="Text Placeholder 2">
-            <a:extLst>
-              <a:ext uri="{FF2B5EF4-FFF2-40B4-BE49-F238E27FC236}">
-                <a16:creationId xmlns:a16="http://schemas.microsoft.com/office/drawing/2014/main" id="{1857C7A0-5DE4-540F-C3DA-F3A1D0A8FDF2}"/>
-              </a:ext>
-            </a:extLst>
-          </p:cNvPr>
-          <p:cNvSpPr>
-            <a:spLocks noGrp="1"/>
-          </p:cNvSpPr>
-          <p:nvPr>
-            <p:ph type="body" sz="quarter" idx="11"/>
-          </p:nvPr>
-        </p:nvSpPr>
-        <p:spPr>
-          <a:xfrm>
-            <a:off x="458143" y="3143633"/>
-            <a:ext cx="3034570" cy="722197"/>
-          </a:xfrm>
-        </p:spPr>
-        <p:txBody>
-          <a:bodyPr/>
-          <a:lstStyle/>
-          <a:p>
-            <a:pPr algn="ctr"/>
-            <a:r>
-              <a:rPr lang="en-US" dirty="0">
-                <a:latin typeface="YaleNew" panose="02000602050000020003" pitchFamily="2" charset="77"/>
-              </a:rPr>
-              <a:t>Agenda</a:t>
-            </a:r>
-          </a:p>
-        </p:txBody>
-      </p:sp>
-      <p:sp>
-        <p:nvSpPr>
-          <p:cNvPr id="6" name="Slide Number Placeholder 5">
-            <a:extLst>
-              <a:ext uri="{FF2B5EF4-FFF2-40B4-BE49-F238E27FC236}">
-                <a16:creationId xmlns:a16="http://schemas.microsoft.com/office/drawing/2014/main" id="{ED04705E-0536-8195-659A-45C71DEAB971}"/>
-              </a:ext>
-            </a:extLst>
-          </p:cNvPr>
-          <p:cNvSpPr>
-            <a:spLocks noGrp="1"/>
-          </p:cNvSpPr>
-          <p:nvPr>
-            <p:ph type="sldNum" sz="quarter" idx="18"/>
-          </p:nvPr>
-        </p:nvSpPr>
-        <p:spPr/>
-        <p:txBody>
-          <a:bodyPr/>
-          <a:lstStyle/>
-          <a:p>
-            <a:fld id="{548469FB-C78A-B94B-B04A-B5BC8C934F85}" type="slidenum">
-              <a:rPr lang="en-US" smtClean="0"/>
-              <a:t>4</a:t>
-            </a:fld>
-            <a:endParaRPr lang="en-US"/>
-          </a:p>
-        </p:txBody>
-      </p:sp>
-    </p:spTree>
-    <p:extLst>
-      <p:ext uri="{BB962C8B-B14F-4D97-AF65-F5344CB8AC3E}">
-        <p14:creationId xmlns:p14="http://schemas.microsoft.com/office/powerpoint/2010/main" val="2450962014"/>
-      </p:ext>
-    </p:extLst>
-  </p:cSld>
-  <p:clrMapOvr>
-    <a:masterClrMapping/>
-  </p:clrMapOvr>
-</p:sld>
-</file>
-
-<file path=ppt/slides/slide40.xml><?xml version="1.0" encoding="utf-8"?>
+<file path=ppt/slides/slide41.xml><?xml version="1.0" encoding="utf-8"?>
 <p:sld xmlns:a="http://schemas.openxmlformats.org/drawingml/2006/main" xmlns:r="http://schemas.openxmlformats.org/officeDocument/2006/relationships" xmlns:p="http://schemas.openxmlformats.org/presentationml/2006/main">
   <p:cSld>
     <p:spTree>
@@ -32606,7 +32835,7 @@
           <a:p>
             <a:fld id="{548469FB-C78A-B94B-B04A-B5BC8C934F85}" type="slidenum">
               <a:rPr lang="en-US" smtClean="0"/>
-              <a:t>40</a:t>
+              <a:t>41</a:t>
             </a:fld>
             <a:endParaRPr lang="en-US"/>
           </a:p>

</xml_diff>